<commit_message>
Rework flow slide layout: fix wrapping, denser cards
Overlay chevron labels in separate textboxes to avoid broken line
breaks inside the arrow shape, widen columns, and fill each body card
with 一言 / description / headline figure / representative players so
the slide no longer reads sparse.

Co-Authored-By: Claude Sonnet 5 <noreply@anthropic.com>
Claude-Session: https://claude.ai/code/session_017hVm54qQ8iaGNRYcCDuKBy
</commit_message>
<xml_diff>
--- a/output/andpad_ai_opportunity_deck.pptx
+++ b/output/andpad_ai_opportunity_deck.pptx
@@ -14689,12 +14689,12 @@
         </p:nvSpPr>
         <p:spPr>
           <a:xfrm>
-            <a:off x="777240" y="1600200"/>
-            <a:ext cx="1051560" cy="960120"/>
+            <a:off x="777240" y="1371600"/>
+            <a:ext cx="932688" cy="896112"/>
           </a:xfrm>
           <a:prstGeom prst="roundRect">
             <a:avLst>
-              <a:gd name="adj" fmla="val 8000"/>
+              <a:gd name="adj" fmla="val 9000"/>
             </a:avLst>
           </a:prstGeom>
           <a:solidFill>
@@ -14735,8 +14735,8 @@
         </p:nvSpPr>
         <p:spPr>
           <a:xfrm>
-            <a:off x="777240" y="1600200"/>
-            <a:ext cx="1051560" cy="960120"/>
+            <a:off x="777240" y="1371600"/>
+            <a:ext cx="932688" cy="896112"/>
           </a:xfrm>
           <a:prstGeom prst="rect">
             <a:avLst/>
@@ -14751,17 +14751,17 @@
           <a:p>
             <a:pPr algn="ctr">
               <a:lnSpc>
-                <a:spcPct val="102000"/>
-              </a:lnSpc>
-              <a:spcBef>
-                <a:spcPts val="0"/>
-              </a:spcBef>
-              <a:spcAft>
-                <a:spcPts val="100"/>
-              </a:spcAft>
-            </a:pPr>
-            <a:r>
-              <a:rPr sz="900" b="1">
+                <a:spcPct val="100000"/>
+              </a:lnSpc>
+              <a:spcBef>
+                <a:spcPts val="0"/>
+              </a:spcBef>
+              <a:spcAft>
+                <a:spcPts val="0"/>
+              </a:spcAft>
+            </a:pPr>
+            <a:r>
+              <a:rPr sz="800" b="1" spc="100">
                 <a:solidFill>
                   <a:srgbClr val="D7DBE0"/>
                 </a:solidFill>
@@ -14774,17 +14774,17 @@
           <a:p>
             <a:pPr algn="ctr">
               <a:lnSpc>
-                <a:spcPct val="102000"/>
-              </a:lnSpc>
-              <a:spcBef>
-                <a:spcPts val="0"/>
-              </a:spcBef>
-              <a:spcAft>
-                <a:spcPts val="100"/>
-              </a:spcAft>
-            </a:pPr>
-            <a:r>
-              <a:rPr sz="1250" b="1">
+                <a:spcPct val="100000"/>
+              </a:lnSpc>
+              <a:spcBef>
+                <a:spcPts val="0"/>
+              </a:spcBef>
+              <a:spcAft>
+                <a:spcPts val="0"/>
+              </a:spcAft>
+            </a:pPr>
+            <a:r>
+              <a:rPr sz="1200" b="1">
                 <a:solidFill>
                   <a:srgbClr val="FFFFFF"/>
                 </a:solidFill>
@@ -14797,17 +14797,17 @@
           <a:p>
             <a:pPr algn="ctr">
               <a:lnSpc>
-                <a:spcPct val="102000"/>
-              </a:lnSpc>
-              <a:spcBef>
-                <a:spcPts val="0"/>
-              </a:spcBef>
-              <a:spcAft>
-                <a:spcPts val="100"/>
-              </a:spcAft>
-            </a:pPr>
-            <a:r>
-              <a:rPr sz="1000" b="1">
+                <a:spcPct val="100000"/>
+              </a:lnSpc>
+              <a:spcBef>
+                <a:spcPts val="0"/>
+              </a:spcBef>
+              <a:spcAft>
+                <a:spcPts val="0"/>
+              </a:spcAft>
+            </a:pPr>
+            <a:r>
+              <a:rPr sz="950" b="1">
                 <a:solidFill>
                   <a:srgbClr val="FFFFFF"/>
                 </a:solidFill>
@@ -14827,8 +14827,8 @@
         </p:nvSpPr>
         <p:spPr>
           <a:xfrm>
-            <a:off x="9646920" y="1600200"/>
-            <a:ext cx="1764792" cy="960120"/>
+            <a:off x="9747504" y="1371600"/>
+            <a:ext cx="1664208" cy="896112"/>
           </a:xfrm>
           <a:prstGeom prst="roundRect">
             <a:avLst>
@@ -14873,8 +14873,8 @@
         </p:nvSpPr>
         <p:spPr>
           <a:xfrm>
-            <a:off x="9646920" y="1600200"/>
-            <a:ext cx="1764792" cy="960120"/>
+            <a:off x="9747504" y="1371600"/>
+            <a:ext cx="1664208" cy="896112"/>
           </a:xfrm>
           <a:prstGeom prst="rect">
             <a:avLst/>
@@ -14889,17 +14889,17 @@
           <a:p>
             <a:pPr algn="ctr">
               <a:lnSpc>
-                <a:spcPct val="105000"/>
-              </a:lnSpc>
-              <a:spcBef>
-                <a:spcPts val="0"/>
-              </a:spcBef>
-              <a:spcAft>
-                <a:spcPts val="100"/>
-              </a:spcAft>
-            </a:pPr>
-            <a:r>
-              <a:rPr sz="900" b="1">
+                <a:spcPct val="100000"/>
+              </a:lnSpc>
+              <a:spcBef>
+                <a:spcPts val="0"/>
+              </a:spcBef>
+              <a:spcAft>
+                <a:spcPts val="0"/>
+              </a:spcAft>
+            </a:pPr>
+            <a:r>
+              <a:rPr sz="800" b="1" spc="100">
                 <a:solidFill>
                   <a:srgbClr val="C7CFDB"/>
                 </a:solidFill>
@@ -14912,24 +14912,47 @@
           <a:p>
             <a:pPr algn="ctr">
               <a:lnSpc>
-                <a:spcPct val="105000"/>
-              </a:lnSpc>
-              <a:spcBef>
-                <a:spcPts val="0"/>
-              </a:spcBef>
-              <a:spcAft>
-                <a:spcPts val="100"/>
-              </a:spcAft>
-            </a:pPr>
-            <a:r>
-              <a:rPr sz="1200" b="1">
+                <a:spcPct val="100000"/>
+              </a:lnSpc>
+              <a:spcBef>
+                <a:spcPts val="0"/>
+              </a:spcBef>
+              <a:spcAft>
+                <a:spcPts val="0"/>
+              </a:spcAft>
+            </a:pPr>
+            <a:r>
+              <a:rPr sz="1250" b="1">
                 <a:solidFill>
                   <a:srgbClr val="FFFFFF"/>
                 </a:solidFill>
                 <a:latin typeface="Noto Sans JP"/>
                 <a:ea typeface="Noto Sans JP"/>
               </a:rPr>
-              <a:t>AIサービス稼働</a:t>
+              <a:t>AIサービス</a:t>
+            </a:r>
+          </a:p>
+          <a:p>
+            <a:pPr algn="ctr">
+              <a:lnSpc>
+                <a:spcPct val="100000"/>
+              </a:lnSpc>
+              <a:spcBef>
+                <a:spcPts val="0"/>
+              </a:spcBef>
+              <a:spcAft>
+                <a:spcPts val="0"/>
+              </a:spcAft>
+            </a:pPr>
+            <a:r>
+              <a:rPr sz="1000" b="1">
+                <a:solidFill>
+                  <a:srgbClr val="FFFFFF"/>
+                </a:solidFill>
+                <a:latin typeface="Noto Sans JP"/>
+                <a:ea typeface="Noto Sans JP"/>
+              </a:rPr>
+              <a:t>稼働</a:t>
             </a:r>
           </a:p>
         </p:txBody>
@@ -14942,8 +14965,8 @@
         </p:nvSpPr>
         <p:spPr>
           <a:xfrm>
-            <a:off x="1828800" y="1600200"/>
-            <a:ext cx="1682495" cy="960120"/>
+            <a:off x="1828800" y="1371600"/>
+            <a:ext cx="1719072" cy="896112"/>
           </a:xfrm>
           <a:prstGeom prst="chevron">
             <a:avLst/>
@@ -14971,65 +14994,94 @@
           </a:fontRef>
         </p:style>
         <p:txBody>
-          <a:bodyPr rtlCol="0" anchor="ctr" wrap="square" lIns="109728" rIns="164592" tIns="0" bIns="0"/>
+          <a:bodyPr rtlCol="0" anchor="ctr"/>
+          <a:lstStyle/>
+          <a:p/>
+        </p:txBody>
+      </p:sp>
+      <p:sp>
+        <p:nvSpPr>
+          <p:cNvPr id="13" name="TextBox 12"/>
+          <p:cNvSpPr txBox="1"/>
+          <p:nvPr/>
+        </p:nvSpPr>
+        <p:spPr>
+          <a:xfrm>
+            <a:off x="1792224" y="1371600"/>
+            <a:ext cx="1664208" cy="896112"/>
+          </a:xfrm>
+          <a:prstGeom prst="rect">
+            <a:avLst/>
+          </a:prstGeom>
+          <a:noFill/>
+        </p:spPr>
+        <p:txBody>
+          <a:bodyPr wrap="square" anchor="ctr" lIns="0" rIns="0" tIns="0" bIns="0">
+            <a:spAutoFit/>
+          </a:bodyPr>
           <a:lstStyle/>
           <a:p>
             <a:pPr algn="ctr">
               <a:lnSpc>
                 <a:spcPct val="100000"/>
               </a:lnSpc>
-            </a:pPr>
-            <a:r>
-              <a:rPr sz="900" b="1">
+              <a:spcBef>
+                <a:spcPts val="0"/>
+              </a:spcBef>
+              <a:spcAft>
+                <a:spcPts val="0"/>
+              </a:spcAft>
+            </a:pPr>
+            <a:r>
+              <a:rPr sz="800" b="1" spc="100">
                 <a:solidFill>
                   <a:srgbClr val="FFC9CE"/>
                 </a:solidFill>
                 <a:latin typeface="Consolas"/>
-              </a:rPr>
-              <a:t>01  </a:t>
-            </a:r>
-            <a:r>
-              <a:rPr sz="1150" b="1">
+                <a:ea typeface="Consolas"/>
+              </a:rPr>
+              <a:t>01</a:t>
+            </a:r>
+          </a:p>
+          <a:p>
+            <a:pPr algn="ctr">
+              <a:lnSpc>
+                <a:spcPct val="100000"/>
+              </a:lnSpc>
+              <a:spcBef>
+                <a:spcPts val="0"/>
+              </a:spcBef>
+              <a:spcAft>
+                <a:spcPts val="0"/>
+              </a:spcAft>
+            </a:pPr>
+            <a:r>
+              <a:rPr sz="1100" b="1">
                 <a:solidFill>
                   <a:srgbClr val="FFFFFF"/>
                 </a:solidFill>
                 <a:latin typeface="Noto Sans JP"/>
+                <a:ea typeface="Noto Sans JP"/>
               </a:rPr>
               <a:t>発電・電源</a:t>
             </a:r>
           </a:p>
-          <a:p>
-            <a:pPr algn="ctr">
-              <a:spcBef>
-                <a:spcPts val="100"/>
-              </a:spcBef>
-            </a:pPr>
-            <a:r>
-              <a:rPr sz="850">
-                <a:solidFill>
-                  <a:srgbClr val="FFE2E5"/>
-                </a:solidFill>
-                <a:latin typeface="Noto Sans JP"/>
-              </a:rPr>
-              <a:t>電気をつくる</a:t>
-            </a:r>
-          </a:p>
-        </p:txBody>
-      </p:sp>
-      <p:sp>
-        <p:nvSpPr>
-          <p:cNvPr id="13" name="Rounded Rectangle 12"/>
+        </p:txBody>
+      </p:sp>
+      <p:sp>
+        <p:nvSpPr>
+          <p:cNvPr id="14" name="Rounded Rectangle 13"/>
           <p:cNvSpPr/>
           <p:nvPr/>
         </p:nvSpPr>
         <p:spPr>
           <a:xfrm>
-            <a:off x="1938528" y="2788920"/>
-            <a:ext cx="1389888" cy="2971800"/>
+            <a:off x="1892807" y="2432304"/>
+            <a:ext cx="1481328" cy="3511296"/>
           </a:xfrm>
           <a:prstGeom prst="roundRect">
             <a:avLst>
-              <a:gd name="adj" fmla="val 5000"/>
+              <a:gd name="adj" fmla="val 4500"/>
             </a:avLst>
           </a:prstGeom>
           <a:solidFill>
@@ -15066,14 +15118,14 @@
       </p:sp>
       <p:sp>
         <p:nvSpPr>
-          <p:cNvPr id="14" name="TextBox 13"/>
-          <p:cNvSpPr txBox="1"/>
-          <p:nvPr/>
-        </p:nvSpPr>
-        <p:spPr>
-          <a:xfrm>
-            <a:off x="2048256" y="2898648"/>
-            <a:ext cx="1170432" cy="274320"/>
+          <p:cNvPr id="15" name="TextBox 14"/>
+          <p:cNvSpPr txBox="1"/>
+          <p:nvPr/>
+        </p:nvSpPr>
+        <p:spPr>
+          <a:xfrm>
+            <a:off x="2020824" y="2560320"/>
+            <a:ext cx="1225295" cy="219456"/>
           </a:xfrm>
           <a:prstGeom prst="rect">
             <a:avLst/>
@@ -15112,14 +15164,14 @@
       </p:sp>
       <p:sp>
         <p:nvSpPr>
-          <p:cNvPr id="15" name="TextBox 14"/>
-          <p:cNvSpPr txBox="1"/>
-          <p:nvPr/>
-        </p:nvSpPr>
-        <p:spPr>
-          <a:xfrm>
-            <a:off x="2048256" y="3246120"/>
-            <a:ext cx="1170432" cy="640080"/>
+          <p:cNvPr id="16" name="TextBox 15"/>
+          <p:cNvSpPr txBox="1"/>
+          <p:nvPr/>
+        </p:nvSpPr>
+        <p:spPr>
+          <a:xfrm>
+            <a:off x="2020824" y="2816352"/>
+            <a:ext cx="1225295" cy="274320"/>
           </a:xfrm>
           <a:prstGeom prst="rect">
             <a:avLst/>
@@ -15134,67 +15186,90 @@
           <a:p>
             <a:pPr algn="l">
               <a:lnSpc>
-                <a:spcPct val="105000"/>
-              </a:lnSpc>
-              <a:spcBef>
-                <a:spcPts val="0"/>
-              </a:spcBef>
-              <a:spcAft>
-                <a:spcPts val="100"/>
-              </a:spcAft>
-            </a:pPr>
-            <a:r>
-              <a:rPr sz="1100" b="1">
-                <a:solidFill>
-                  <a:srgbClr val="E60012"/>
+                <a:spcPct val="106000"/>
+              </a:lnSpc>
+              <a:spcBef>
+                <a:spcPts val="0"/>
+              </a:spcBef>
+              <a:spcAft>
+                <a:spcPts val="400"/>
+              </a:spcAft>
+            </a:pPr>
+            <a:r>
+              <a:rPr sz="1150" b="1">
+                <a:solidFill>
+                  <a:srgbClr val="1A1D21"/>
                 </a:solidFill>
                 <a:latin typeface="Noto Sans JP"/>
                 <a:ea typeface="Noto Sans JP"/>
               </a:rPr>
-              <a:t>受注残 5兆円超</a:t>
-            </a:r>
-          </a:p>
+              <a:t>電気をつくる</a:t>
+            </a:r>
+          </a:p>
+        </p:txBody>
+      </p:sp>
+      <p:sp>
+        <p:nvSpPr>
+          <p:cNvPr id="17" name="TextBox 16"/>
+          <p:cNvSpPr txBox="1"/>
+          <p:nvPr/>
+        </p:nvSpPr>
+        <p:spPr>
+          <a:xfrm>
+            <a:off x="2020824" y="3182112"/>
+            <a:ext cx="1225295" cy="914400"/>
+          </a:xfrm>
+          <a:prstGeom prst="rect">
+            <a:avLst/>
+          </a:prstGeom>
+          <a:noFill/>
+        </p:spPr>
+        <p:txBody>
+          <a:bodyPr wrap="square" anchor="t" lIns="0" rIns="0" tIns="0" bIns="0">
+            <a:spAutoFit/>
+          </a:bodyPr>
+          <a:lstStyle/>
           <a:p>
             <a:pPr algn="l">
               <a:lnSpc>
-                <a:spcPct val="105000"/>
-              </a:lnSpc>
-              <a:spcBef>
-                <a:spcPts val="0"/>
-              </a:spcBef>
-              <a:spcAft>
-                <a:spcPts val="100"/>
-              </a:spcAft>
-            </a:pPr>
-            <a:r>
-              <a:rPr sz="750" b="0">
-                <a:solidFill>
-                  <a:srgbClr val="8A9098"/>
-                </a:solidFill>
-                <a:latin typeface="Consolas"/>
-                <a:ea typeface="Consolas"/>
-              </a:rPr>
-              <a:t>三菱重工</a:t>
-            </a:r>
-          </a:p>
-        </p:txBody>
-      </p:sp>
-      <p:sp>
-        <p:nvSpPr>
-          <p:cNvPr id="16" name="Rectangle 15"/>
+                <a:spcPct val="116000"/>
+              </a:lnSpc>
+              <a:spcBef>
+                <a:spcPts val="0"/>
+              </a:spcBef>
+              <a:spcAft>
+                <a:spcPts val="400"/>
+              </a:spcAft>
+            </a:pPr>
+            <a:r>
+              <a:rPr sz="880" b="0">
+                <a:solidFill>
+                  <a:srgbClr val="3C4148"/>
+                </a:solidFill>
+                <a:latin typeface="Noto Sans JP"/>
+                <a:ea typeface="Noto Sans JP"/>
+              </a:rPr>
+              <a:t>電力が全ての起点。ガスタービンや非常用発電機の需要が急増。</a:t>
+            </a:r>
+          </a:p>
+        </p:txBody>
+      </p:sp>
+      <p:sp>
+        <p:nvSpPr>
+          <p:cNvPr id="18" name="Rectangle 17"/>
           <p:cNvSpPr/>
           <p:nvPr/>
         </p:nvSpPr>
         <p:spPr>
           <a:xfrm>
-            <a:off x="2048256" y="3959352"/>
-            <a:ext cx="1170432" cy="10972"/>
+            <a:off x="2020824" y="4133088"/>
+            <a:ext cx="1225295" cy="9144"/>
           </a:xfrm>
           <a:prstGeom prst="rect">
             <a:avLst/>
           </a:prstGeom>
           <a:solidFill>
-            <a:srgbClr val="E2E4E9"/>
+            <a:srgbClr val="F3C7CD"/>
           </a:solidFill>
           <a:ln>
             <a:noFill/>
@@ -15225,14 +15300,14 @@
       </p:sp>
       <p:sp>
         <p:nvSpPr>
-          <p:cNvPr id="17" name="TextBox 16"/>
-          <p:cNvSpPr txBox="1"/>
-          <p:nvPr/>
-        </p:nvSpPr>
-        <p:spPr>
-          <a:xfrm>
-            <a:off x="2048256" y="4069079"/>
-            <a:ext cx="1170432" cy="1600200"/>
+          <p:cNvPr id="19" name="TextBox 18"/>
+          <p:cNvSpPr txBox="1"/>
+          <p:nvPr/>
+        </p:nvSpPr>
+        <p:spPr>
+          <a:xfrm>
+            <a:off x="2020824" y="4224528"/>
+            <a:ext cx="1225295" cy="603504"/>
           </a:xfrm>
           <a:prstGeom prst="rect">
             <a:avLst/>
@@ -15247,107 +15322,153 @@
           <a:p>
             <a:pPr algn="l">
               <a:lnSpc>
-                <a:spcPct val="105000"/>
-              </a:lnSpc>
-              <a:spcBef>
-                <a:spcPts val="0"/>
-              </a:spcBef>
-              <a:spcAft>
-                <a:spcPts val="300"/>
-              </a:spcAft>
-            </a:pPr>
-            <a:r>
-              <a:rPr sz="750" b="1">
+                <a:spcPct val="106000"/>
+              </a:lnSpc>
+              <a:spcBef>
+                <a:spcPts val="0"/>
+              </a:spcBef>
+              <a:spcAft>
+                <a:spcPts val="0"/>
+              </a:spcAft>
+            </a:pPr>
+            <a:r>
+              <a:rPr sz="1200" b="1">
+                <a:solidFill>
+                  <a:srgbClr val="E60012"/>
+                </a:solidFill>
+                <a:latin typeface="Noto Sans JP"/>
+                <a:ea typeface="Noto Sans JP"/>
+              </a:rPr>
+              <a:t>受注残 5兆円超</a:t>
+            </a:r>
+          </a:p>
+          <a:p>
+            <a:pPr algn="l">
+              <a:lnSpc>
+                <a:spcPct val="106000"/>
+              </a:lnSpc>
+              <a:spcBef>
+                <a:spcPts val="0"/>
+              </a:spcBef>
+              <a:spcAft>
+                <a:spcPts val="0"/>
+              </a:spcAft>
+            </a:pPr>
+            <a:r>
+              <a:rPr sz="750" b="0">
                 <a:solidFill>
                   <a:srgbClr val="8A9098"/>
                 </a:solidFill>
                 <a:latin typeface="Consolas"/>
                 <a:ea typeface="Consolas"/>
               </a:rPr>
-              <a:t>代表企業</a:t>
-            </a:r>
-          </a:p>
+              <a:t>三菱重工</a:t>
+            </a:r>
+          </a:p>
+        </p:txBody>
+      </p:sp>
+      <p:sp>
+        <p:nvSpPr>
+          <p:cNvPr id="20" name="TextBox 19"/>
+          <p:cNvSpPr txBox="1"/>
+          <p:nvPr/>
+        </p:nvSpPr>
+        <p:spPr>
+          <a:xfrm>
+            <a:off x="2020824" y="4919472"/>
+            <a:ext cx="1225295" cy="201168"/>
+          </a:xfrm>
+          <a:prstGeom prst="rect">
+            <a:avLst/>
+          </a:prstGeom>
+          <a:noFill/>
+        </p:spPr>
+        <p:txBody>
+          <a:bodyPr wrap="square" anchor="t" lIns="0" rIns="0" tIns="0" bIns="0">
+            <a:spAutoFit/>
+          </a:bodyPr>
+          <a:lstStyle/>
           <a:p>
             <a:pPr algn="l">
               <a:lnSpc>
-                <a:spcPct val="105000"/>
-              </a:lnSpc>
-              <a:spcBef>
-                <a:spcPts val="0"/>
-              </a:spcBef>
-              <a:spcAft>
-                <a:spcPts val="300"/>
-              </a:spcAft>
-            </a:pPr>
-            <a:r>
-              <a:rPr sz="950" b="1">
+                <a:spcPct val="106000"/>
+              </a:lnSpc>
+              <a:spcBef>
+                <a:spcPts val="0"/>
+              </a:spcBef>
+              <a:spcAft>
+                <a:spcPts val="400"/>
+              </a:spcAft>
+            </a:pPr>
+            <a:r>
+              <a:rPr sz="750" b="1">
+                <a:solidFill>
+                  <a:srgbClr val="8A9098"/>
+                </a:solidFill>
+                <a:latin typeface="Consolas"/>
+                <a:ea typeface="Consolas"/>
+              </a:rPr>
+              <a:t>代表企業（国内）</a:t>
+            </a:r>
+          </a:p>
+        </p:txBody>
+      </p:sp>
+      <p:sp>
+        <p:nvSpPr>
+          <p:cNvPr id="21" name="TextBox 20"/>
+          <p:cNvSpPr txBox="1"/>
+          <p:nvPr/>
+        </p:nvSpPr>
+        <p:spPr>
+          <a:xfrm>
+            <a:off x="2020824" y="5138928"/>
+            <a:ext cx="1225295" cy="749808"/>
+          </a:xfrm>
+          <a:prstGeom prst="rect">
+            <a:avLst/>
+          </a:prstGeom>
+          <a:noFill/>
+        </p:spPr>
+        <p:txBody>
+          <a:bodyPr wrap="square" anchor="t" lIns="0" rIns="0" tIns="0" bIns="0">
+            <a:spAutoFit/>
+          </a:bodyPr>
+          <a:lstStyle/>
+          <a:p>
+            <a:pPr algn="l">
+              <a:lnSpc>
+                <a:spcPct val="122000"/>
+              </a:lnSpc>
+              <a:spcBef>
+                <a:spcPts val="0"/>
+              </a:spcBef>
+              <a:spcAft>
+                <a:spcPts val="400"/>
+              </a:spcAft>
+            </a:pPr>
+            <a:r>
+              <a:rPr sz="900" b="1">
                 <a:solidFill>
                   <a:srgbClr val="1A1D21"/>
                 </a:solidFill>
                 <a:latin typeface="Noto Sans JP"/>
                 <a:ea typeface="Noto Sans JP"/>
               </a:rPr>
-              <a:t>三菱重工</a:t>
-            </a:r>
-          </a:p>
-          <a:p>
-            <a:pPr algn="l">
-              <a:lnSpc>
-                <a:spcPct val="105000"/>
-              </a:lnSpc>
-              <a:spcBef>
-                <a:spcPts val="0"/>
-              </a:spcBef>
-              <a:spcAft>
-                <a:spcPts val="300"/>
-              </a:spcAft>
-            </a:pPr>
-            <a:r>
-              <a:rPr sz="950" b="1">
-                <a:solidFill>
-                  <a:srgbClr val="1A1D21"/>
-                </a:solidFill>
-                <a:latin typeface="Noto Sans JP"/>
-                <a:ea typeface="Noto Sans JP"/>
-              </a:rPr>
-              <a:t>IHI</a:t>
-            </a:r>
-          </a:p>
-          <a:p>
-            <a:pPr algn="l">
-              <a:lnSpc>
-                <a:spcPct val="105000"/>
-              </a:lnSpc>
-              <a:spcBef>
-                <a:spcPts val="0"/>
-              </a:spcBef>
-              <a:spcAft>
-                <a:spcPts val="300"/>
-              </a:spcAft>
-            </a:pPr>
-            <a:r>
-              <a:rPr sz="950" b="1">
-                <a:solidFill>
-                  <a:srgbClr val="1A1D21"/>
-                </a:solidFill>
-                <a:latin typeface="Noto Sans JP"/>
-                <a:ea typeface="Noto Sans JP"/>
-              </a:rPr>
-              <a:t>ヤンマー</a:t>
-            </a:r>
-          </a:p>
-        </p:txBody>
-      </p:sp>
-      <p:sp>
-        <p:nvSpPr>
-          <p:cNvPr id="18" name="Chevron 17"/>
+              <a:t>三菱重工・IHI・川崎重工・ヤンマー・デンヨー</a:t>
+            </a:r>
+          </a:p>
+        </p:txBody>
+      </p:sp>
+      <p:sp>
+        <p:nvSpPr>
+          <p:cNvPr id="22" name="Chevron 21"/>
           <p:cNvSpPr/>
           <p:nvPr/>
         </p:nvSpPr>
         <p:spPr>
           <a:xfrm>
-            <a:off x="3328416" y="1600200"/>
-            <a:ext cx="1682495" cy="960120"/>
+            <a:off x="3401568" y="1371600"/>
+            <a:ext cx="1719072" cy="896112"/>
           </a:xfrm>
           <a:prstGeom prst="chevron">
             <a:avLst/>
@@ -15375,65 +15496,94 @@
           </a:fontRef>
         </p:style>
         <p:txBody>
-          <a:bodyPr rtlCol="0" anchor="ctr" wrap="square" lIns="109728" rIns="164592" tIns="0" bIns="0"/>
+          <a:bodyPr rtlCol="0" anchor="ctr"/>
+          <a:lstStyle/>
+          <a:p/>
+        </p:txBody>
+      </p:sp>
+      <p:sp>
+        <p:nvSpPr>
+          <p:cNvPr id="23" name="TextBox 22"/>
+          <p:cNvSpPr txBox="1"/>
+          <p:nvPr/>
+        </p:nvSpPr>
+        <p:spPr>
+          <a:xfrm>
+            <a:off x="3364992" y="1371600"/>
+            <a:ext cx="1664208" cy="896112"/>
+          </a:xfrm>
+          <a:prstGeom prst="rect">
+            <a:avLst/>
+          </a:prstGeom>
+          <a:noFill/>
+        </p:spPr>
+        <p:txBody>
+          <a:bodyPr wrap="square" anchor="ctr" lIns="0" rIns="0" tIns="0" bIns="0">
+            <a:spAutoFit/>
+          </a:bodyPr>
           <a:lstStyle/>
           <a:p>
             <a:pPr algn="ctr">
               <a:lnSpc>
                 <a:spcPct val="100000"/>
               </a:lnSpc>
-            </a:pPr>
-            <a:r>
-              <a:rPr sz="900" b="1">
+              <a:spcBef>
+                <a:spcPts val="0"/>
+              </a:spcBef>
+              <a:spcAft>
+                <a:spcPts val="0"/>
+              </a:spcAft>
+            </a:pPr>
+            <a:r>
+              <a:rPr sz="800" b="1" spc="100">
                 <a:solidFill>
                   <a:srgbClr val="FFC9CE"/>
                 </a:solidFill>
                 <a:latin typeface="Consolas"/>
-              </a:rPr>
-              <a:t>02  </a:t>
-            </a:r>
-            <a:r>
-              <a:rPr sz="1150" b="1">
+                <a:ea typeface="Consolas"/>
+              </a:rPr>
+              <a:t>02</a:t>
+            </a:r>
+          </a:p>
+          <a:p>
+            <a:pPr algn="ctr">
+              <a:lnSpc>
+                <a:spcPct val="100000"/>
+              </a:lnSpc>
+              <a:spcBef>
+                <a:spcPts val="0"/>
+              </a:spcBef>
+              <a:spcAft>
+                <a:spcPts val="0"/>
+              </a:spcAft>
+            </a:pPr>
+            <a:r>
+              <a:rPr sz="1100" b="1">
                 <a:solidFill>
                   <a:srgbClr val="FFFFFF"/>
                 </a:solidFill>
                 <a:latin typeface="Noto Sans JP"/>
+                <a:ea typeface="Noto Sans JP"/>
               </a:rPr>
               <a:t>送変電・電線</a:t>
             </a:r>
           </a:p>
-          <a:p>
-            <a:pPr algn="ctr">
-              <a:spcBef>
-                <a:spcPts val="100"/>
-              </a:spcBef>
-            </a:pPr>
-            <a:r>
-              <a:rPr sz="850">
-                <a:solidFill>
-                  <a:srgbClr val="FFE2E5"/>
-                </a:solidFill>
-                <a:latin typeface="Noto Sans JP"/>
-              </a:rPr>
-              <a:t>電気を送る・変える</a:t>
-            </a:r>
-          </a:p>
-        </p:txBody>
-      </p:sp>
-      <p:sp>
-        <p:nvSpPr>
-          <p:cNvPr id="19" name="Rounded Rectangle 18"/>
+        </p:txBody>
+      </p:sp>
+      <p:sp>
+        <p:nvSpPr>
+          <p:cNvPr id="24" name="Rounded Rectangle 23"/>
           <p:cNvSpPr/>
           <p:nvPr/>
         </p:nvSpPr>
         <p:spPr>
           <a:xfrm>
-            <a:off x="3438144" y="2788920"/>
-            <a:ext cx="1389888" cy="2971800"/>
+            <a:off x="3465576" y="2432304"/>
+            <a:ext cx="1481328" cy="3511296"/>
           </a:xfrm>
           <a:prstGeom prst="roundRect">
             <a:avLst>
-              <a:gd name="adj" fmla="val 5000"/>
+              <a:gd name="adj" fmla="val 4500"/>
             </a:avLst>
           </a:prstGeom>
           <a:solidFill>
@@ -15470,14 +15620,14 @@
       </p:sp>
       <p:sp>
         <p:nvSpPr>
-          <p:cNvPr id="20" name="TextBox 19"/>
-          <p:cNvSpPr txBox="1"/>
-          <p:nvPr/>
-        </p:nvSpPr>
-        <p:spPr>
-          <a:xfrm>
-            <a:off x="3547872" y="2898648"/>
-            <a:ext cx="1170432" cy="274320"/>
+          <p:cNvPr id="25" name="TextBox 24"/>
+          <p:cNvSpPr txBox="1"/>
+          <p:nvPr/>
+        </p:nvSpPr>
+        <p:spPr>
+          <a:xfrm>
+            <a:off x="3593592" y="2560320"/>
+            <a:ext cx="1225295" cy="219456"/>
           </a:xfrm>
           <a:prstGeom prst="rect">
             <a:avLst/>
@@ -15509,21 +15659,21 @@
                 <a:latin typeface="Consolas"/>
                 <a:ea typeface="Consolas"/>
               </a:rPr>
-              <a:t>A＋B</a:t>
-            </a:r>
-          </a:p>
-        </p:txBody>
-      </p:sp>
-      <p:sp>
-        <p:nvSpPr>
-          <p:cNvPr id="21" name="TextBox 20"/>
-          <p:cNvSpPr txBox="1"/>
-          <p:nvPr/>
-        </p:nvSpPr>
-        <p:spPr>
-          <a:xfrm>
-            <a:off x="3547872" y="3246120"/>
-            <a:ext cx="1170432" cy="640080"/>
+              <a:t>A＋B 両取り</a:t>
+            </a:r>
+          </a:p>
+        </p:txBody>
+      </p:sp>
+      <p:sp>
+        <p:nvSpPr>
+          <p:cNvPr id="26" name="TextBox 25"/>
+          <p:cNvSpPr txBox="1"/>
+          <p:nvPr/>
+        </p:nvSpPr>
+        <p:spPr>
+          <a:xfrm>
+            <a:off x="3593592" y="2816352"/>
+            <a:ext cx="1225295" cy="274320"/>
           </a:xfrm>
           <a:prstGeom prst="rect">
             <a:avLst/>
@@ -15538,67 +15688,90 @@
           <a:p>
             <a:pPr algn="l">
               <a:lnSpc>
-                <a:spcPct val="105000"/>
-              </a:lnSpc>
-              <a:spcBef>
-                <a:spcPts val="0"/>
-              </a:spcBef>
-              <a:spcAft>
-                <a:spcPts val="100"/>
-              </a:spcAft>
-            </a:pPr>
-            <a:r>
-              <a:rPr sz="1100" b="1">
-                <a:solidFill>
-                  <a:srgbClr val="E60012"/>
+                <a:spcPct val="106000"/>
+              </a:lnSpc>
+              <a:spcBef>
+                <a:spcPts val="0"/>
+              </a:spcBef>
+              <a:spcAft>
+                <a:spcPts val="400"/>
+              </a:spcAft>
+            </a:pPr>
+            <a:r>
+              <a:rPr sz="1150" b="1">
+                <a:solidFill>
+                  <a:srgbClr val="1A1D21"/>
                 </a:solidFill>
                 <a:latin typeface="Noto Sans JP"/>
                 <a:ea typeface="Noto Sans JP"/>
               </a:rPr>
-              <a:t>変圧器 生産能力2倍</a:t>
-            </a:r>
-          </a:p>
+              <a:t>電気を送る・変える</a:t>
+            </a:r>
+          </a:p>
+        </p:txBody>
+      </p:sp>
+      <p:sp>
+        <p:nvSpPr>
+          <p:cNvPr id="27" name="TextBox 26"/>
+          <p:cNvSpPr txBox="1"/>
+          <p:nvPr/>
+        </p:nvSpPr>
+        <p:spPr>
+          <a:xfrm>
+            <a:off x="3593592" y="3182112"/>
+            <a:ext cx="1225295" cy="914400"/>
+          </a:xfrm>
+          <a:prstGeom prst="rect">
+            <a:avLst/>
+          </a:prstGeom>
+          <a:noFill/>
+        </p:spPr>
+        <p:txBody>
+          <a:bodyPr wrap="square" anchor="t" lIns="0" rIns="0" tIns="0" bIns="0">
+            <a:spAutoFit/>
+          </a:bodyPr>
+          <a:lstStyle/>
           <a:p>
             <a:pPr algn="l">
               <a:lnSpc>
-                <a:spcPct val="105000"/>
-              </a:lnSpc>
-              <a:spcBef>
-                <a:spcPts val="0"/>
-              </a:spcBef>
-              <a:spcAft>
-                <a:spcPts val="100"/>
-              </a:spcAft>
-            </a:pPr>
-            <a:r>
-              <a:rPr sz="750" b="0">
-                <a:solidFill>
-                  <a:srgbClr val="8A9098"/>
-                </a:solidFill>
-                <a:latin typeface="Consolas"/>
-                <a:ea typeface="Consolas"/>
-              </a:rPr>
-              <a:t>ダイヘン・東芝ES</a:t>
-            </a:r>
-          </a:p>
-        </p:txBody>
-      </p:sp>
-      <p:sp>
-        <p:nvSpPr>
-          <p:cNvPr id="22" name="Rectangle 21"/>
+                <a:spcPct val="116000"/>
+              </a:lnSpc>
+              <a:spcBef>
+                <a:spcPts val="0"/>
+              </a:spcBef>
+              <a:spcAft>
+                <a:spcPts val="400"/>
+              </a:spcAft>
+            </a:pPr>
+            <a:r>
+              <a:rPr sz="880" b="0">
+                <a:solidFill>
+                  <a:srgbClr val="3C4148"/>
+                </a:solidFill>
+                <a:latin typeface="Noto Sans JP"/>
+                <a:ea typeface="Noto Sans JP"/>
+              </a:rPr>
+              <a:t>高電圧で送りDC向けに変換。変圧器は世界的に品薄で受注は数年先まで。</a:t>
+            </a:r>
+          </a:p>
+        </p:txBody>
+      </p:sp>
+      <p:sp>
+        <p:nvSpPr>
+          <p:cNvPr id="28" name="Rectangle 27"/>
           <p:cNvSpPr/>
           <p:nvPr/>
         </p:nvSpPr>
         <p:spPr>
           <a:xfrm>
-            <a:off x="3547872" y="3959352"/>
-            <a:ext cx="1170432" cy="10972"/>
+            <a:off x="3593592" y="4133088"/>
+            <a:ext cx="1225295" cy="9144"/>
           </a:xfrm>
           <a:prstGeom prst="rect">
             <a:avLst/>
           </a:prstGeom>
           <a:solidFill>
-            <a:srgbClr val="E2E4E9"/>
+            <a:srgbClr val="F3C7CD"/>
           </a:solidFill>
           <a:ln>
             <a:noFill/>
@@ -15629,14 +15802,14 @@
       </p:sp>
       <p:sp>
         <p:nvSpPr>
-          <p:cNvPr id="23" name="TextBox 22"/>
-          <p:cNvSpPr txBox="1"/>
-          <p:nvPr/>
-        </p:nvSpPr>
-        <p:spPr>
-          <a:xfrm>
-            <a:off x="3547872" y="4069079"/>
-            <a:ext cx="1170432" cy="1600200"/>
+          <p:cNvPr id="29" name="TextBox 28"/>
+          <p:cNvSpPr txBox="1"/>
+          <p:nvPr/>
+        </p:nvSpPr>
+        <p:spPr>
+          <a:xfrm>
+            <a:off x="3593592" y="4224528"/>
+            <a:ext cx="1225295" cy="603504"/>
           </a:xfrm>
           <a:prstGeom prst="rect">
             <a:avLst/>
@@ -15651,107 +15824,153 @@
           <a:p>
             <a:pPr algn="l">
               <a:lnSpc>
-                <a:spcPct val="105000"/>
-              </a:lnSpc>
-              <a:spcBef>
-                <a:spcPts val="0"/>
-              </a:spcBef>
-              <a:spcAft>
-                <a:spcPts val="300"/>
-              </a:spcAft>
-            </a:pPr>
-            <a:r>
-              <a:rPr sz="750" b="1">
+                <a:spcPct val="106000"/>
+              </a:lnSpc>
+              <a:spcBef>
+                <a:spcPts val="0"/>
+              </a:spcBef>
+              <a:spcAft>
+                <a:spcPts val="0"/>
+              </a:spcAft>
+            </a:pPr>
+            <a:r>
+              <a:rPr sz="1200" b="1">
+                <a:solidFill>
+                  <a:srgbClr val="E60012"/>
+                </a:solidFill>
+                <a:latin typeface="Noto Sans JP"/>
+                <a:ea typeface="Noto Sans JP"/>
+              </a:rPr>
+              <a:t>変圧器 生産能力2倍</a:t>
+            </a:r>
+          </a:p>
+          <a:p>
+            <a:pPr algn="l">
+              <a:lnSpc>
+                <a:spcPct val="106000"/>
+              </a:lnSpc>
+              <a:spcBef>
+                <a:spcPts val="0"/>
+              </a:spcBef>
+              <a:spcAft>
+                <a:spcPts val="0"/>
+              </a:spcAft>
+            </a:pPr>
+            <a:r>
+              <a:rPr sz="750" b="0">
                 <a:solidFill>
                   <a:srgbClr val="8A9098"/>
                 </a:solidFill>
                 <a:latin typeface="Consolas"/>
                 <a:ea typeface="Consolas"/>
               </a:rPr>
-              <a:t>代表企業</a:t>
-            </a:r>
-          </a:p>
+              <a:t>ダイヘン・東芝ES</a:t>
+            </a:r>
+          </a:p>
+        </p:txBody>
+      </p:sp>
+      <p:sp>
+        <p:nvSpPr>
+          <p:cNvPr id="30" name="TextBox 29"/>
+          <p:cNvSpPr txBox="1"/>
+          <p:nvPr/>
+        </p:nvSpPr>
+        <p:spPr>
+          <a:xfrm>
+            <a:off x="3593592" y="4919472"/>
+            <a:ext cx="1225295" cy="201168"/>
+          </a:xfrm>
+          <a:prstGeom prst="rect">
+            <a:avLst/>
+          </a:prstGeom>
+          <a:noFill/>
+        </p:spPr>
+        <p:txBody>
+          <a:bodyPr wrap="square" anchor="t" lIns="0" rIns="0" tIns="0" bIns="0">
+            <a:spAutoFit/>
+          </a:bodyPr>
+          <a:lstStyle/>
           <a:p>
             <a:pPr algn="l">
               <a:lnSpc>
-                <a:spcPct val="105000"/>
-              </a:lnSpc>
-              <a:spcBef>
-                <a:spcPts val="0"/>
-              </a:spcBef>
-              <a:spcAft>
-                <a:spcPts val="300"/>
-              </a:spcAft>
-            </a:pPr>
-            <a:r>
-              <a:rPr sz="950" b="1">
+                <a:spcPct val="106000"/>
+              </a:lnSpc>
+              <a:spcBef>
+                <a:spcPts val="0"/>
+              </a:spcBef>
+              <a:spcAft>
+                <a:spcPts val="400"/>
+              </a:spcAft>
+            </a:pPr>
+            <a:r>
+              <a:rPr sz="750" b="1">
+                <a:solidFill>
+                  <a:srgbClr val="8A9098"/>
+                </a:solidFill>
+                <a:latin typeface="Consolas"/>
+                <a:ea typeface="Consolas"/>
+              </a:rPr>
+              <a:t>代表企業（国内）</a:t>
+            </a:r>
+          </a:p>
+        </p:txBody>
+      </p:sp>
+      <p:sp>
+        <p:nvSpPr>
+          <p:cNvPr id="31" name="TextBox 30"/>
+          <p:cNvSpPr txBox="1"/>
+          <p:nvPr/>
+        </p:nvSpPr>
+        <p:spPr>
+          <a:xfrm>
+            <a:off x="3593592" y="5138928"/>
+            <a:ext cx="1225295" cy="749808"/>
+          </a:xfrm>
+          <a:prstGeom prst="rect">
+            <a:avLst/>
+          </a:prstGeom>
+          <a:noFill/>
+        </p:spPr>
+        <p:txBody>
+          <a:bodyPr wrap="square" anchor="t" lIns="0" rIns="0" tIns="0" bIns="0">
+            <a:spAutoFit/>
+          </a:bodyPr>
+          <a:lstStyle/>
+          <a:p>
+            <a:pPr algn="l">
+              <a:lnSpc>
+                <a:spcPct val="122000"/>
+              </a:lnSpc>
+              <a:spcBef>
+                <a:spcPts val="0"/>
+              </a:spcBef>
+              <a:spcAft>
+                <a:spcPts val="400"/>
+              </a:spcAft>
+            </a:pPr>
+            <a:r>
+              <a:rPr sz="900" b="1">
                 <a:solidFill>
                   <a:srgbClr val="1A1D21"/>
                 </a:solidFill>
                 <a:latin typeface="Noto Sans JP"/>
                 <a:ea typeface="Noto Sans JP"/>
               </a:rPr>
-              <a:t>日立</a:t>
-            </a:r>
-          </a:p>
-          <a:p>
-            <a:pPr algn="l">
-              <a:lnSpc>
-                <a:spcPct val="105000"/>
-              </a:lnSpc>
-              <a:spcBef>
-                <a:spcPts val="0"/>
-              </a:spcBef>
-              <a:spcAft>
-                <a:spcPts val="300"/>
-              </a:spcAft>
-            </a:pPr>
-            <a:r>
-              <a:rPr sz="950" b="1">
-                <a:solidFill>
-                  <a:srgbClr val="1A1D21"/>
-                </a:solidFill>
-                <a:latin typeface="Noto Sans JP"/>
-                <a:ea typeface="Noto Sans JP"/>
-              </a:rPr>
-              <a:t>三菱電機</a:t>
-            </a:r>
-          </a:p>
-          <a:p>
-            <a:pPr algn="l">
-              <a:lnSpc>
-                <a:spcPct val="105000"/>
-              </a:lnSpc>
-              <a:spcBef>
-                <a:spcPts val="0"/>
-              </a:spcBef>
-              <a:spcAft>
-                <a:spcPts val="300"/>
-              </a:spcAft>
-            </a:pPr>
-            <a:r>
-              <a:rPr sz="950" b="1">
-                <a:solidFill>
-                  <a:srgbClr val="1A1D21"/>
-                </a:solidFill>
-                <a:latin typeface="Noto Sans JP"/>
-                <a:ea typeface="Noto Sans JP"/>
-              </a:rPr>
-              <a:t>フジクラ</a:t>
-            </a:r>
-          </a:p>
-        </p:txBody>
-      </p:sp>
-      <p:sp>
-        <p:nvSpPr>
-          <p:cNvPr id="24" name="Chevron 23"/>
+              <a:t>日立・三菱電機・ダイヘン・フジクラ・電力4社</a:t>
+            </a:r>
+          </a:p>
+        </p:txBody>
+      </p:sp>
+      <p:sp>
+        <p:nvSpPr>
+          <p:cNvPr id="32" name="Chevron 31"/>
           <p:cNvSpPr/>
           <p:nvPr/>
         </p:nvSpPr>
         <p:spPr>
           <a:xfrm>
-            <a:off x="4828032" y="1600200"/>
-            <a:ext cx="1682495" cy="960120"/>
+            <a:off x="4974336" y="1371600"/>
+            <a:ext cx="1719072" cy="896112"/>
           </a:xfrm>
           <a:prstGeom prst="chevron">
             <a:avLst/>
@@ -15779,65 +15998,94 @@
           </a:fontRef>
         </p:style>
         <p:txBody>
-          <a:bodyPr rtlCol="0" anchor="ctr" wrap="square" lIns="109728" rIns="164592" tIns="0" bIns="0"/>
+          <a:bodyPr rtlCol="0" anchor="ctr"/>
+          <a:lstStyle/>
+          <a:p/>
+        </p:txBody>
+      </p:sp>
+      <p:sp>
+        <p:nvSpPr>
+          <p:cNvPr id="33" name="TextBox 32"/>
+          <p:cNvSpPr txBox="1"/>
+          <p:nvPr/>
+        </p:nvSpPr>
+        <p:spPr>
+          <a:xfrm>
+            <a:off x="4937760" y="1371600"/>
+            <a:ext cx="1664208" cy="896112"/>
+          </a:xfrm>
+          <a:prstGeom prst="rect">
+            <a:avLst/>
+          </a:prstGeom>
+          <a:noFill/>
+        </p:spPr>
+        <p:txBody>
+          <a:bodyPr wrap="square" anchor="ctr" lIns="0" rIns="0" tIns="0" bIns="0">
+            <a:spAutoFit/>
+          </a:bodyPr>
           <a:lstStyle/>
           <a:p>
             <a:pPr algn="ctr">
               <a:lnSpc>
                 <a:spcPct val="100000"/>
               </a:lnSpc>
-            </a:pPr>
-            <a:r>
-              <a:rPr sz="900" b="1">
+              <a:spcBef>
+                <a:spcPts val="0"/>
+              </a:spcBef>
+              <a:spcAft>
+                <a:spcPts val="0"/>
+              </a:spcAft>
+            </a:pPr>
+            <a:r>
+              <a:rPr sz="800" b="1" spc="100">
                 <a:solidFill>
                   <a:srgbClr val="FFC9CE"/>
                 </a:solidFill>
                 <a:latin typeface="Consolas"/>
-              </a:rPr>
-              <a:t>03  </a:t>
-            </a:r>
-            <a:r>
-              <a:rPr sz="1150" b="1">
+                <a:ea typeface="Consolas"/>
+              </a:rPr>
+              <a:t>03</a:t>
+            </a:r>
+          </a:p>
+          <a:p>
+            <a:pPr algn="ctr">
+              <a:lnSpc>
+                <a:spcPct val="100000"/>
+              </a:lnSpc>
+              <a:spcBef>
+                <a:spcPts val="0"/>
+              </a:spcBef>
+              <a:spcAft>
+                <a:spcPts val="0"/>
+              </a:spcAft>
+            </a:pPr>
+            <a:r>
+              <a:rPr sz="1100" b="1">
                 <a:solidFill>
                   <a:srgbClr val="FFFFFF"/>
                 </a:solidFill>
                 <a:latin typeface="Noto Sans JP"/>
+                <a:ea typeface="Noto Sans JP"/>
               </a:rPr>
               <a:t>DC建設・設備工事</a:t>
             </a:r>
           </a:p>
-          <a:p>
-            <a:pPr algn="ctr">
-              <a:spcBef>
-                <a:spcPts val="100"/>
-              </a:spcBef>
-            </a:pPr>
-            <a:r>
-              <a:rPr sz="850">
-                <a:solidFill>
-                  <a:srgbClr val="FFE2E5"/>
-                </a:solidFill>
-                <a:latin typeface="Noto Sans JP"/>
-              </a:rPr>
-              <a:t>箱を建てる</a:t>
-            </a:r>
-          </a:p>
-        </p:txBody>
-      </p:sp>
-      <p:sp>
-        <p:nvSpPr>
-          <p:cNvPr id="25" name="Rounded Rectangle 24"/>
+        </p:txBody>
+      </p:sp>
+      <p:sp>
+        <p:nvSpPr>
+          <p:cNvPr id="34" name="Rounded Rectangle 33"/>
           <p:cNvSpPr/>
           <p:nvPr/>
         </p:nvSpPr>
         <p:spPr>
           <a:xfrm>
-            <a:off x="4937759" y="2788920"/>
-            <a:ext cx="1389888" cy="2971800"/>
+            <a:off x="5038344" y="2432304"/>
+            <a:ext cx="1481328" cy="3511296"/>
           </a:xfrm>
           <a:prstGeom prst="roundRect">
             <a:avLst>
-              <a:gd name="adj" fmla="val 5000"/>
+              <a:gd name="adj" fmla="val 4500"/>
             </a:avLst>
           </a:prstGeom>
           <a:solidFill>
@@ -15874,14 +16122,14 @@
       </p:sp>
       <p:sp>
         <p:nvSpPr>
-          <p:cNvPr id="26" name="TextBox 25"/>
-          <p:cNvSpPr txBox="1"/>
-          <p:nvPr/>
-        </p:nvSpPr>
-        <p:spPr>
-          <a:xfrm>
-            <a:off x="5047488" y="2898648"/>
-            <a:ext cx="1170432" cy="274320"/>
+          <p:cNvPr id="35" name="TextBox 34"/>
+          <p:cNvSpPr txBox="1"/>
+          <p:nvPr/>
+        </p:nvSpPr>
+        <p:spPr>
+          <a:xfrm>
+            <a:off x="5166359" y="2560320"/>
+            <a:ext cx="1225295" cy="219456"/>
           </a:xfrm>
           <a:prstGeom prst="rect">
             <a:avLst/>
@@ -15920,14 +16168,14 @@
       </p:sp>
       <p:sp>
         <p:nvSpPr>
-          <p:cNvPr id="27" name="TextBox 26"/>
-          <p:cNvSpPr txBox="1"/>
-          <p:nvPr/>
-        </p:nvSpPr>
-        <p:spPr>
-          <a:xfrm>
-            <a:off x="5047488" y="3246120"/>
-            <a:ext cx="1170432" cy="640080"/>
+          <p:cNvPr id="36" name="TextBox 35"/>
+          <p:cNvSpPr txBox="1"/>
+          <p:nvPr/>
+        </p:nvSpPr>
+        <p:spPr>
+          <a:xfrm>
+            <a:off x="5166359" y="2816352"/>
+            <a:ext cx="1225295" cy="274320"/>
           </a:xfrm>
           <a:prstGeom prst="rect">
             <a:avLst/>
@@ -15942,67 +16190,90 @@
           <a:p>
             <a:pPr algn="l">
               <a:lnSpc>
-                <a:spcPct val="105000"/>
-              </a:lnSpc>
-              <a:spcBef>
-                <a:spcPts val="0"/>
-              </a:spcBef>
-              <a:spcAft>
-                <a:spcPts val="100"/>
-              </a:spcAft>
-            </a:pPr>
-            <a:r>
-              <a:rPr sz="1100" b="1">
-                <a:solidFill>
-                  <a:srgbClr val="E60012"/>
+                <a:spcPct val="106000"/>
+              </a:lnSpc>
+              <a:spcBef>
+                <a:spcPts val="0"/>
+              </a:spcBef>
+              <a:spcAft>
+                <a:spcPts val="400"/>
+              </a:spcAft>
+            </a:pPr>
+            <a:r>
+              <a:rPr sz="1150" b="1">
+                <a:solidFill>
+                  <a:srgbClr val="1A1D21"/>
                 </a:solidFill>
                 <a:latin typeface="Noto Sans JP"/>
                 <a:ea typeface="Noto Sans JP"/>
               </a:rPr>
-              <a:t>空調工事 受注+25.5%</a:t>
-            </a:r>
-          </a:p>
+              <a:t>箱を建てる</a:t>
+            </a:r>
+          </a:p>
+        </p:txBody>
+      </p:sp>
+      <p:sp>
+        <p:nvSpPr>
+          <p:cNvPr id="37" name="TextBox 36"/>
+          <p:cNvSpPr txBox="1"/>
+          <p:nvPr/>
+        </p:nvSpPr>
+        <p:spPr>
+          <a:xfrm>
+            <a:off x="5166359" y="3182112"/>
+            <a:ext cx="1225295" cy="914400"/>
+          </a:xfrm>
+          <a:prstGeom prst="rect">
+            <a:avLst/>
+          </a:prstGeom>
+          <a:noFill/>
+        </p:spPr>
+        <p:txBody>
+          <a:bodyPr wrap="square" anchor="t" lIns="0" rIns="0" tIns="0" bIns="0">
+            <a:spAutoFit/>
+          </a:bodyPr>
+          <a:lstStyle/>
           <a:p>
             <a:pPr algn="l">
               <a:lnSpc>
-                <a:spcPct val="105000"/>
-              </a:lnSpc>
-              <a:spcBef>
-                <a:spcPts val="0"/>
-              </a:spcBef>
-              <a:spcAft>
-                <a:spcPts val="100"/>
-              </a:spcAft>
-            </a:pPr>
-            <a:r>
-              <a:rPr sz="750" b="0">
-                <a:solidFill>
-                  <a:srgbClr val="8A9098"/>
-                </a:solidFill>
-                <a:latin typeface="Consolas"/>
-                <a:ea typeface="Consolas"/>
-              </a:rPr>
-              <a:t>ダイダン</a:t>
-            </a:r>
-          </a:p>
-        </p:txBody>
-      </p:sp>
-      <p:sp>
-        <p:nvSpPr>
-          <p:cNvPr id="28" name="Rectangle 27"/>
+                <a:spcPct val="116000"/>
+              </a:lnSpc>
+              <a:spcBef>
+                <a:spcPts val="0"/>
+              </a:spcBef>
+              <a:spcAft>
+                <a:spcPts val="400"/>
+              </a:spcAft>
+            </a:pPr>
+            <a:r>
+              <a:rPr sz="880" b="0">
+                <a:solidFill>
+                  <a:srgbClr val="3C4148"/>
+                </a:solidFill>
+                <a:latin typeface="Noto Sans JP"/>
+                <a:ea typeface="Noto Sans JP"/>
+              </a:rPr>
+              <a:t>巨大な建屋を建設。電気・空調のサブコンが主役で、営業の本命。</a:t>
+            </a:r>
+          </a:p>
+        </p:txBody>
+      </p:sp>
+      <p:sp>
+        <p:nvSpPr>
+          <p:cNvPr id="38" name="Rectangle 37"/>
           <p:cNvSpPr/>
           <p:nvPr/>
         </p:nvSpPr>
         <p:spPr>
           <a:xfrm>
-            <a:off x="5047488" y="3959352"/>
-            <a:ext cx="1170432" cy="10972"/>
+            <a:off x="5166359" y="4133088"/>
+            <a:ext cx="1225295" cy="9144"/>
           </a:xfrm>
           <a:prstGeom prst="rect">
             <a:avLst/>
           </a:prstGeom>
           <a:solidFill>
-            <a:srgbClr val="E2E4E9"/>
+            <a:srgbClr val="F3C7CD"/>
           </a:solidFill>
           <a:ln>
             <a:noFill/>
@@ -16033,14 +16304,14 @@
       </p:sp>
       <p:sp>
         <p:nvSpPr>
-          <p:cNvPr id="29" name="TextBox 28"/>
-          <p:cNvSpPr txBox="1"/>
-          <p:nvPr/>
-        </p:nvSpPr>
-        <p:spPr>
-          <a:xfrm>
-            <a:off x="5047488" y="4069079"/>
-            <a:ext cx="1170432" cy="1600200"/>
+          <p:cNvPr id="39" name="TextBox 38"/>
+          <p:cNvSpPr txBox="1"/>
+          <p:nvPr/>
+        </p:nvSpPr>
+        <p:spPr>
+          <a:xfrm>
+            <a:off x="5166359" y="4224528"/>
+            <a:ext cx="1225295" cy="603504"/>
           </a:xfrm>
           <a:prstGeom prst="rect">
             <a:avLst/>
@@ -16055,107 +16326,153 @@
           <a:p>
             <a:pPr algn="l">
               <a:lnSpc>
-                <a:spcPct val="105000"/>
-              </a:lnSpc>
-              <a:spcBef>
-                <a:spcPts val="0"/>
-              </a:spcBef>
-              <a:spcAft>
-                <a:spcPts val="300"/>
-              </a:spcAft>
-            </a:pPr>
-            <a:r>
-              <a:rPr sz="750" b="1">
+                <a:spcPct val="106000"/>
+              </a:lnSpc>
+              <a:spcBef>
+                <a:spcPts val="0"/>
+              </a:spcBef>
+              <a:spcAft>
+                <a:spcPts val="0"/>
+              </a:spcAft>
+            </a:pPr>
+            <a:r>
+              <a:rPr sz="1200" b="1">
+                <a:solidFill>
+                  <a:srgbClr val="E60012"/>
+                </a:solidFill>
+                <a:latin typeface="Noto Sans JP"/>
+                <a:ea typeface="Noto Sans JP"/>
+              </a:rPr>
+              <a:t>空調工事 受注 +25.5%</a:t>
+            </a:r>
+          </a:p>
+          <a:p>
+            <a:pPr algn="l">
+              <a:lnSpc>
+                <a:spcPct val="106000"/>
+              </a:lnSpc>
+              <a:spcBef>
+                <a:spcPts val="0"/>
+              </a:spcBef>
+              <a:spcAft>
+                <a:spcPts val="0"/>
+              </a:spcAft>
+            </a:pPr>
+            <a:r>
+              <a:rPr sz="750" b="0">
                 <a:solidFill>
                   <a:srgbClr val="8A9098"/>
                 </a:solidFill>
                 <a:latin typeface="Consolas"/>
                 <a:ea typeface="Consolas"/>
               </a:rPr>
-              <a:t>代表企業</a:t>
-            </a:r>
-          </a:p>
+              <a:t>ダイダン</a:t>
+            </a:r>
+          </a:p>
+        </p:txBody>
+      </p:sp>
+      <p:sp>
+        <p:nvSpPr>
+          <p:cNvPr id="40" name="TextBox 39"/>
+          <p:cNvSpPr txBox="1"/>
+          <p:nvPr/>
+        </p:nvSpPr>
+        <p:spPr>
+          <a:xfrm>
+            <a:off x="5166359" y="4919472"/>
+            <a:ext cx="1225295" cy="201168"/>
+          </a:xfrm>
+          <a:prstGeom prst="rect">
+            <a:avLst/>
+          </a:prstGeom>
+          <a:noFill/>
+        </p:spPr>
+        <p:txBody>
+          <a:bodyPr wrap="square" anchor="t" lIns="0" rIns="0" tIns="0" bIns="0">
+            <a:spAutoFit/>
+          </a:bodyPr>
+          <a:lstStyle/>
           <a:p>
             <a:pPr algn="l">
               <a:lnSpc>
-                <a:spcPct val="105000"/>
-              </a:lnSpc>
-              <a:spcBef>
-                <a:spcPts val="0"/>
-              </a:spcBef>
-              <a:spcAft>
-                <a:spcPts val="300"/>
-              </a:spcAft>
-            </a:pPr>
-            <a:r>
-              <a:rPr sz="950" b="1">
+                <a:spcPct val="106000"/>
+              </a:lnSpc>
+              <a:spcBef>
+                <a:spcPts val="0"/>
+              </a:spcBef>
+              <a:spcAft>
+                <a:spcPts val="400"/>
+              </a:spcAft>
+            </a:pPr>
+            <a:r>
+              <a:rPr sz="750" b="1">
+                <a:solidFill>
+                  <a:srgbClr val="8A9098"/>
+                </a:solidFill>
+                <a:latin typeface="Consolas"/>
+                <a:ea typeface="Consolas"/>
+              </a:rPr>
+              <a:t>代表企業（国内）</a:t>
+            </a:r>
+          </a:p>
+        </p:txBody>
+      </p:sp>
+      <p:sp>
+        <p:nvSpPr>
+          <p:cNvPr id="41" name="TextBox 40"/>
+          <p:cNvSpPr txBox="1"/>
+          <p:nvPr/>
+        </p:nvSpPr>
+        <p:spPr>
+          <a:xfrm>
+            <a:off x="5166359" y="5138928"/>
+            <a:ext cx="1225295" cy="749808"/>
+          </a:xfrm>
+          <a:prstGeom prst="rect">
+            <a:avLst/>
+          </a:prstGeom>
+          <a:noFill/>
+        </p:spPr>
+        <p:txBody>
+          <a:bodyPr wrap="square" anchor="t" lIns="0" rIns="0" tIns="0" bIns="0">
+            <a:spAutoFit/>
+          </a:bodyPr>
+          <a:lstStyle/>
+          <a:p>
+            <a:pPr algn="l">
+              <a:lnSpc>
+                <a:spcPct val="122000"/>
+              </a:lnSpc>
+              <a:spcBef>
+                <a:spcPts val="0"/>
+              </a:spcBef>
+              <a:spcAft>
+                <a:spcPts val="400"/>
+              </a:spcAft>
+            </a:pPr>
+            <a:r>
+              <a:rPr sz="900" b="1">
                 <a:solidFill>
                   <a:srgbClr val="1A1D21"/>
                 </a:solidFill>
                 <a:latin typeface="Noto Sans JP"/>
                 <a:ea typeface="Noto Sans JP"/>
               </a:rPr>
-              <a:t>鹿島・大林</a:t>
-            </a:r>
-          </a:p>
-          <a:p>
-            <a:pPr algn="l">
-              <a:lnSpc>
-                <a:spcPct val="105000"/>
-              </a:lnSpc>
-              <a:spcBef>
-                <a:spcPts val="0"/>
-              </a:spcBef>
-              <a:spcAft>
-                <a:spcPts val="300"/>
-              </a:spcAft>
-            </a:pPr>
-            <a:r>
-              <a:rPr sz="950" b="1">
-                <a:solidFill>
-                  <a:srgbClr val="1A1D21"/>
-                </a:solidFill>
-                <a:latin typeface="Noto Sans JP"/>
-                <a:ea typeface="Noto Sans JP"/>
-              </a:rPr>
-              <a:t>きんでん</a:t>
-            </a:r>
-          </a:p>
-          <a:p>
-            <a:pPr algn="l">
-              <a:lnSpc>
-                <a:spcPct val="105000"/>
-              </a:lnSpc>
-              <a:spcBef>
-                <a:spcPts val="0"/>
-              </a:spcBef>
-              <a:spcAft>
-                <a:spcPts val="300"/>
-              </a:spcAft>
-            </a:pPr>
-            <a:r>
-              <a:rPr sz="950" b="1">
-                <a:solidFill>
-                  <a:srgbClr val="1A1D21"/>
-                </a:solidFill>
-                <a:latin typeface="Noto Sans JP"/>
-                <a:ea typeface="Noto Sans JP"/>
-              </a:rPr>
-              <a:t>高砂熱学</a:t>
-            </a:r>
-          </a:p>
-        </p:txBody>
-      </p:sp>
-      <p:sp>
-        <p:nvSpPr>
-          <p:cNvPr id="30" name="Chevron 29"/>
+              <a:t>鹿島・大林・きんでん・関電工・高砂熱学</a:t>
+            </a:r>
+          </a:p>
+        </p:txBody>
+      </p:sp>
+      <p:sp>
+        <p:nvSpPr>
+          <p:cNvPr id="42" name="Chevron 41"/>
           <p:cNvSpPr/>
           <p:nvPr/>
         </p:nvSpPr>
         <p:spPr>
           <a:xfrm>
-            <a:off x="6327648" y="1600200"/>
-            <a:ext cx="1682495" cy="960120"/>
+            <a:off x="6547104" y="1371600"/>
+            <a:ext cx="1719072" cy="896112"/>
           </a:xfrm>
           <a:prstGeom prst="chevron">
             <a:avLst/>
@@ -16183,65 +16500,94 @@
           </a:fontRef>
         </p:style>
         <p:txBody>
-          <a:bodyPr rtlCol="0" anchor="ctr" wrap="square" lIns="109728" rIns="164592" tIns="0" bIns="0"/>
+          <a:bodyPr rtlCol="0" anchor="ctr"/>
+          <a:lstStyle/>
+          <a:p/>
+        </p:txBody>
+      </p:sp>
+      <p:sp>
+        <p:nvSpPr>
+          <p:cNvPr id="43" name="TextBox 42"/>
+          <p:cNvSpPr txBox="1"/>
+          <p:nvPr/>
+        </p:nvSpPr>
+        <p:spPr>
+          <a:xfrm>
+            <a:off x="6510528" y="1371600"/>
+            <a:ext cx="1664208" cy="896112"/>
+          </a:xfrm>
+          <a:prstGeom prst="rect">
+            <a:avLst/>
+          </a:prstGeom>
+          <a:noFill/>
+        </p:spPr>
+        <p:txBody>
+          <a:bodyPr wrap="square" anchor="ctr" lIns="0" rIns="0" tIns="0" bIns="0">
+            <a:spAutoFit/>
+          </a:bodyPr>
           <a:lstStyle/>
           <a:p>
             <a:pPr algn="ctr">
               <a:lnSpc>
                 <a:spcPct val="100000"/>
               </a:lnSpc>
-            </a:pPr>
-            <a:r>
-              <a:rPr sz="900" b="1">
+              <a:spcBef>
+                <a:spcPts val="0"/>
+              </a:spcBef>
+              <a:spcAft>
+                <a:spcPts val="0"/>
+              </a:spcAft>
+            </a:pPr>
+            <a:r>
+              <a:rPr sz="800" b="1" spc="100">
                 <a:solidFill>
                   <a:srgbClr val="FFC9CE"/>
                 </a:solidFill>
                 <a:latin typeface="Consolas"/>
-              </a:rPr>
-              <a:t>04  </a:t>
-            </a:r>
-            <a:r>
-              <a:rPr sz="1150" b="1">
+                <a:ea typeface="Consolas"/>
+              </a:rPr>
+              <a:t>04</a:t>
+            </a:r>
+          </a:p>
+          <a:p>
+            <a:pPr algn="ctr">
+              <a:lnSpc>
+                <a:spcPct val="100000"/>
+              </a:lnSpc>
+              <a:spcBef>
+                <a:spcPts val="0"/>
+              </a:spcBef>
+              <a:spcAft>
+                <a:spcPts val="0"/>
+              </a:spcAft>
+            </a:pPr>
+            <a:r>
+              <a:rPr sz="1100" b="1">
                 <a:solidFill>
                   <a:srgbClr val="FFFFFF"/>
                 </a:solidFill>
                 <a:latin typeface="Noto Sans JP"/>
+                <a:ea typeface="Noto Sans JP"/>
               </a:rPr>
               <a:t>冷却・電源保護</a:t>
             </a:r>
           </a:p>
-          <a:p>
-            <a:pPr algn="ctr">
-              <a:spcBef>
-                <a:spcPts val="100"/>
-              </a:spcBef>
-            </a:pPr>
-            <a:r>
-              <a:rPr sz="850">
-                <a:solidFill>
-                  <a:srgbClr val="FFE2E5"/>
-                </a:solidFill>
-                <a:latin typeface="Noto Sans JP"/>
-              </a:rPr>
-              <a:t>冷やす・止めない</a:t>
-            </a:r>
-          </a:p>
-        </p:txBody>
-      </p:sp>
-      <p:sp>
-        <p:nvSpPr>
-          <p:cNvPr id="31" name="Rounded Rectangle 30"/>
+        </p:txBody>
+      </p:sp>
+      <p:sp>
+        <p:nvSpPr>
+          <p:cNvPr id="44" name="Rounded Rectangle 43"/>
           <p:cNvSpPr/>
           <p:nvPr/>
         </p:nvSpPr>
         <p:spPr>
           <a:xfrm>
-            <a:off x="6437375" y="2788920"/>
-            <a:ext cx="1389888" cy="2971800"/>
+            <a:off x="6611112" y="2432304"/>
+            <a:ext cx="1481328" cy="3511296"/>
           </a:xfrm>
           <a:prstGeom prst="roundRect">
             <a:avLst>
-              <a:gd name="adj" fmla="val 5000"/>
+              <a:gd name="adj" fmla="val 4500"/>
             </a:avLst>
           </a:prstGeom>
           <a:solidFill>
@@ -16278,14 +16624,14 @@
       </p:sp>
       <p:sp>
         <p:nvSpPr>
-          <p:cNvPr id="32" name="TextBox 31"/>
-          <p:cNvSpPr txBox="1"/>
-          <p:nvPr/>
-        </p:nvSpPr>
-        <p:spPr>
-          <a:xfrm>
-            <a:off x="6547103" y="2898648"/>
-            <a:ext cx="1170432" cy="274320"/>
+          <p:cNvPr id="45" name="TextBox 44"/>
+          <p:cNvSpPr txBox="1"/>
+          <p:nvPr/>
+        </p:nvSpPr>
+        <p:spPr>
+          <a:xfrm>
+            <a:off x="6739127" y="2560320"/>
+            <a:ext cx="1225295" cy="219456"/>
           </a:xfrm>
           <a:prstGeom prst="rect">
             <a:avLst/>
@@ -16324,14 +16670,14 @@
       </p:sp>
       <p:sp>
         <p:nvSpPr>
-          <p:cNvPr id="33" name="TextBox 32"/>
-          <p:cNvSpPr txBox="1"/>
-          <p:nvPr/>
-        </p:nvSpPr>
-        <p:spPr>
-          <a:xfrm>
-            <a:off x="6547103" y="3246120"/>
-            <a:ext cx="1170432" cy="640080"/>
+          <p:cNvPr id="46" name="TextBox 45"/>
+          <p:cNvSpPr txBox="1"/>
+          <p:nvPr/>
+        </p:nvSpPr>
+        <p:spPr>
+          <a:xfrm>
+            <a:off x="6739127" y="2816352"/>
+            <a:ext cx="1225295" cy="274320"/>
           </a:xfrm>
           <a:prstGeom prst="rect">
             <a:avLst/>
@@ -16346,67 +16692,90 @@
           <a:p>
             <a:pPr algn="l">
               <a:lnSpc>
-                <a:spcPct val="105000"/>
-              </a:lnSpc>
-              <a:spcBef>
-                <a:spcPts val="0"/>
-              </a:spcBef>
-              <a:spcAft>
-                <a:spcPts val="100"/>
-              </a:spcAft>
-            </a:pPr>
-            <a:r>
-              <a:rPr sz="1100" b="1">
-                <a:solidFill>
-                  <a:srgbClr val="E60012"/>
+                <a:spcPct val="106000"/>
+              </a:lnSpc>
+              <a:spcBef>
+                <a:spcPts val="0"/>
+              </a:spcBef>
+              <a:spcAft>
+                <a:spcPts val="400"/>
+              </a:spcAft>
+            </a:pPr>
+            <a:r>
+              <a:rPr sz="1150" b="1">
+                <a:solidFill>
+                  <a:srgbClr val="1A1D21"/>
                 </a:solidFill>
                 <a:latin typeface="Noto Sans JP"/>
                 <a:ea typeface="Noto Sans JP"/>
               </a:rPr>
-              <a:t>北米DC冷却 約13倍</a:t>
-            </a:r>
-          </a:p>
+              <a:t>冷やす・止めない</a:t>
+            </a:r>
+          </a:p>
+        </p:txBody>
+      </p:sp>
+      <p:sp>
+        <p:nvSpPr>
+          <p:cNvPr id="47" name="TextBox 46"/>
+          <p:cNvSpPr txBox="1"/>
+          <p:nvPr/>
+        </p:nvSpPr>
+        <p:spPr>
+          <a:xfrm>
+            <a:off x="6739127" y="3182112"/>
+            <a:ext cx="1225295" cy="914400"/>
+          </a:xfrm>
+          <a:prstGeom prst="rect">
+            <a:avLst/>
+          </a:prstGeom>
+          <a:noFill/>
+        </p:spPr>
+        <p:txBody>
+          <a:bodyPr wrap="square" anchor="t" lIns="0" rIns="0" tIns="0" bIns="0">
+            <a:spAutoFit/>
+          </a:bodyPr>
+          <a:lstStyle/>
           <a:p>
             <a:pPr algn="l">
               <a:lnSpc>
-                <a:spcPct val="105000"/>
-              </a:lnSpc>
-              <a:spcBef>
-                <a:spcPts val="0"/>
-              </a:spcBef>
-              <a:spcAft>
-                <a:spcPts val="100"/>
-              </a:spcAft>
-            </a:pPr>
-            <a:r>
-              <a:rPr sz="750" b="0">
-                <a:solidFill>
-                  <a:srgbClr val="8A9098"/>
-                </a:solidFill>
-                <a:latin typeface="Consolas"/>
-                <a:ea typeface="Consolas"/>
-              </a:rPr>
-              <a:t>ダイキン</a:t>
-            </a:r>
-          </a:p>
-        </p:txBody>
-      </p:sp>
-      <p:sp>
-        <p:nvSpPr>
-          <p:cNvPr id="34" name="Rectangle 33"/>
+                <a:spcPct val="116000"/>
+              </a:lnSpc>
+              <a:spcBef>
+                <a:spcPts val="0"/>
+              </a:spcBef>
+              <a:spcAft>
+                <a:spcPts val="400"/>
+              </a:spcAft>
+            </a:pPr>
+            <a:r>
+              <a:rPr sz="880" b="0">
+                <a:solidFill>
+                  <a:srgbClr val="3C4148"/>
+                </a:solidFill>
+                <a:latin typeface="Noto Sans JP"/>
+                <a:ea typeface="Noto Sans JP"/>
+              </a:rPr>
+              <a:t>液冷で冷やし、UPSで止めない。据付・保守が伴う機器の宝庫。</a:t>
+            </a:r>
+          </a:p>
+        </p:txBody>
+      </p:sp>
+      <p:sp>
+        <p:nvSpPr>
+          <p:cNvPr id="48" name="Rectangle 47"/>
           <p:cNvSpPr/>
           <p:nvPr/>
         </p:nvSpPr>
         <p:spPr>
           <a:xfrm>
-            <a:off x="6547103" y="3959352"/>
-            <a:ext cx="1170432" cy="10972"/>
+            <a:off x="6739127" y="4133088"/>
+            <a:ext cx="1225295" cy="9144"/>
           </a:xfrm>
           <a:prstGeom prst="rect">
             <a:avLst/>
           </a:prstGeom>
           <a:solidFill>
-            <a:srgbClr val="E2E4E9"/>
+            <a:srgbClr val="F3C7CD"/>
           </a:solidFill>
           <a:ln>
             <a:noFill/>
@@ -16437,14 +16806,14 @@
       </p:sp>
       <p:sp>
         <p:nvSpPr>
-          <p:cNvPr id="35" name="TextBox 34"/>
-          <p:cNvSpPr txBox="1"/>
-          <p:nvPr/>
-        </p:nvSpPr>
-        <p:spPr>
-          <a:xfrm>
-            <a:off x="6547103" y="4069079"/>
-            <a:ext cx="1170432" cy="1600200"/>
+          <p:cNvPr id="49" name="TextBox 48"/>
+          <p:cNvSpPr txBox="1"/>
+          <p:nvPr/>
+        </p:nvSpPr>
+        <p:spPr>
+          <a:xfrm>
+            <a:off x="6739127" y="4224528"/>
+            <a:ext cx="1225295" cy="603504"/>
           </a:xfrm>
           <a:prstGeom prst="rect">
             <a:avLst/>
@@ -16459,107 +16828,153 @@
           <a:p>
             <a:pPr algn="l">
               <a:lnSpc>
-                <a:spcPct val="105000"/>
-              </a:lnSpc>
-              <a:spcBef>
-                <a:spcPts val="0"/>
-              </a:spcBef>
-              <a:spcAft>
-                <a:spcPts val="300"/>
-              </a:spcAft>
-            </a:pPr>
-            <a:r>
-              <a:rPr sz="750" b="1">
+                <a:spcPct val="106000"/>
+              </a:lnSpc>
+              <a:spcBef>
+                <a:spcPts val="0"/>
+              </a:spcBef>
+              <a:spcAft>
+                <a:spcPts val="0"/>
+              </a:spcAft>
+            </a:pPr>
+            <a:r>
+              <a:rPr sz="1200" b="1">
+                <a:solidFill>
+                  <a:srgbClr val="E60012"/>
+                </a:solidFill>
+                <a:latin typeface="Noto Sans JP"/>
+                <a:ea typeface="Noto Sans JP"/>
+              </a:rPr>
+              <a:t>北米DC冷却 約13倍</a:t>
+            </a:r>
+          </a:p>
+          <a:p>
+            <a:pPr algn="l">
+              <a:lnSpc>
+                <a:spcPct val="106000"/>
+              </a:lnSpc>
+              <a:spcBef>
+                <a:spcPts val="0"/>
+              </a:spcBef>
+              <a:spcAft>
+                <a:spcPts val="0"/>
+              </a:spcAft>
+            </a:pPr>
+            <a:r>
+              <a:rPr sz="750" b="0">
                 <a:solidFill>
                   <a:srgbClr val="8A9098"/>
                 </a:solidFill>
                 <a:latin typeface="Consolas"/>
                 <a:ea typeface="Consolas"/>
               </a:rPr>
-              <a:t>代表企業</a:t>
-            </a:r>
-          </a:p>
+              <a:t>ダイキン</a:t>
+            </a:r>
+          </a:p>
+        </p:txBody>
+      </p:sp>
+      <p:sp>
+        <p:nvSpPr>
+          <p:cNvPr id="50" name="TextBox 49"/>
+          <p:cNvSpPr txBox="1"/>
+          <p:nvPr/>
+        </p:nvSpPr>
+        <p:spPr>
+          <a:xfrm>
+            <a:off x="6739127" y="4919472"/>
+            <a:ext cx="1225295" cy="201168"/>
+          </a:xfrm>
+          <a:prstGeom prst="rect">
+            <a:avLst/>
+          </a:prstGeom>
+          <a:noFill/>
+        </p:spPr>
+        <p:txBody>
+          <a:bodyPr wrap="square" anchor="t" lIns="0" rIns="0" tIns="0" bIns="0">
+            <a:spAutoFit/>
+          </a:bodyPr>
+          <a:lstStyle/>
           <a:p>
             <a:pPr algn="l">
               <a:lnSpc>
-                <a:spcPct val="105000"/>
-              </a:lnSpc>
-              <a:spcBef>
-                <a:spcPts val="0"/>
-              </a:spcBef>
-              <a:spcAft>
-                <a:spcPts val="300"/>
-              </a:spcAft>
-            </a:pPr>
-            <a:r>
-              <a:rPr sz="950" b="1">
+                <a:spcPct val="106000"/>
+              </a:lnSpc>
+              <a:spcBef>
+                <a:spcPts val="0"/>
+              </a:spcBef>
+              <a:spcAft>
+                <a:spcPts val="400"/>
+              </a:spcAft>
+            </a:pPr>
+            <a:r>
+              <a:rPr sz="750" b="1">
+                <a:solidFill>
+                  <a:srgbClr val="8A9098"/>
+                </a:solidFill>
+                <a:latin typeface="Consolas"/>
+                <a:ea typeface="Consolas"/>
+              </a:rPr>
+              <a:t>代表企業（国内）</a:t>
+            </a:r>
+          </a:p>
+        </p:txBody>
+      </p:sp>
+      <p:sp>
+        <p:nvSpPr>
+          <p:cNvPr id="51" name="TextBox 50"/>
+          <p:cNvSpPr txBox="1"/>
+          <p:nvPr/>
+        </p:nvSpPr>
+        <p:spPr>
+          <a:xfrm>
+            <a:off x="6739127" y="5138928"/>
+            <a:ext cx="1225295" cy="749808"/>
+          </a:xfrm>
+          <a:prstGeom prst="rect">
+            <a:avLst/>
+          </a:prstGeom>
+          <a:noFill/>
+        </p:spPr>
+        <p:txBody>
+          <a:bodyPr wrap="square" anchor="t" lIns="0" rIns="0" tIns="0" bIns="0">
+            <a:spAutoFit/>
+          </a:bodyPr>
+          <a:lstStyle/>
+          <a:p>
+            <a:pPr algn="l">
+              <a:lnSpc>
+                <a:spcPct val="122000"/>
+              </a:lnSpc>
+              <a:spcBef>
+                <a:spcPts val="0"/>
+              </a:spcBef>
+              <a:spcAft>
+                <a:spcPts val="400"/>
+              </a:spcAft>
+            </a:pPr>
+            <a:r>
+              <a:rPr sz="900" b="1">
                 <a:solidFill>
                   <a:srgbClr val="1A1D21"/>
                 </a:solidFill>
                 <a:latin typeface="Noto Sans JP"/>
                 <a:ea typeface="Noto Sans JP"/>
               </a:rPr>
-              <a:t>ダイキン</a:t>
-            </a:r>
-          </a:p>
-          <a:p>
-            <a:pPr algn="l">
-              <a:lnSpc>
-                <a:spcPct val="105000"/>
-              </a:lnSpc>
-              <a:spcBef>
-                <a:spcPts val="0"/>
-              </a:spcBef>
-              <a:spcAft>
-                <a:spcPts val="300"/>
-              </a:spcAft>
-            </a:pPr>
-            <a:r>
-              <a:rPr sz="950" b="1">
-                <a:solidFill>
-                  <a:srgbClr val="1A1D21"/>
-                </a:solidFill>
-                <a:latin typeface="Noto Sans JP"/>
-                <a:ea typeface="Noto Sans JP"/>
-              </a:rPr>
-              <a:t>GSユアサ</a:t>
-            </a:r>
-          </a:p>
-          <a:p>
-            <a:pPr algn="l">
-              <a:lnSpc>
-                <a:spcPct val="105000"/>
-              </a:lnSpc>
-              <a:spcBef>
-                <a:spcPts val="0"/>
-              </a:spcBef>
-              <a:spcAft>
-                <a:spcPts val="300"/>
-              </a:spcAft>
-            </a:pPr>
-            <a:r>
-              <a:rPr sz="950" b="1">
-                <a:solidFill>
-                  <a:srgbClr val="1A1D21"/>
-                </a:solidFill>
-                <a:latin typeface="Noto Sans JP"/>
-                <a:ea typeface="Noto Sans JP"/>
-              </a:rPr>
-              <a:t>オイレス</a:t>
-            </a:r>
-          </a:p>
-        </p:txBody>
-      </p:sp>
-      <p:sp>
-        <p:nvSpPr>
-          <p:cNvPr id="36" name="Chevron 35"/>
+              <a:t>ダイキン・GSユアサ・オイレス・エア・ウォーター</a:t>
+            </a:r>
+          </a:p>
+        </p:txBody>
+      </p:sp>
+      <p:sp>
+        <p:nvSpPr>
+          <p:cNvPr id="52" name="Chevron 51"/>
           <p:cNvSpPr/>
           <p:nvPr/>
         </p:nvSpPr>
         <p:spPr>
           <a:xfrm>
-            <a:off x="7827264" y="1600200"/>
-            <a:ext cx="1682495" cy="960120"/>
+            <a:off x="8119872" y="1371600"/>
+            <a:ext cx="1719072" cy="896112"/>
           </a:xfrm>
           <a:prstGeom prst="chevron">
             <a:avLst/>
@@ -16587,65 +17002,94 @@
           </a:fontRef>
         </p:style>
         <p:txBody>
-          <a:bodyPr rtlCol="0" anchor="ctr" wrap="square" lIns="109728" rIns="164592" tIns="0" bIns="0"/>
+          <a:bodyPr rtlCol="0" anchor="ctr"/>
+          <a:lstStyle/>
+          <a:p/>
+        </p:txBody>
+      </p:sp>
+      <p:sp>
+        <p:nvSpPr>
+          <p:cNvPr id="53" name="TextBox 52"/>
+          <p:cNvSpPr txBox="1"/>
+          <p:nvPr/>
+        </p:nvSpPr>
+        <p:spPr>
+          <a:xfrm>
+            <a:off x="8083296" y="1371600"/>
+            <a:ext cx="1664208" cy="896112"/>
+          </a:xfrm>
+          <a:prstGeom prst="rect">
+            <a:avLst/>
+          </a:prstGeom>
+          <a:noFill/>
+        </p:spPr>
+        <p:txBody>
+          <a:bodyPr wrap="square" anchor="ctr" lIns="0" rIns="0" tIns="0" bIns="0">
+            <a:spAutoFit/>
+          </a:bodyPr>
           <a:lstStyle/>
           <a:p>
             <a:pPr algn="ctr">
               <a:lnSpc>
                 <a:spcPct val="100000"/>
               </a:lnSpc>
-            </a:pPr>
-            <a:r>
-              <a:rPr sz="900" b="1">
+              <a:spcBef>
+                <a:spcPts val="0"/>
+              </a:spcBef>
+              <a:spcAft>
+                <a:spcPts val="0"/>
+              </a:spcAft>
+            </a:pPr>
+            <a:r>
+              <a:rPr sz="800" b="1" spc="100">
                 <a:solidFill>
                   <a:srgbClr val="FFC9CE"/>
                 </a:solidFill>
                 <a:latin typeface="Consolas"/>
-              </a:rPr>
-              <a:t>05  </a:t>
-            </a:r>
-            <a:r>
-              <a:rPr sz="1150" b="1">
+                <a:ea typeface="Consolas"/>
+              </a:rPr>
+              <a:t>05</a:t>
+            </a:r>
+          </a:p>
+          <a:p>
+            <a:pPr algn="ctr">
+              <a:lnSpc>
+                <a:spcPct val="100000"/>
+              </a:lnSpc>
+              <a:spcBef>
+                <a:spcPts val="0"/>
+              </a:spcBef>
+              <a:spcAft>
+                <a:spcPts val="0"/>
+              </a:spcAft>
+            </a:pPr>
+            <a:r>
+              <a:rPr sz="1100" b="1">
                 <a:solidFill>
                   <a:srgbClr val="FFFFFF"/>
                 </a:solidFill>
                 <a:latin typeface="Noto Sans JP"/>
+                <a:ea typeface="Noto Sans JP"/>
               </a:rPr>
               <a:t>半導体</a:t>
             </a:r>
           </a:p>
-          <a:p>
-            <a:pPr algn="ctr">
-              <a:spcBef>
-                <a:spcPts val="100"/>
-              </a:spcBef>
-            </a:pPr>
-            <a:r>
-              <a:rPr sz="850">
-                <a:solidFill>
-                  <a:srgbClr val="FFE2E5"/>
-                </a:solidFill>
-                <a:latin typeface="Noto Sans JP"/>
-              </a:rPr>
-              <a:t>計算する頭脳</a:t>
-            </a:r>
-          </a:p>
-        </p:txBody>
-      </p:sp>
-      <p:sp>
-        <p:nvSpPr>
-          <p:cNvPr id="37" name="Rounded Rectangle 36"/>
+        </p:txBody>
+      </p:sp>
+      <p:sp>
+        <p:nvSpPr>
+          <p:cNvPr id="54" name="Rounded Rectangle 53"/>
           <p:cNvSpPr/>
           <p:nvPr/>
         </p:nvSpPr>
         <p:spPr>
           <a:xfrm>
-            <a:off x="7936992" y="2788920"/>
-            <a:ext cx="1389888" cy="2971800"/>
+            <a:off x="8183880" y="2432304"/>
+            <a:ext cx="1481328" cy="3511296"/>
           </a:xfrm>
           <a:prstGeom prst="roundRect">
             <a:avLst>
-              <a:gd name="adj" fmla="val 5000"/>
+              <a:gd name="adj" fmla="val 4500"/>
             </a:avLst>
           </a:prstGeom>
           <a:solidFill>
@@ -16682,14 +17126,14 @@
       </p:sp>
       <p:sp>
         <p:nvSpPr>
-          <p:cNvPr id="38" name="TextBox 37"/>
-          <p:cNvSpPr txBox="1"/>
-          <p:nvPr/>
-        </p:nvSpPr>
-        <p:spPr>
-          <a:xfrm>
-            <a:off x="8046719" y="2898648"/>
-            <a:ext cx="1170432" cy="274320"/>
+          <p:cNvPr id="55" name="TextBox 54"/>
+          <p:cNvSpPr txBox="1"/>
+          <p:nvPr/>
+        </p:nvSpPr>
+        <p:spPr>
+          <a:xfrm>
+            <a:off x="8311896" y="2560320"/>
+            <a:ext cx="1225295" cy="219456"/>
           </a:xfrm>
           <a:prstGeom prst="rect">
             <a:avLst/>
@@ -16721,21 +17165,21 @@
                 <a:latin typeface="Consolas"/>
                 <a:ea typeface="Consolas"/>
               </a:rPr>
-              <a:t>A＋B</a:t>
-            </a:r>
-          </a:p>
-        </p:txBody>
-      </p:sp>
-      <p:sp>
-        <p:nvSpPr>
-          <p:cNvPr id="39" name="TextBox 38"/>
-          <p:cNvSpPr txBox="1"/>
-          <p:nvPr/>
-        </p:nvSpPr>
-        <p:spPr>
-          <a:xfrm>
-            <a:off x="8046719" y="3246120"/>
-            <a:ext cx="1170432" cy="640080"/>
+              <a:t>A＋B 両取り</a:t>
+            </a:r>
+          </a:p>
+        </p:txBody>
+      </p:sp>
+      <p:sp>
+        <p:nvSpPr>
+          <p:cNvPr id="56" name="TextBox 55"/>
+          <p:cNvSpPr txBox="1"/>
+          <p:nvPr/>
+        </p:nvSpPr>
+        <p:spPr>
+          <a:xfrm>
+            <a:off x="8311896" y="2816352"/>
+            <a:ext cx="1225295" cy="274320"/>
           </a:xfrm>
           <a:prstGeom prst="rect">
             <a:avLst/>
@@ -16750,67 +17194,90 @@
           <a:p>
             <a:pPr algn="l">
               <a:lnSpc>
-                <a:spcPct val="105000"/>
-              </a:lnSpc>
-              <a:spcBef>
-                <a:spcPts val="0"/>
-              </a:spcBef>
-              <a:spcAft>
-                <a:spcPts val="100"/>
-              </a:spcAft>
-            </a:pPr>
-            <a:r>
-              <a:rPr sz="1100" b="1">
-                <a:solidFill>
-                  <a:srgbClr val="E60012"/>
+                <a:spcPct val="106000"/>
+              </a:lnSpc>
+              <a:spcBef>
+                <a:spcPts val="0"/>
+              </a:spcBef>
+              <a:spcAft>
+                <a:spcPts val="400"/>
+              </a:spcAft>
+            </a:pPr>
+            <a:r>
+              <a:rPr sz="1150" b="1">
+                <a:solidFill>
+                  <a:srgbClr val="1A1D21"/>
                 </a:solidFill>
                 <a:latin typeface="Noto Sans JP"/>
                 <a:ea typeface="Noto Sans JP"/>
               </a:rPr>
-              <a:t>設備投資 +66%</a:t>
-            </a:r>
-          </a:p>
+              <a:t>計算する頭脳</a:t>
+            </a:r>
+          </a:p>
+        </p:txBody>
+      </p:sp>
+      <p:sp>
+        <p:nvSpPr>
+          <p:cNvPr id="57" name="TextBox 56"/>
+          <p:cNvSpPr txBox="1"/>
+          <p:nvPr/>
+        </p:nvSpPr>
+        <p:spPr>
+          <a:xfrm>
+            <a:off x="8311896" y="3182112"/>
+            <a:ext cx="1225295" cy="914400"/>
+          </a:xfrm>
+          <a:prstGeom prst="rect">
+            <a:avLst/>
+          </a:prstGeom>
+          <a:noFill/>
+        </p:spPr>
+        <p:txBody>
+          <a:bodyPr wrap="square" anchor="t" lIns="0" rIns="0" tIns="0" bIns="0">
+            <a:spAutoFit/>
+          </a:bodyPr>
+          <a:lstStyle/>
           <a:p>
             <a:pPr algn="l">
               <a:lnSpc>
-                <a:spcPct val="105000"/>
-              </a:lnSpc>
-              <a:spcBef>
-                <a:spcPts val="0"/>
-              </a:spcBef>
-              <a:spcAft>
-                <a:spcPts val="100"/>
-              </a:spcAft>
-            </a:pPr>
-            <a:r>
-              <a:rPr sz="750" b="0">
-                <a:solidFill>
-                  <a:srgbClr val="8A9098"/>
-                </a:solidFill>
-                <a:latin typeface="Consolas"/>
-                <a:ea typeface="Consolas"/>
-              </a:rPr>
-              <a:t>キオクシア</a:t>
-            </a:r>
-          </a:p>
-        </p:txBody>
-      </p:sp>
-      <p:sp>
-        <p:nvSpPr>
-          <p:cNvPr id="40" name="Rectangle 39"/>
+                <a:spcPct val="116000"/>
+              </a:lnSpc>
+              <a:spcBef>
+                <a:spcPts val="0"/>
+              </a:spcBef>
+              <a:spcAft>
+                <a:spcPts val="400"/>
+              </a:spcAft>
+            </a:pPr>
+            <a:r>
+              <a:rPr sz="880" b="0">
+                <a:solidFill>
+                  <a:srgbClr val="3C4148"/>
+                </a:solidFill>
+                <a:latin typeface="Noto Sans JP"/>
+                <a:ea typeface="Noto Sans JP"/>
+              </a:rPr>
+              <a:t>AIチップ本体は海外勢が強いが、装置・材料で日本が世界的シェア。</a:t>
+            </a:r>
+          </a:p>
+        </p:txBody>
+      </p:sp>
+      <p:sp>
+        <p:nvSpPr>
+          <p:cNvPr id="58" name="Rectangle 57"/>
           <p:cNvSpPr/>
           <p:nvPr/>
         </p:nvSpPr>
         <p:spPr>
           <a:xfrm>
-            <a:off x="8046719" y="3959352"/>
-            <a:ext cx="1170432" cy="10972"/>
+            <a:off x="8311896" y="4133088"/>
+            <a:ext cx="1225295" cy="9144"/>
           </a:xfrm>
           <a:prstGeom prst="rect">
             <a:avLst/>
           </a:prstGeom>
           <a:solidFill>
-            <a:srgbClr val="E2E4E9"/>
+            <a:srgbClr val="F3C7CD"/>
           </a:solidFill>
           <a:ln>
             <a:noFill/>
@@ -16841,14 +17308,14 @@
       </p:sp>
       <p:sp>
         <p:nvSpPr>
-          <p:cNvPr id="41" name="TextBox 40"/>
-          <p:cNvSpPr txBox="1"/>
-          <p:nvPr/>
-        </p:nvSpPr>
-        <p:spPr>
-          <a:xfrm>
-            <a:off x="8046719" y="4069079"/>
-            <a:ext cx="1170432" cy="1600200"/>
+          <p:cNvPr id="59" name="TextBox 58"/>
+          <p:cNvSpPr txBox="1"/>
+          <p:nvPr/>
+        </p:nvSpPr>
+        <p:spPr>
+          <a:xfrm>
+            <a:off x="8311896" y="4224528"/>
+            <a:ext cx="1225295" cy="603504"/>
           </a:xfrm>
           <a:prstGeom prst="rect">
             <a:avLst/>
@@ -16863,111 +17330,157 @@
           <a:p>
             <a:pPr algn="l">
               <a:lnSpc>
-                <a:spcPct val="105000"/>
-              </a:lnSpc>
-              <a:spcBef>
-                <a:spcPts val="0"/>
-              </a:spcBef>
-              <a:spcAft>
-                <a:spcPts val="300"/>
-              </a:spcAft>
-            </a:pPr>
-            <a:r>
-              <a:rPr sz="750" b="1">
+                <a:spcPct val="106000"/>
+              </a:lnSpc>
+              <a:spcBef>
+                <a:spcPts val="0"/>
+              </a:spcBef>
+              <a:spcAft>
+                <a:spcPts val="0"/>
+              </a:spcAft>
+            </a:pPr>
+            <a:r>
+              <a:rPr sz="1200" b="1">
+                <a:solidFill>
+                  <a:srgbClr val="E60012"/>
+                </a:solidFill>
+                <a:latin typeface="Noto Sans JP"/>
+                <a:ea typeface="Noto Sans JP"/>
+              </a:rPr>
+              <a:t>設備投資 +66%</a:t>
+            </a:r>
+          </a:p>
+          <a:p>
+            <a:pPr algn="l">
+              <a:lnSpc>
+                <a:spcPct val="106000"/>
+              </a:lnSpc>
+              <a:spcBef>
+                <a:spcPts val="0"/>
+              </a:spcBef>
+              <a:spcAft>
+                <a:spcPts val="0"/>
+              </a:spcAft>
+            </a:pPr>
+            <a:r>
+              <a:rPr sz="750" b="0">
                 <a:solidFill>
                   <a:srgbClr val="8A9098"/>
                 </a:solidFill>
                 <a:latin typeface="Consolas"/>
                 <a:ea typeface="Consolas"/>
               </a:rPr>
-              <a:t>代表企業</a:t>
-            </a:r>
-          </a:p>
+              <a:t>キオクシア</a:t>
+            </a:r>
+          </a:p>
+        </p:txBody>
+      </p:sp>
+      <p:sp>
+        <p:nvSpPr>
+          <p:cNvPr id="60" name="TextBox 59"/>
+          <p:cNvSpPr txBox="1"/>
+          <p:nvPr/>
+        </p:nvSpPr>
+        <p:spPr>
+          <a:xfrm>
+            <a:off x="8311896" y="4919472"/>
+            <a:ext cx="1225295" cy="201168"/>
+          </a:xfrm>
+          <a:prstGeom prst="rect">
+            <a:avLst/>
+          </a:prstGeom>
+          <a:noFill/>
+        </p:spPr>
+        <p:txBody>
+          <a:bodyPr wrap="square" anchor="t" lIns="0" rIns="0" tIns="0" bIns="0">
+            <a:spAutoFit/>
+          </a:bodyPr>
+          <a:lstStyle/>
           <a:p>
             <a:pPr algn="l">
               <a:lnSpc>
-                <a:spcPct val="105000"/>
-              </a:lnSpc>
-              <a:spcBef>
-                <a:spcPts val="0"/>
-              </a:spcBef>
-              <a:spcAft>
-                <a:spcPts val="300"/>
-              </a:spcAft>
-            </a:pPr>
-            <a:r>
-              <a:rPr sz="950" b="1">
+                <a:spcPct val="106000"/>
+              </a:lnSpc>
+              <a:spcBef>
+                <a:spcPts val="0"/>
+              </a:spcBef>
+              <a:spcAft>
+                <a:spcPts val="400"/>
+              </a:spcAft>
+            </a:pPr>
+            <a:r>
+              <a:rPr sz="750" b="1">
+                <a:solidFill>
+                  <a:srgbClr val="8A9098"/>
+                </a:solidFill>
+                <a:latin typeface="Consolas"/>
+                <a:ea typeface="Consolas"/>
+              </a:rPr>
+              <a:t>代表企業（国内）</a:t>
+            </a:r>
+          </a:p>
+        </p:txBody>
+      </p:sp>
+      <p:sp>
+        <p:nvSpPr>
+          <p:cNvPr id="61" name="TextBox 60"/>
+          <p:cNvSpPr txBox="1"/>
+          <p:nvPr/>
+        </p:nvSpPr>
+        <p:spPr>
+          <a:xfrm>
+            <a:off x="8311896" y="5138928"/>
+            <a:ext cx="1225295" cy="749808"/>
+          </a:xfrm>
+          <a:prstGeom prst="rect">
+            <a:avLst/>
+          </a:prstGeom>
+          <a:noFill/>
+        </p:spPr>
+        <p:txBody>
+          <a:bodyPr wrap="square" anchor="t" lIns="0" rIns="0" tIns="0" bIns="0">
+            <a:spAutoFit/>
+          </a:bodyPr>
+          <a:lstStyle/>
+          <a:p>
+            <a:pPr algn="l">
+              <a:lnSpc>
+                <a:spcPct val="122000"/>
+              </a:lnSpc>
+              <a:spcBef>
+                <a:spcPts val="0"/>
+              </a:spcBef>
+              <a:spcAft>
+                <a:spcPts val="400"/>
+              </a:spcAft>
+            </a:pPr>
+            <a:r>
+              <a:rPr sz="900" b="1">
                 <a:solidFill>
                   <a:srgbClr val="1A1D21"/>
                 </a:solidFill>
                 <a:latin typeface="Noto Sans JP"/>
                 <a:ea typeface="Noto Sans JP"/>
               </a:rPr>
-              <a:t>東京ｴﾚｸﾄﾛﾝ</a:t>
-            </a:r>
-          </a:p>
-          <a:p>
-            <a:pPr algn="l">
-              <a:lnSpc>
-                <a:spcPct val="105000"/>
-              </a:lnSpc>
-              <a:spcBef>
-                <a:spcPts val="0"/>
-              </a:spcBef>
-              <a:spcAft>
-                <a:spcPts val="300"/>
-              </a:spcAft>
-            </a:pPr>
-            <a:r>
-              <a:rPr sz="950" b="1">
-                <a:solidFill>
-                  <a:srgbClr val="1A1D21"/>
-                </a:solidFill>
-                <a:latin typeface="Noto Sans JP"/>
-                <a:ea typeface="Noto Sans JP"/>
-              </a:rPr>
-              <a:t>ディスコ</a:t>
-            </a:r>
-          </a:p>
-          <a:p>
-            <a:pPr algn="l">
-              <a:lnSpc>
-                <a:spcPct val="105000"/>
-              </a:lnSpc>
-              <a:spcBef>
-                <a:spcPts val="0"/>
-              </a:spcBef>
-              <a:spcAft>
-                <a:spcPts val="300"/>
-              </a:spcAft>
-            </a:pPr>
-            <a:r>
-              <a:rPr sz="950" b="1">
-                <a:solidFill>
-                  <a:srgbClr val="1A1D21"/>
-                </a:solidFill>
-                <a:latin typeface="Noto Sans JP"/>
-                <a:ea typeface="Noto Sans JP"/>
-              </a:rPr>
-              <a:t>信越化学</a:t>
-            </a:r>
-          </a:p>
-        </p:txBody>
-      </p:sp>
-      <p:sp>
-        <p:nvSpPr>
-          <p:cNvPr id="42" name="Rounded Rectangle 41"/>
+              <a:t>東京エレクトロン・ディスコ・信越化学・キオクシア</a:t>
+            </a:r>
+          </a:p>
+        </p:txBody>
+      </p:sp>
+      <p:sp>
+        <p:nvSpPr>
+          <p:cNvPr id="62" name="Rounded Rectangle 61"/>
           <p:cNvSpPr/>
           <p:nvPr/>
         </p:nvSpPr>
         <p:spPr>
           <a:xfrm>
-            <a:off x="777240" y="5943600"/>
-            <a:ext cx="10634472" cy="566928"/>
+            <a:off x="777240" y="6089904"/>
+            <a:ext cx="10634472" cy="512064"/>
           </a:xfrm>
           <a:prstGeom prst="roundRect">
             <a:avLst>
-              <a:gd name="adj" fmla="val 5000"/>
+              <a:gd name="adj" fmla="val 6000"/>
             </a:avLst>
           </a:prstGeom>
           <a:solidFill>
@@ -17004,14 +17517,14 @@
       </p:sp>
       <p:sp>
         <p:nvSpPr>
-          <p:cNvPr id="43" name="TextBox 42"/>
-          <p:cNvSpPr txBox="1"/>
-          <p:nvPr/>
-        </p:nvSpPr>
-        <p:spPr>
-          <a:xfrm>
-            <a:off x="1005840" y="5943600"/>
-            <a:ext cx="10241280" cy="566928"/>
+          <p:cNvPr id="63" name="TextBox 62"/>
+          <p:cNvSpPr txBox="1"/>
+          <p:nvPr/>
+        </p:nvSpPr>
+        <p:spPr>
+          <a:xfrm>
+            <a:off x="1005840" y="6089904"/>
+            <a:ext cx="10241280" cy="512064"/>
           </a:xfrm>
           <a:prstGeom prst="rect">
             <a:avLst/>
@@ -17056,7 +17569,7 @@
               <a:t> A 発注者＝自社の設備投資を建てる側で管理</a:t>
             </a:r>
             <a:r>
-              <a:rPr sz="1050" b="0">
+              <a:rPr sz="1000" b="0">
                 <a:solidFill>
                   <a:srgbClr val="8A9098"/>
                 </a:solidFill>
@@ -17076,14 +17589,14 @@
               <a:t>B 請負＝据付・試運転・保守を納める側で管理</a:t>
             </a:r>
             <a:r>
-              <a:rPr sz="950" b="0">
+              <a:rPr sz="900" b="0">
                 <a:solidFill>
                   <a:srgbClr val="8A9098"/>
                 </a:solidFill>
                 <a:latin typeface="Noto Sans JP"/>
                 <a:ea typeface="Noto Sans JP"/>
               </a:rPr>
-              <a:t>　（各段階は代表企業のみ表示）</a:t>
+              <a:t>　※各段階は代表企業のみ表示</a:t>
             </a:r>
           </a:p>
         </p:txBody>

</xml_diff>

<commit_message>
Add "06 foundation layer" to value-chain flow (deck + HTML)
Integrate the peripheral parts/materials/gas makers as a full-width
foundation band (06) beneath the 01-05 chevron flow — mirroring the
Porter support-activity layout — in both the flow HTML and the deck's
flow slide, with representative players grouped by equipment parts,
electronic components/substrates, and industrial gases.

Co-Authored-By: Claude Sonnet 5 <noreply@anthropic.com>
Claude-Session: https://claude.ai/code/session_017hVm54qQ8iaGNRYcCDuKBy
</commit_message>
<xml_diff>
--- a/output/andpad_ai_opportunity_deck.pptx
+++ b/output/andpad_ai_opportunity_deck.pptx
@@ -19849,8 +19849,8 @@
         </p:nvSpPr>
         <p:spPr>
           <a:xfrm>
-            <a:off x="777240" y="1371600"/>
-            <a:ext cx="932688" cy="896112"/>
+            <a:off x="777240" y="1325880"/>
+            <a:ext cx="932688" cy="822960"/>
           </a:xfrm>
           <a:prstGeom prst="roundRect">
             <a:avLst>
@@ -19895,8 +19895,8 @@
         </p:nvSpPr>
         <p:spPr>
           <a:xfrm>
-            <a:off x="777240" y="1371600"/>
-            <a:ext cx="932688" cy="896112"/>
+            <a:off x="777240" y="1325880"/>
+            <a:ext cx="932688" cy="822960"/>
           </a:xfrm>
           <a:prstGeom prst="rect">
             <a:avLst/>
@@ -19987,8 +19987,8 @@
         </p:nvSpPr>
         <p:spPr>
           <a:xfrm>
-            <a:off x="9747504" y="1371600"/>
-            <a:ext cx="1664208" cy="896112"/>
+            <a:off x="9747504" y="1325880"/>
+            <a:ext cx="1664208" cy="822960"/>
           </a:xfrm>
           <a:prstGeom prst="roundRect">
             <a:avLst>
@@ -20033,8 +20033,8 @@
         </p:nvSpPr>
         <p:spPr>
           <a:xfrm>
-            <a:off x="9747504" y="1371600"/>
-            <a:ext cx="1664208" cy="896112"/>
+            <a:off x="9747504" y="1325880"/>
+            <a:ext cx="1664208" cy="822960"/>
           </a:xfrm>
           <a:prstGeom prst="rect">
             <a:avLst/>
@@ -20125,8 +20125,8 @@
         </p:nvSpPr>
         <p:spPr>
           <a:xfrm>
-            <a:off x="1828800" y="1371600"/>
-            <a:ext cx="1719072" cy="896112"/>
+            <a:off x="1828800" y="1325880"/>
+            <a:ext cx="1719072" cy="822960"/>
           </a:xfrm>
           <a:prstGeom prst="chevron">
             <a:avLst/>
@@ -20167,8 +20167,8 @@
         </p:nvSpPr>
         <p:spPr>
           <a:xfrm>
-            <a:off x="1792224" y="1371600"/>
-            <a:ext cx="1664208" cy="896112"/>
+            <a:off x="1792224" y="1325880"/>
+            <a:ext cx="1664208" cy="822960"/>
           </a:xfrm>
           <a:prstGeom prst="rect">
             <a:avLst/>
@@ -20236,8 +20236,8 @@
         </p:nvSpPr>
         <p:spPr>
           <a:xfrm>
-            <a:off x="1892807" y="2432304"/>
-            <a:ext cx="1481328" cy="3511296"/>
+            <a:off x="1892807" y="2286000"/>
+            <a:ext cx="1481328" cy="2761488"/>
           </a:xfrm>
           <a:prstGeom prst="roundRect">
             <a:avLst>
@@ -20284,8 +20284,8 @@
         </p:nvSpPr>
         <p:spPr>
           <a:xfrm>
-            <a:off x="2020824" y="2560320"/>
-            <a:ext cx="1225295" cy="219456"/>
+            <a:off x="2011679" y="2386584"/>
+            <a:ext cx="1243584" cy="201168"/>
           </a:xfrm>
           <a:prstGeom prst="rect">
             <a:avLst/>
@@ -20330,8 +20330,8 @@
         </p:nvSpPr>
         <p:spPr>
           <a:xfrm>
-            <a:off x="2020824" y="2816352"/>
-            <a:ext cx="1225295" cy="274320"/>
+            <a:off x="2011679" y="2606040"/>
+            <a:ext cx="1243584" cy="256032"/>
           </a:xfrm>
           <a:prstGeom prst="rect">
             <a:avLst/>
@@ -20356,7 +20356,7 @@
               </a:spcAft>
             </a:pPr>
             <a:r>
-              <a:rPr sz="1150" b="1">
+              <a:rPr sz="1100" b="1">
                 <a:solidFill>
                   <a:srgbClr val="1A1D21"/>
                 </a:solidFill>
@@ -20376,8 +20376,8 @@
         </p:nvSpPr>
         <p:spPr>
           <a:xfrm>
-            <a:off x="2020824" y="3182112"/>
-            <a:ext cx="1225295" cy="914400"/>
+            <a:off x="2011679" y="2907792"/>
+            <a:ext cx="1243584" cy="603504"/>
           </a:xfrm>
           <a:prstGeom prst="rect">
             <a:avLst/>
@@ -20392,24 +20392,24 @@
           <a:p>
             <a:pPr algn="l">
               <a:lnSpc>
-                <a:spcPct val="116000"/>
-              </a:lnSpc>
-              <a:spcBef>
-                <a:spcPts val="0"/>
-              </a:spcBef>
-              <a:spcAft>
-                <a:spcPts val="400"/>
-              </a:spcAft>
-            </a:pPr>
-            <a:r>
-              <a:rPr sz="880" b="0">
+                <a:spcPct val="112000"/>
+              </a:lnSpc>
+              <a:spcBef>
+                <a:spcPts val="0"/>
+              </a:spcBef>
+              <a:spcAft>
+                <a:spcPts val="400"/>
+              </a:spcAft>
+            </a:pPr>
+            <a:r>
+              <a:rPr sz="850" b="0">
                 <a:solidFill>
                   <a:srgbClr val="3C4148"/>
                 </a:solidFill>
                 <a:latin typeface="Noto Sans JP"/>
                 <a:ea typeface="Noto Sans JP"/>
               </a:rPr>
-              <a:t>電力が全ての起点。ガスタービンや非常用発電機の需要が急増。</a:t>
+              <a:t>電力が全ての起点。発電機・非常用電源が急増。</a:t>
             </a:r>
           </a:p>
         </p:txBody>
@@ -20422,8 +20422,8 @@
         </p:nvSpPr>
         <p:spPr>
           <a:xfrm>
-            <a:off x="2020824" y="4133088"/>
-            <a:ext cx="1225295" cy="9144"/>
+            <a:off x="2011679" y="3566160"/>
+            <a:ext cx="1243584" cy="9144"/>
           </a:xfrm>
           <a:prstGeom prst="rect">
             <a:avLst/>
@@ -20466,8 +20466,8 @@
         </p:nvSpPr>
         <p:spPr>
           <a:xfrm>
-            <a:off x="2020824" y="4224528"/>
-            <a:ext cx="1225295" cy="603504"/>
+            <a:off x="2011679" y="3639312"/>
+            <a:ext cx="1243584" cy="530352"/>
           </a:xfrm>
           <a:prstGeom prst="rect">
             <a:avLst/>
@@ -20482,17 +20482,17 @@
           <a:p>
             <a:pPr algn="l">
               <a:lnSpc>
-                <a:spcPct val="106000"/>
-              </a:lnSpc>
-              <a:spcBef>
-                <a:spcPts val="0"/>
-              </a:spcBef>
-              <a:spcAft>
-                <a:spcPts val="0"/>
-              </a:spcAft>
-            </a:pPr>
-            <a:r>
-              <a:rPr sz="1200" b="1">
+                <a:spcPct val="104000"/>
+              </a:lnSpc>
+              <a:spcBef>
+                <a:spcPts val="0"/>
+              </a:spcBef>
+              <a:spcAft>
+                <a:spcPts val="0"/>
+              </a:spcAft>
+            </a:pPr>
+            <a:r>
+              <a:rPr sz="1150" b="1">
                 <a:solidFill>
                   <a:srgbClr val="E60012"/>
                 </a:solidFill>
@@ -20505,17 +20505,17 @@
           <a:p>
             <a:pPr algn="l">
               <a:lnSpc>
-                <a:spcPct val="106000"/>
-              </a:lnSpc>
-              <a:spcBef>
-                <a:spcPts val="0"/>
-              </a:spcBef>
-              <a:spcAft>
-                <a:spcPts val="0"/>
-              </a:spcAft>
-            </a:pPr>
-            <a:r>
-              <a:rPr sz="750" b="0">
+                <a:spcPct val="104000"/>
+              </a:lnSpc>
+              <a:spcBef>
+                <a:spcPts val="0"/>
+              </a:spcBef>
+              <a:spcAft>
+                <a:spcPts val="0"/>
+              </a:spcAft>
+            </a:pPr>
+            <a:r>
+              <a:rPr sz="700" b="0">
                 <a:solidFill>
                   <a:srgbClr val="8A9098"/>
                 </a:solidFill>
@@ -20535,8 +20535,8 @@
         </p:nvSpPr>
         <p:spPr>
           <a:xfrm>
-            <a:off x="2020824" y="4919472"/>
-            <a:ext cx="1225295" cy="201168"/>
+            <a:off x="2011679" y="4206240"/>
+            <a:ext cx="1243584" cy="182880"/>
           </a:xfrm>
           <a:prstGeom prst="rect">
             <a:avLst/>
@@ -20561,7 +20561,7 @@
               </a:spcAft>
             </a:pPr>
             <a:r>
-              <a:rPr sz="750" b="1">
+              <a:rPr sz="700" b="1">
                 <a:solidFill>
                   <a:srgbClr val="8A9098"/>
                 </a:solidFill>
@@ -20581,8 +20581,8 @@
         </p:nvSpPr>
         <p:spPr>
           <a:xfrm>
-            <a:off x="2020824" y="5138928"/>
-            <a:ext cx="1225295" cy="749808"/>
+            <a:off x="2011679" y="4389120"/>
+            <a:ext cx="1243584" cy="603504"/>
           </a:xfrm>
           <a:prstGeom prst="rect">
             <a:avLst/>
@@ -20597,24 +20597,24 @@
           <a:p>
             <a:pPr algn="l">
               <a:lnSpc>
-                <a:spcPct val="122000"/>
-              </a:lnSpc>
-              <a:spcBef>
-                <a:spcPts val="0"/>
-              </a:spcBef>
-              <a:spcAft>
-                <a:spcPts val="400"/>
-              </a:spcAft>
-            </a:pPr>
-            <a:r>
-              <a:rPr sz="900" b="1">
+                <a:spcPct val="118000"/>
+              </a:lnSpc>
+              <a:spcBef>
+                <a:spcPts val="0"/>
+              </a:spcBef>
+              <a:spcAft>
+                <a:spcPts val="400"/>
+              </a:spcAft>
+            </a:pPr>
+            <a:r>
+              <a:rPr sz="880" b="1">
                 <a:solidFill>
                   <a:srgbClr val="1A1D21"/>
                 </a:solidFill>
                 <a:latin typeface="Noto Sans JP"/>
                 <a:ea typeface="Noto Sans JP"/>
               </a:rPr>
-              <a:t>三菱重工・IHI・川崎重工・ヤンマー・デンヨー</a:t>
+              <a:t>三菱重工・IHI・ヤンマー・デンヨー</a:t>
             </a:r>
           </a:p>
         </p:txBody>
@@ -20627,8 +20627,8 @@
         </p:nvSpPr>
         <p:spPr>
           <a:xfrm>
-            <a:off x="3401568" y="1371600"/>
-            <a:ext cx="1719072" cy="896112"/>
+            <a:off x="3401568" y="1325880"/>
+            <a:ext cx="1719072" cy="822960"/>
           </a:xfrm>
           <a:prstGeom prst="chevron">
             <a:avLst/>
@@ -20669,8 +20669,8 @@
         </p:nvSpPr>
         <p:spPr>
           <a:xfrm>
-            <a:off x="3364992" y="1371600"/>
-            <a:ext cx="1664208" cy="896112"/>
+            <a:off x="3364992" y="1325880"/>
+            <a:ext cx="1664208" cy="822960"/>
           </a:xfrm>
           <a:prstGeom prst="rect">
             <a:avLst/>
@@ -20738,8 +20738,8 @@
         </p:nvSpPr>
         <p:spPr>
           <a:xfrm>
-            <a:off x="3465576" y="2432304"/>
-            <a:ext cx="1481328" cy="3511296"/>
+            <a:off x="3465576" y="2286000"/>
+            <a:ext cx="1481328" cy="2761488"/>
           </a:xfrm>
           <a:prstGeom prst="roundRect">
             <a:avLst>
@@ -20786,8 +20786,8 @@
         </p:nvSpPr>
         <p:spPr>
           <a:xfrm>
-            <a:off x="3593592" y="2560320"/>
-            <a:ext cx="1225295" cy="219456"/>
+            <a:off x="3584448" y="2386584"/>
+            <a:ext cx="1243584" cy="201168"/>
           </a:xfrm>
           <a:prstGeom prst="rect">
             <a:avLst/>
@@ -20832,8 +20832,8 @@
         </p:nvSpPr>
         <p:spPr>
           <a:xfrm>
-            <a:off x="3593592" y="2816352"/>
-            <a:ext cx="1225295" cy="274320"/>
+            <a:off x="3584448" y="2606040"/>
+            <a:ext cx="1243584" cy="256032"/>
           </a:xfrm>
           <a:prstGeom prst="rect">
             <a:avLst/>
@@ -20858,7 +20858,7 @@
               </a:spcAft>
             </a:pPr>
             <a:r>
-              <a:rPr sz="1150" b="1">
+              <a:rPr sz="1100" b="1">
                 <a:solidFill>
                   <a:srgbClr val="1A1D21"/>
                 </a:solidFill>
@@ -20878,8 +20878,8 @@
         </p:nvSpPr>
         <p:spPr>
           <a:xfrm>
-            <a:off x="3593592" y="3182112"/>
-            <a:ext cx="1225295" cy="914400"/>
+            <a:off x="3584448" y="2907792"/>
+            <a:ext cx="1243584" cy="603504"/>
           </a:xfrm>
           <a:prstGeom prst="rect">
             <a:avLst/>
@@ -20894,24 +20894,24 @@
           <a:p>
             <a:pPr algn="l">
               <a:lnSpc>
-                <a:spcPct val="116000"/>
-              </a:lnSpc>
-              <a:spcBef>
-                <a:spcPts val="0"/>
-              </a:spcBef>
-              <a:spcAft>
-                <a:spcPts val="400"/>
-              </a:spcAft>
-            </a:pPr>
-            <a:r>
-              <a:rPr sz="880" b="0">
+                <a:spcPct val="112000"/>
+              </a:lnSpc>
+              <a:spcBef>
+                <a:spcPts val="0"/>
+              </a:spcBef>
+              <a:spcAft>
+                <a:spcPts val="400"/>
+              </a:spcAft>
+            </a:pPr>
+            <a:r>
+              <a:rPr sz="850" b="0">
                 <a:solidFill>
                   <a:srgbClr val="3C4148"/>
                 </a:solidFill>
                 <a:latin typeface="Noto Sans JP"/>
                 <a:ea typeface="Noto Sans JP"/>
               </a:rPr>
-              <a:t>高電圧で送りDC向けに変換。変圧器は世界的に品薄で受注は数年先まで。</a:t>
+              <a:t>変圧器でDC向けに変換。品薄で受注は数年先。</a:t>
             </a:r>
           </a:p>
         </p:txBody>
@@ -20924,8 +20924,8 @@
         </p:nvSpPr>
         <p:spPr>
           <a:xfrm>
-            <a:off x="3593592" y="4133088"/>
-            <a:ext cx="1225295" cy="9144"/>
+            <a:off x="3584448" y="3566160"/>
+            <a:ext cx="1243584" cy="9144"/>
           </a:xfrm>
           <a:prstGeom prst="rect">
             <a:avLst/>
@@ -20968,8 +20968,8 @@
         </p:nvSpPr>
         <p:spPr>
           <a:xfrm>
-            <a:off x="3593592" y="4224528"/>
-            <a:ext cx="1225295" cy="603504"/>
+            <a:off x="3584448" y="3639312"/>
+            <a:ext cx="1243584" cy="530352"/>
           </a:xfrm>
           <a:prstGeom prst="rect">
             <a:avLst/>
@@ -20984,17 +20984,17 @@
           <a:p>
             <a:pPr algn="l">
               <a:lnSpc>
-                <a:spcPct val="106000"/>
-              </a:lnSpc>
-              <a:spcBef>
-                <a:spcPts val="0"/>
-              </a:spcBef>
-              <a:spcAft>
-                <a:spcPts val="0"/>
-              </a:spcAft>
-            </a:pPr>
-            <a:r>
-              <a:rPr sz="1200" b="1">
+                <a:spcPct val="104000"/>
+              </a:lnSpc>
+              <a:spcBef>
+                <a:spcPts val="0"/>
+              </a:spcBef>
+              <a:spcAft>
+                <a:spcPts val="0"/>
+              </a:spcAft>
+            </a:pPr>
+            <a:r>
+              <a:rPr sz="1150" b="1">
                 <a:solidFill>
                   <a:srgbClr val="E60012"/>
                 </a:solidFill>
@@ -21007,17 +21007,17 @@
           <a:p>
             <a:pPr algn="l">
               <a:lnSpc>
-                <a:spcPct val="106000"/>
-              </a:lnSpc>
-              <a:spcBef>
-                <a:spcPts val="0"/>
-              </a:spcBef>
-              <a:spcAft>
-                <a:spcPts val="0"/>
-              </a:spcAft>
-            </a:pPr>
-            <a:r>
-              <a:rPr sz="750" b="0">
+                <a:spcPct val="104000"/>
+              </a:lnSpc>
+              <a:spcBef>
+                <a:spcPts val="0"/>
+              </a:spcBef>
+              <a:spcAft>
+                <a:spcPts val="0"/>
+              </a:spcAft>
+            </a:pPr>
+            <a:r>
+              <a:rPr sz="700" b="0">
                 <a:solidFill>
                   <a:srgbClr val="8A9098"/>
                 </a:solidFill>
@@ -21037,8 +21037,8 @@
         </p:nvSpPr>
         <p:spPr>
           <a:xfrm>
-            <a:off x="3593592" y="4919472"/>
-            <a:ext cx="1225295" cy="201168"/>
+            <a:off x="3584448" y="4206240"/>
+            <a:ext cx="1243584" cy="182880"/>
           </a:xfrm>
           <a:prstGeom prst="rect">
             <a:avLst/>
@@ -21063,7 +21063,7 @@
               </a:spcAft>
             </a:pPr>
             <a:r>
-              <a:rPr sz="750" b="1">
+              <a:rPr sz="700" b="1">
                 <a:solidFill>
                   <a:srgbClr val="8A9098"/>
                 </a:solidFill>
@@ -21083,8 +21083,8 @@
         </p:nvSpPr>
         <p:spPr>
           <a:xfrm>
-            <a:off x="3593592" y="5138928"/>
-            <a:ext cx="1225295" cy="749808"/>
+            <a:off x="3584448" y="4389120"/>
+            <a:ext cx="1243584" cy="603504"/>
           </a:xfrm>
           <a:prstGeom prst="rect">
             <a:avLst/>
@@ -21099,24 +21099,24 @@
           <a:p>
             <a:pPr algn="l">
               <a:lnSpc>
-                <a:spcPct val="122000"/>
-              </a:lnSpc>
-              <a:spcBef>
-                <a:spcPts val="0"/>
-              </a:spcBef>
-              <a:spcAft>
-                <a:spcPts val="400"/>
-              </a:spcAft>
-            </a:pPr>
-            <a:r>
-              <a:rPr sz="900" b="1">
+                <a:spcPct val="118000"/>
+              </a:lnSpc>
+              <a:spcBef>
+                <a:spcPts val="0"/>
+              </a:spcBef>
+              <a:spcAft>
+                <a:spcPts val="400"/>
+              </a:spcAft>
+            </a:pPr>
+            <a:r>
+              <a:rPr sz="880" b="1">
                 <a:solidFill>
                   <a:srgbClr val="1A1D21"/>
                 </a:solidFill>
                 <a:latin typeface="Noto Sans JP"/>
                 <a:ea typeface="Noto Sans JP"/>
               </a:rPr>
-              <a:t>日立・三菱電機・ダイヘン・フジクラ・電力4社</a:t>
+              <a:t>日立・三菱電機・ダイヘン・フジクラ</a:t>
             </a:r>
           </a:p>
         </p:txBody>
@@ -21129,8 +21129,8 @@
         </p:nvSpPr>
         <p:spPr>
           <a:xfrm>
-            <a:off x="4974336" y="1371600"/>
-            <a:ext cx="1719072" cy="896112"/>
+            <a:off x="4974336" y="1325880"/>
+            <a:ext cx="1719072" cy="822960"/>
           </a:xfrm>
           <a:prstGeom prst="chevron">
             <a:avLst/>
@@ -21171,8 +21171,8 @@
         </p:nvSpPr>
         <p:spPr>
           <a:xfrm>
-            <a:off x="4937760" y="1371600"/>
-            <a:ext cx="1664208" cy="896112"/>
+            <a:off x="4937760" y="1325880"/>
+            <a:ext cx="1664208" cy="822960"/>
           </a:xfrm>
           <a:prstGeom prst="rect">
             <a:avLst/>
@@ -21240,8 +21240,8 @@
         </p:nvSpPr>
         <p:spPr>
           <a:xfrm>
-            <a:off x="5038344" y="2432304"/>
-            <a:ext cx="1481328" cy="3511296"/>
+            <a:off x="5038344" y="2286000"/>
+            <a:ext cx="1481328" cy="2761488"/>
           </a:xfrm>
           <a:prstGeom prst="roundRect">
             <a:avLst>
@@ -21288,8 +21288,8 @@
         </p:nvSpPr>
         <p:spPr>
           <a:xfrm>
-            <a:off x="5166359" y="2560320"/>
-            <a:ext cx="1225295" cy="219456"/>
+            <a:off x="5157216" y="2386584"/>
+            <a:ext cx="1243584" cy="201168"/>
           </a:xfrm>
           <a:prstGeom prst="rect">
             <a:avLst/>
@@ -21334,8 +21334,8 @@
         </p:nvSpPr>
         <p:spPr>
           <a:xfrm>
-            <a:off x="5166359" y="2816352"/>
-            <a:ext cx="1225295" cy="274320"/>
+            <a:off x="5157216" y="2606040"/>
+            <a:ext cx="1243584" cy="256032"/>
           </a:xfrm>
           <a:prstGeom prst="rect">
             <a:avLst/>
@@ -21360,7 +21360,7 @@
               </a:spcAft>
             </a:pPr>
             <a:r>
-              <a:rPr sz="1150" b="1">
+              <a:rPr sz="1100" b="1">
                 <a:solidFill>
                   <a:srgbClr val="1A1D21"/>
                 </a:solidFill>
@@ -21380,8 +21380,8 @@
         </p:nvSpPr>
         <p:spPr>
           <a:xfrm>
-            <a:off x="5166359" y="3182112"/>
-            <a:ext cx="1225295" cy="914400"/>
+            <a:off x="5157216" y="2907792"/>
+            <a:ext cx="1243584" cy="603504"/>
           </a:xfrm>
           <a:prstGeom prst="rect">
             <a:avLst/>
@@ -21396,24 +21396,24 @@
           <a:p>
             <a:pPr algn="l">
               <a:lnSpc>
-                <a:spcPct val="116000"/>
-              </a:lnSpc>
-              <a:spcBef>
-                <a:spcPts val="0"/>
-              </a:spcBef>
-              <a:spcAft>
-                <a:spcPts val="400"/>
-              </a:spcAft>
-            </a:pPr>
-            <a:r>
-              <a:rPr sz="880" b="0">
+                <a:spcPct val="112000"/>
+              </a:lnSpc>
+              <a:spcBef>
+                <a:spcPts val="0"/>
+              </a:spcBef>
+              <a:spcAft>
+                <a:spcPts val="400"/>
+              </a:spcAft>
+            </a:pPr>
+            <a:r>
+              <a:rPr sz="850" b="0">
                 <a:solidFill>
                   <a:srgbClr val="3C4148"/>
                 </a:solidFill>
                 <a:latin typeface="Noto Sans JP"/>
                 <a:ea typeface="Noto Sans JP"/>
               </a:rPr>
-              <a:t>巨大な建屋を建設。電気・空調のサブコンが主役で、営業の本命。</a:t>
+              <a:t>巨大な建屋を建設。設備工事が営業の本命。</a:t>
             </a:r>
           </a:p>
         </p:txBody>
@@ -21426,8 +21426,8 @@
         </p:nvSpPr>
         <p:spPr>
           <a:xfrm>
-            <a:off x="5166359" y="4133088"/>
-            <a:ext cx="1225295" cy="9144"/>
+            <a:off x="5157216" y="3566160"/>
+            <a:ext cx="1243584" cy="9144"/>
           </a:xfrm>
           <a:prstGeom prst="rect">
             <a:avLst/>
@@ -21470,8 +21470,8 @@
         </p:nvSpPr>
         <p:spPr>
           <a:xfrm>
-            <a:off x="5166359" y="4224528"/>
-            <a:ext cx="1225295" cy="603504"/>
+            <a:off x="5157216" y="3639312"/>
+            <a:ext cx="1243584" cy="530352"/>
           </a:xfrm>
           <a:prstGeom prst="rect">
             <a:avLst/>
@@ -21486,17 +21486,17 @@
           <a:p>
             <a:pPr algn="l">
               <a:lnSpc>
-                <a:spcPct val="106000"/>
-              </a:lnSpc>
-              <a:spcBef>
-                <a:spcPts val="0"/>
-              </a:spcBef>
-              <a:spcAft>
-                <a:spcPts val="0"/>
-              </a:spcAft>
-            </a:pPr>
-            <a:r>
-              <a:rPr sz="1200" b="1">
+                <a:spcPct val="104000"/>
+              </a:lnSpc>
+              <a:spcBef>
+                <a:spcPts val="0"/>
+              </a:spcBef>
+              <a:spcAft>
+                <a:spcPts val="0"/>
+              </a:spcAft>
+            </a:pPr>
+            <a:r>
+              <a:rPr sz="1150" b="1">
                 <a:solidFill>
                   <a:srgbClr val="E60012"/>
                 </a:solidFill>
@@ -21509,17 +21509,17 @@
           <a:p>
             <a:pPr algn="l">
               <a:lnSpc>
-                <a:spcPct val="106000"/>
-              </a:lnSpc>
-              <a:spcBef>
-                <a:spcPts val="0"/>
-              </a:spcBef>
-              <a:spcAft>
-                <a:spcPts val="0"/>
-              </a:spcAft>
-            </a:pPr>
-            <a:r>
-              <a:rPr sz="750" b="0">
+                <a:spcPct val="104000"/>
+              </a:lnSpc>
+              <a:spcBef>
+                <a:spcPts val="0"/>
+              </a:spcBef>
+              <a:spcAft>
+                <a:spcPts val="0"/>
+              </a:spcAft>
+            </a:pPr>
+            <a:r>
+              <a:rPr sz="700" b="0">
                 <a:solidFill>
                   <a:srgbClr val="8A9098"/>
                 </a:solidFill>
@@ -21539,8 +21539,8 @@
         </p:nvSpPr>
         <p:spPr>
           <a:xfrm>
-            <a:off x="5166359" y="4919472"/>
-            <a:ext cx="1225295" cy="201168"/>
+            <a:off x="5157216" y="4206240"/>
+            <a:ext cx="1243584" cy="182880"/>
           </a:xfrm>
           <a:prstGeom prst="rect">
             <a:avLst/>
@@ -21565,7 +21565,7 @@
               </a:spcAft>
             </a:pPr>
             <a:r>
-              <a:rPr sz="750" b="1">
+              <a:rPr sz="700" b="1">
                 <a:solidFill>
                   <a:srgbClr val="8A9098"/>
                 </a:solidFill>
@@ -21585,8 +21585,8 @@
         </p:nvSpPr>
         <p:spPr>
           <a:xfrm>
-            <a:off x="5166359" y="5138928"/>
-            <a:ext cx="1225295" cy="749808"/>
+            <a:off x="5157216" y="4389120"/>
+            <a:ext cx="1243584" cy="603504"/>
           </a:xfrm>
           <a:prstGeom prst="rect">
             <a:avLst/>
@@ -21601,24 +21601,24 @@
           <a:p>
             <a:pPr algn="l">
               <a:lnSpc>
-                <a:spcPct val="122000"/>
-              </a:lnSpc>
-              <a:spcBef>
-                <a:spcPts val="0"/>
-              </a:spcBef>
-              <a:spcAft>
-                <a:spcPts val="400"/>
-              </a:spcAft>
-            </a:pPr>
-            <a:r>
-              <a:rPr sz="900" b="1">
+                <a:spcPct val="118000"/>
+              </a:lnSpc>
+              <a:spcBef>
+                <a:spcPts val="0"/>
+              </a:spcBef>
+              <a:spcAft>
+                <a:spcPts val="400"/>
+              </a:spcAft>
+            </a:pPr>
+            <a:r>
+              <a:rPr sz="880" b="1">
                 <a:solidFill>
                   <a:srgbClr val="1A1D21"/>
                 </a:solidFill>
                 <a:latin typeface="Noto Sans JP"/>
                 <a:ea typeface="Noto Sans JP"/>
               </a:rPr>
-              <a:t>鹿島・大林・きんでん・関電工・高砂熱学</a:t>
+              <a:t>鹿島・大林・きんでん・高砂熱学</a:t>
             </a:r>
           </a:p>
         </p:txBody>
@@ -21631,8 +21631,8 @@
         </p:nvSpPr>
         <p:spPr>
           <a:xfrm>
-            <a:off x="6547104" y="1371600"/>
-            <a:ext cx="1719072" cy="896112"/>
+            <a:off x="6547104" y="1325880"/>
+            <a:ext cx="1719072" cy="822960"/>
           </a:xfrm>
           <a:prstGeom prst="chevron">
             <a:avLst/>
@@ -21673,8 +21673,8 @@
         </p:nvSpPr>
         <p:spPr>
           <a:xfrm>
-            <a:off x="6510528" y="1371600"/>
-            <a:ext cx="1664208" cy="896112"/>
+            <a:off x="6510528" y="1325880"/>
+            <a:ext cx="1664208" cy="822960"/>
           </a:xfrm>
           <a:prstGeom prst="rect">
             <a:avLst/>
@@ -21742,8 +21742,8 @@
         </p:nvSpPr>
         <p:spPr>
           <a:xfrm>
-            <a:off x="6611112" y="2432304"/>
-            <a:ext cx="1481328" cy="3511296"/>
+            <a:off x="6611112" y="2286000"/>
+            <a:ext cx="1481328" cy="2761488"/>
           </a:xfrm>
           <a:prstGeom prst="roundRect">
             <a:avLst>
@@ -21790,8 +21790,8 @@
         </p:nvSpPr>
         <p:spPr>
           <a:xfrm>
-            <a:off x="6739127" y="2560320"/>
-            <a:ext cx="1225295" cy="219456"/>
+            <a:off x="6729983" y="2386584"/>
+            <a:ext cx="1243584" cy="201168"/>
           </a:xfrm>
           <a:prstGeom prst="rect">
             <a:avLst/>
@@ -21836,8 +21836,8 @@
         </p:nvSpPr>
         <p:spPr>
           <a:xfrm>
-            <a:off x="6739127" y="2816352"/>
-            <a:ext cx="1225295" cy="274320"/>
+            <a:off x="6729983" y="2606040"/>
+            <a:ext cx="1243584" cy="256032"/>
           </a:xfrm>
           <a:prstGeom prst="rect">
             <a:avLst/>
@@ -21862,7 +21862,7 @@
               </a:spcAft>
             </a:pPr>
             <a:r>
-              <a:rPr sz="1150" b="1">
+              <a:rPr sz="1100" b="1">
                 <a:solidFill>
                   <a:srgbClr val="1A1D21"/>
                 </a:solidFill>
@@ -21882,8 +21882,8 @@
         </p:nvSpPr>
         <p:spPr>
           <a:xfrm>
-            <a:off x="6739127" y="3182112"/>
-            <a:ext cx="1225295" cy="914400"/>
+            <a:off x="6729983" y="2907792"/>
+            <a:ext cx="1243584" cy="603504"/>
           </a:xfrm>
           <a:prstGeom prst="rect">
             <a:avLst/>
@@ -21898,24 +21898,24 @@
           <a:p>
             <a:pPr algn="l">
               <a:lnSpc>
-                <a:spcPct val="116000"/>
-              </a:lnSpc>
-              <a:spcBef>
-                <a:spcPts val="0"/>
-              </a:spcBef>
-              <a:spcAft>
-                <a:spcPts val="400"/>
-              </a:spcAft>
-            </a:pPr>
-            <a:r>
-              <a:rPr sz="880" b="0">
+                <a:spcPct val="112000"/>
+              </a:lnSpc>
+              <a:spcBef>
+                <a:spcPts val="0"/>
+              </a:spcBef>
+              <a:spcAft>
+                <a:spcPts val="400"/>
+              </a:spcAft>
+            </a:pPr>
+            <a:r>
+              <a:rPr sz="850" b="0">
                 <a:solidFill>
                   <a:srgbClr val="3C4148"/>
                 </a:solidFill>
                 <a:latin typeface="Noto Sans JP"/>
                 <a:ea typeface="Noto Sans JP"/>
               </a:rPr>
-              <a:t>液冷で冷やし、UPSで止めない。据付・保守が伴う機器の宝庫。</a:t>
+              <a:t>液冷で冷やしUPSで止めない。据付・保守の宝庫。</a:t>
             </a:r>
           </a:p>
         </p:txBody>
@@ -21928,8 +21928,8 @@
         </p:nvSpPr>
         <p:spPr>
           <a:xfrm>
-            <a:off x="6739127" y="4133088"/>
-            <a:ext cx="1225295" cy="9144"/>
+            <a:off x="6729983" y="3566160"/>
+            <a:ext cx="1243584" cy="9144"/>
           </a:xfrm>
           <a:prstGeom prst="rect">
             <a:avLst/>
@@ -21972,8 +21972,8 @@
         </p:nvSpPr>
         <p:spPr>
           <a:xfrm>
-            <a:off x="6739127" y="4224528"/>
-            <a:ext cx="1225295" cy="603504"/>
+            <a:off x="6729983" y="3639312"/>
+            <a:ext cx="1243584" cy="530352"/>
           </a:xfrm>
           <a:prstGeom prst="rect">
             <a:avLst/>
@@ -21988,17 +21988,17 @@
           <a:p>
             <a:pPr algn="l">
               <a:lnSpc>
-                <a:spcPct val="106000"/>
-              </a:lnSpc>
-              <a:spcBef>
-                <a:spcPts val="0"/>
-              </a:spcBef>
-              <a:spcAft>
-                <a:spcPts val="0"/>
-              </a:spcAft>
-            </a:pPr>
-            <a:r>
-              <a:rPr sz="1200" b="1">
+                <a:spcPct val="104000"/>
+              </a:lnSpc>
+              <a:spcBef>
+                <a:spcPts val="0"/>
+              </a:spcBef>
+              <a:spcAft>
+                <a:spcPts val="0"/>
+              </a:spcAft>
+            </a:pPr>
+            <a:r>
+              <a:rPr sz="1150" b="1">
                 <a:solidFill>
                   <a:srgbClr val="E60012"/>
                 </a:solidFill>
@@ -22011,17 +22011,17 @@
           <a:p>
             <a:pPr algn="l">
               <a:lnSpc>
-                <a:spcPct val="106000"/>
-              </a:lnSpc>
-              <a:spcBef>
-                <a:spcPts val="0"/>
-              </a:spcBef>
-              <a:spcAft>
-                <a:spcPts val="0"/>
-              </a:spcAft>
-            </a:pPr>
-            <a:r>
-              <a:rPr sz="750" b="0">
+                <a:spcPct val="104000"/>
+              </a:lnSpc>
+              <a:spcBef>
+                <a:spcPts val="0"/>
+              </a:spcBef>
+              <a:spcAft>
+                <a:spcPts val="0"/>
+              </a:spcAft>
+            </a:pPr>
+            <a:r>
+              <a:rPr sz="700" b="0">
                 <a:solidFill>
                   <a:srgbClr val="8A9098"/>
                 </a:solidFill>
@@ -22041,8 +22041,8 @@
         </p:nvSpPr>
         <p:spPr>
           <a:xfrm>
-            <a:off x="6739127" y="4919472"/>
-            <a:ext cx="1225295" cy="201168"/>
+            <a:off x="6729983" y="4206240"/>
+            <a:ext cx="1243584" cy="182880"/>
           </a:xfrm>
           <a:prstGeom prst="rect">
             <a:avLst/>
@@ -22067,7 +22067,7 @@
               </a:spcAft>
             </a:pPr>
             <a:r>
-              <a:rPr sz="750" b="1">
+              <a:rPr sz="700" b="1">
                 <a:solidFill>
                   <a:srgbClr val="8A9098"/>
                 </a:solidFill>
@@ -22087,8 +22087,8 @@
         </p:nvSpPr>
         <p:spPr>
           <a:xfrm>
-            <a:off x="6739127" y="5138928"/>
-            <a:ext cx="1225295" cy="749808"/>
+            <a:off x="6729983" y="4389120"/>
+            <a:ext cx="1243584" cy="603504"/>
           </a:xfrm>
           <a:prstGeom prst="rect">
             <a:avLst/>
@@ -22103,24 +22103,24 @@
           <a:p>
             <a:pPr algn="l">
               <a:lnSpc>
-                <a:spcPct val="122000"/>
-              </a:lnSpc>
-              <a:spcBef>
-                <a:spcPts val="0"/>
-              </a:spcBef>
-              <a:spcAft>
-                <a:spcPts val="400"/>
-              </a:spcAft>
-            </a:pPr>
-            <a:r>
-              <a:rPr sz="900" b="1">
+                <a:spcPct val="118000"/>
+              </a:lnSpc>
+              <a:spcBef>
+                <a:spcPts val="0"/>
+              </a:spcBef>
+              <a:spcAft>
+                <a:spcPts val="400"/>
+              </a:spcAft>
+            </a:pPr>
+            <a:r>
+              <a:rPr sz="880" b="1">
                 <a:solidFill>
                   <a:srgbClr val="1A1D21"/>
                 </a:solidFill>
                 <a:latin typeface="Noto Sans JP"/>
                 <a:ea typeface="Noto Sans JP"/>
               </a:rPr>
-              <a:t>ダイキン・GSユアサ・オイレス・エア・ウォーター</a:t>
+              <a:t>ダイキン・GSユアサ・オイレス</a:t>
             </a:r>
           </a:p>
         </p:txBody>
@@ -22133,8 +22133,8 @@
         </p:nvSpPr>
         <p:spPr>
           <a:xfrm>
-            <a:off x="8119872" y="1371600"/>
-            <a:ext cx="1719072" cy="896112"/>
+            <a:off x="8119872" y="1325880"/>
+            <a:ext cx="1719072" cy="822960"/>
           </a:xfrm>
           <a:prstGeom prst="chevron">
             <a:avLst/>
@@ -22175,8 +22175,8 @@
         </p:nvSpPr>
         <p:spPr>
           <a:xfrm>
-            <a:off x="8083296" y="1371600"/>
-            <a:ext cx="1664208" cy="896112"/>
+            <a:off x="8083296" y="1325880"/>
+            <a:ext cx="1664208" cy="822960"/>
           </a:xfrm>
           <a:prstGeom prst="rect">
             <a:avLst/>
@@ -22244,8 +22244,8 @@
         </p:nvSpPr>
         <p:spPr>
           <a:xfrm>
-            <a:off x="8183880" y="2432304"/>
-            <a:ext cx="1481328" cy="3511296"/>
+            <a:off x="8183880" y="2286000"/>
+            <a:ext cx="1481328" cy="2761488"/>
           </a:xfrm>
           <a:prstGeom prst="roundRect">
             <a:avLst>
@@ -22292,8 +22292,8 @@
         </p:nvSpPr>
         <p:spPr>
           <a:xfrm>
-            <a:off x="8311896" y="2560320"/>
-            <a:ext cx="1225295" cy="219456"/>
+            <a:off x="8302752" y="2386584"/>
+            <a:ext cx="1243584" cy="201168"/>
           </a:xfrm>
           <a:prstGeom prst="rect">
             <a:avLst/>
@@ -22338,8 +22338,8 @@
         </p:nvSpPr>
         <p:spPr>
           <a:xfrm>
-            <a:off x="8311896" y="2816352"/>
-            <a:ext cx="1225295" cy="274320"/>
+            <a:off x="8302752" y="2606040"/>
+            <a:ext cx="1243584" cy="256032"/>
           </a:xfrm>
           <a:prstGeom prst="rect">
             <a:avLst/>
@@ -22364,7 +22364,7 @@
               </a:spcAft>
             </a:pPr>
             <a:r>
-              <a:rPr sz="1150" b="1">
+              <a:rPr sz="1100" b="1">
                 <a:solidFill>
                   <a:srgbClr val="1A1D21"/>
                 </a:solidFill>
@@ -22384,8 +22384,8 @@
         </p:nvSpPr>
         <p:spPr>
           <a:xfrm>
-            <a:off x="8311896" y="3182112"/>
-            <a:ext cx="1225295" cy="914400"/>
+            <a:off x="8302752" y="2907792"/>
+            <a:ext cx="1243584" cy="603504"/>
           </a:xfrm>
           <a:prstGeom prst="rect">
             <a:avLst/>
@@ -22400,24 +22400,24 @@
           <a:p>
             <a:pPr algn="l">
               <a:lnSpc>
-                <a:spcPct val="116000"/>
-              </a:lnSpc>
-              <a:spcBef>
-                <a:spcPts val="0"/>
-              </a:spcBef>
-              <a:spcAft>
-                <a:spcPts val="400"/>
-              </a:spcAft>
-            </a:pPr>
-            <a:r>
-              <a:rPr sz="880" b="0">
+                <a:spcPct val="112000"/>
+              </a:lnSpc>
+              <a:spcBef>
+                <a:spcPts val="0"/>
+              </a:spcBef>
+              <a:spcAft>
+                <a:spcPts val="400"/>
+              </a:spcAft>
+            </a:pPr>
+            <a:r>
+              <a:rPr sz="850" b="0">
                 <a:solidFill>
                   <a:srgbClr val="3C4148"/>
                 </a:solidFill>
                 <a:latin typeface="Noto Sans JP"/>
                 <a:ea typeface="Noto Sans JP"/>
               </a:rPr>
-              <a:t>AIチップ本体は海外勢が強いが、装置・材料で日本が世界的シェア。</a:t>
+              <a:t>チップは海外勢。装置・材料で日本が強い。</a:t>
             </a:r>
           </a:p>
         </p:txBody>
@@ -22430,8 +22430,8 @@
         </p:nvSpPr>
         <p:spPr>
           <a:xfrm>
-            <a:off x="8311896" y="4133088"/>
-            <a:ext cx="1225295" cy="9144"/>
+            <a:off x="8302752" y="3566160"/>
+            <a:ext cx="1243584" cy="9144"/>
           </a:xfrm>
           <a:prstGeom prst="rect">
             <a:avLst/>
@@ -22474,8 +22474,8 @@
         </p:nvSpPr>
         <p:spPr>
           <a:xfrm>
-            <a:off x="8311896" y="4224528"/>
-            <a:ext cx="1225295" cy="603504"/>
+            <a:off x="8302752" y="3639312"/>
+            <a:ext cx="1243584" cy="530352"/>
           </a:xfrm>
           <a:prstGeom prst="rect">
             <a:avLst/>
@@ -22490,17 +22490,17 @@
           <a:p>
             <a:pPr algn="l">
               <a:lnSpc>
-                <a:spcPct val="106000"/>
-              </a:lnSpc>
-              <a:spcBef>
-                <a:spcPts val="0"/>
-              </a:spcBef>
-              <a:spcAft>
-                <a:spcPts val="0"/>
-              </a:spcAft>
-            </a:pPr>
-            <a:r>
-              <a:rPr sz="1200" b="1">
+                <a:spcPct val="104000"/>
+              </a:lnSpc>
+              <a:spcBef>
+                <a:spcPts val="0"/>
+              </a:spcBef>
+              <a:spcAft>
+                <a:spcPts val="0"/>
+              </a:spcAft>
+            </a:pPr>
+            <a:r>
+              <a:rPr sz="1150" b="1">
                 <a:solidFill>
                   <a:srgbClr val="E60012"/>
                 </a:solidFill>
@@ -22513,17 +22513,17 @@
           <a:p>
             <a:pPr algn="l">
               <a:lnSpc>
-                <a:spcPct val="106000"/>
-              </a:lnSpc>
-              <a:spcBef>
-                <a:spcPts val="0"/>
-              </a:spcBef>
-              <a:spcAft>
-                <a:spcPts val="0"/>
-              </a:spcAft>
-            </a:pPr>
-            <a:r>
-              <a:rPr sz="750" b="0">
+                <a:spcPct val="104000"/>
+              </a:lnSpc>
+              <a:spcBef>
+                <a:spcPts val="0"/>
+              </a:spcBef>
+              <a:spcAft>
+                <a:spcPts val="0"/>
+              </a:spcAft>
+            </a:pPr>
+            <a:r>
+              <a:rPr sz="700" b="0">
                 <a:solidFill>
                   <a:srgbClr val="8A9098"/>
                 </a:solidFill>
@@ -22543,8 +22543,8 @@
         </p:nvSpPr>
         <p:spPr>
           <a:xfrm>
-            <a:off x="8311896" y="4919472"/>
-            <a:ext cx="1225295" cy="201168"/>
+            <a:off x="8302752" y="4206240"/>
+            <a:ext cx="1243584" cy="182880"/>
           </a:xfrm>
           <a:prstGeom prst="rect">
             <a:avLst/>
@@ -22569,7 +22569,7 @@
               </a:spcAft>
             </a:pPr>
             <a:r>
-              <a:rPr sz="750" b="1">
+              <a:rPr sz="700" b="1">
                 <a:solidFill>
                   <a:srgbClr val="8A9098"/>
                 </a:solidFill>
@@ -22589,8 +22589,8 @@
         </p:nvSpPr>
         <p:spPr>
           <a:xfrm>
-            <a:off x="8311896" y="5138928"/>
-            <a:ext cx="1225295" cy="749808"/>
+            <a:off x="8302752" y="4389120"/>
+            <a:ext cx="1243584" cy="603504"/>
           </a:xfrm>
           <a:prstGeom prst="rect">
             <a:avLst/>
@@ -22605,24 +22605,24 @@
           <a:p>
             <a:pPr algn="l">
               <a:lnSpc>
-                <a:spcPct val="122000"/>
-              </a:lnSpc>
-              <a:spcBef>
-                <a:spcPts val="0"/>
-              </a:spcBef>
-              <a:spcAft>
-                <a:spcPts val="400"/>
-              </a:spcAft>
-            </a:pPr>
-            <a:r>
-              <a:rPr sz="900" b="1">
+                <a:spcPct val="118000"/>
+              </a:lnSpc>
+              <a:spcBef>
+                <a:spcPts val="0"/>
+              </a:spcBef>
+              <a:spcAft>
+                <a:spcPts val="400"/>
+              </a:spcAft>
+            </a:pPr>
+            <a:r>
+              <a:rPr sz="880" b="1">
                 <a:solidFill>
                   <a:srgbClr val="1A1D21"/>
                 </a:solidFill>
                 <a:latin typeface="Noto Sans JP"/>
                 <a:ea typeface="Noto Sans JP"/>
               </a:rPr>
-              <a:t>東京エレクトロン・ディスコ・信越化学・キオクシア</a:t>
+              <a:t>東京ｴﾚｸﾄﾛﾝ・ディスコ・信越化学</a:t>
             </a:r>
           </a:p>
         </p:txBody>
@@ -22635,8 +22635,489 @@
         </p:nvSpPr>
         <p:spPr>
           <a:xfrm>
-            <a:off x="777240" y="5989320"/>
-            <a:ext cx="10634472" cy="457200"/>
+            <a:off x="777240" y="5175504"/>
+            <a:ext cx="10634472" cy="969264"/>
+          </a:xfrm>
+          <a:prstGeom prst="roundRect">
+            <a:avLst>
+              <a:gd name="adj" fmla="val 5000"/>
+            </a:avLst>
+          </a:prstGeom>
+          <a:solidFill>
+            <a:srgbClr val="FDECEE"/>
+          </a:solidFill>
+          <a:ln w="15240">
+            <a:solidFill>
+              <a:srgbClr val="F3C7CD"/>
+            </a:solidFill>
+          </a:ln>
+          <a:effectLst/>
+        </p:spPr>
+        <p:style>
+          <a:lnRef idx="1">
+            <a:schemeClr val="accent1"/>
+          </a:lnRef>
+          <a:fillRef idx="3">
+            <a:schemeClr val="accent1"/>
+          </a:fillRef>
+          <a:effectRef idx="2">
+            <a:schemeClr val="accent1"/>
+          </a:effectRef>
+          <a:fontRef idx="minor">
+            <a:schemeClr val="lt1"/>
+          </a:fontRef>
+        </p:style>
+        <p:txBody>
+          <a:bodyPr rtlCol="0" anchor="ctr"/>
+          <a:lstStyle/>
+          <a:p>
+            <a:pPr algn="ctr"/>
+          </a:p>
+        </p:txBody>
+      </p:sp>
+      <p:sp>
+        <p:nvSpPr>
+          <p:cNvPr id="63" name="Rounded Rectangle 62"/>
+          <p:cNvSpPr/>
+          <p:nvPr/>
+        </p:nvSpPr>
+        <p:spPr>
+          <a:xfrm>
+            <a:off x="777240" y="5175504"/>
+            <a:ext cx="1737360" cy="969264"/>
+          </a:xfrm>
+          <a:prstGeom prst="roundRect">
+            <a:avLst>
+              <a:gd name="adj" fmla="val 5000"/>
+            </a:avLst>
+          </a:prstGeom>
+          <a:solidFill>
+            <a:srgbClr val="E60012"/>
+          </a:solidFill>
+          <a:ln>
+            <a:noFill/>
+          </a:ln>
+          <a:effectLst/>
+        </p:spPr>
+        <p:style>
+          <a:lnRef idx="1">
+            <a:schemeClr val="accent1"/>
+          </a:lnRef>
+          <a:fillRef idx="3">
+            <a:schemeClr val="accent1"/>
+          </a:fillRef>
+          <a:effectRef idx="2">
+            <a:schemeClr val="accent1"/>
+          </a:effectRef>
+          <a:fontRef idx="minor">
+            <a:schemeClr val="lt1"/>
+          </a:fontRef>
+        </p:style>
+        <p:txBody>
+          <a:bodyPr rtlCol="0" anchor="ctr"/>
+          <a:lstStyle/>
+          <a:p>
+            <a:pPr algn="ctr"/>
+          </a:p>
+        </p:txBody>
+      </p:sp>
+      <p:sp>
+        <p:nvSpPr>
+          <p:cNvPr id="64" name="TextBox 63"/>
+          <p:cNvSpPr txBox="1"/>
+          <p:nvPr/>
+        </p:nvSpPr>
+        <p:spPr>
+          <a:xfrm>
+            <a:off x="868680" y="5175504"/>
+            <a:ext cx="1572768" cy="969264"/>
+          </a:xfrm>
+          <a:prstGeom prst="rect">
+            <a:avLst/>
+          </a:prstGeom>
+          <a:noFill/>
+        </p:spPr>
+        <p:txBody>
+          <a:bodyPr wrap="square" anchor="ctr" lIns="0" rIns="0" tIns="0" bIns="0">
+            <a:spAutoFit/>
+          </a:bodyPr>
+          <a:lstStyle/>
+          <a:p>
+            <a:pPr algn="ctr">
+              <a:lnSpc>
+                <a:spcPct val="102000"/>
+              </a:lnSpc>
+              <a:spcBef>
+                <a:spcPts val="0"/>
+              </a:spcBef>
+              <a:spcAft>
+                <a:spcPts val="100"/>
+              </a:spcAft>
+            </a:pPr>
+            <a:r>
+              <a:rPr sz="1200" b="1" spc="100">
+                <a:solidFill>
+                  <a:srgbClr val="FFC9CE"/>
+                </a:solidFill>
+                <a:latin typeface="Consolas"/>
+                <a:ea typeface="Consolas"/>
+              </a:rPr>
+              <a:t>06</a:t>
+            </a:r>
+          </a:p>
+          <a:p>
+            <a:pPr algn="ctr">
+              <a:lnSpc>
+                <a:spcPct val="102000"/>
+              </a:lnSpc>
+              <a:spcBef>
+                <a:spcPts val="0"/>
+              </a:spcBef>
+              <a:spcAft>
+                <a:spcPts val="100"/>
+              </a:spcAft>
+            </a:pPr>
+            <a:r>
+              <a:rPr sz="1100" b="1">
+                <a:solidFill>
+                  <a:srgbClr val="FFFFFF"/>
+                </a:solidFill>
+                <a:latin typeface="Noto Sans JP"/>
+                <a:ea typeface="Noto Sans JP"/>
+              </a:rPr>
+              <a:t>部品・材料・ガス</a:t>
+            </a:r>
+          </a:p>
+          <a:p>
+            <a:pPr algn="ctr">
+              <a:lnSpc>
+                <a:spcPct val="102000"/>
+              </a:lnSpc>
+              <a:spcBef>
+                <a:spcPts val="0"/>
+              </a:spcBef>
+              <a:spcAft>
+                <a:spcPts val="100"/>
+              </a:spcAft>
+            </a:pPr>
+            <a:r>
+              <a:rPr sz="800" b="0">
+                <a:solidFill>
+                  <a:srgbClr val="FFE2E5"/>
+                </a:solidFill>
+                <a:latin typeface="Noto Sans JP"/>
+                <a:ea typeface="Noto Sans JP"/>
+              </a:rPr>
+              <a:t>全体を支える基盤層</a:t>
+            </a:r>
+          </a:p>
+        </p:txBody>
+      </p:sp>
+      <p:sp>
+        <p:nvSpPr>
+          <p:cNvPr id="65" name="TextBox 64"/>
+          <p:cNvSpPr txBox="1"/>
+          <p:nvPr/>
+        </p:nvSpPr>
+        <p:spPr>
+          <a:xfrm>
+            <a:off x="2734056" y="5294376"/>
+            <a:ext cx="2734056" cy="731520"/>
+          </a:xfrm>
+          <a:prstGeom prst="rect">
+            <a:avLst/>
+          </a:prstGeom>
+          <a:noFill/>
+        </p:spPr>
+        <p:txBody>
+          <a:bodyPr wrap="square" anchor="t" lIns="0" rIns="0" tIns="0" bIns="0">
+            <a:spAutoFit/>
+          </a:bodyPr>
+          <a:lstStyle/>
+          <a:p>
+            <a:pPr algn="l">
+              <a:lnSpc>
+                <a:spcPct val="118000"/>
+              </a:lnSpc>
+              <a:spcBef>
+                <a:spcPts val="0"/>
+              </a:spcBef>
+              <a:spcAft>
+                <a:spcPts val="200"/>
+              </a:spcAft>
+            </a:pPr>
+            <a:r>
+              <a:rPr sz="850" b="1">
+                <a:solidFill>
+                  <a:srgbClr val="E60012"/>
+                </a:solidFill>
+                <a:latin typeface="Consolas"/>
+                <a:ea typeface="Consolas"/>
+              </a:rPr>
+              <a:t>装置部品・サブシステム</a:t>
+            </a:r>
+          </a:p>
+          <a:p>
+            <a:pPr algn="l">
+              <a:lnSpc>
+                <a:spcPct val="118000"/>
+              </a:lnSpc>
+              <a:spcBef>
+                <a:spcPts val="0"/>
+              </a:spcBef>
+              <a:spcAft>
+                <a:spcPts val="200"/>
+              </a:spcAft>
+            </a:pPr>
+            <a:r>
+              <a:rPr sz="950" b="1">
+                <a:solidFill>
+                  <a:srgbClr val="1A1D21"/>
+                </a:solidFill>
+                <a:latin typeface="Noto Sans JP"/>
+                <a:ea typeface="Noto Sans JP"/>
+              </a:rPr>
+              <a:t>SMC・堀場製作所・アドバンテスト・日本ピラー・ダイフク</a:t>
+            </a:r>
+          </a:p>
+        </p:txBody>
+      </p:sp>
+      <p:sp>
+        <p:nvSpPr>
+          <p:cNvPr id="66" name="Rectangle 65"/>
+          <p:cNvSpPr/>
+          <p:nvPr/>
+        </p:nvSpPr>
+        <p:spPr>
+          <a:xfrm>
+            <a:off x="5541264" y="5321808"/>
+            <a:ext cx="10972" cy="676656"/>
+          </a:xfrm>
+          <a:prstGeom prst="rect">
+            <a:avLst/>
+          </a:prstGeom>
+          <a:solidFill>
+            <a:srgbClr val="F3C7CD"/>
+          </a:solidFill>
+          <a:ln>
+            <a:noFill/>
+          </a:ln>
+          <a:effectLst/>
+        </p:spPr>
+        <p:style>
+          <a:lnRef idx="1">
+            <a:schemeClr val="accent1"/>
+          </a:lnRef>
+          <a:fillRef idx="3">
+            <a:schemeClr val="accent1"/>
+          </a:fillRef>
+          <a:effectRef idx="2">
+            <a:schemeClr val="accent1"/>
+          </a:effectRef>
+          <a:fontRef idx="minor">
+            <a:schemeClr val="lt1"/>
+          </a:fontRef>
+        </p:style>
+        <p:txBody>
+          <a:bodyPr rtlCol="0" anchor="ctr"/>
+          <a:lstStyle/>
+          <a:p>
+            <a:pPr algn="ctr"/>
+          </a:p>
+        </p:txBody>
+      </p:sp>
+      <p:sp>
+        <p:nvSpPr>
+          <p:cNvPr id="67" name="TextBox 66"/>
+          <p:cNvSpPr txBox="1"/>
+          <p:nvPr/>
+        </p:nvSpPr>
+        <p:spPr>
+          <a:xfrm>
+            <a:off x="5614416" y="5294376"/>
+            <a:ext cx="2734056" cy="731520"/>
+          </a:xfrm>
+          <a:prstGeom prst="rect">
+            <a:avLst/>
+          </a:prstGeom>
+          <a:noFill/>
+        </p:spPr>
+        <p:txBody>
+          <a:bodyPr wrap="square" anchor="t" lIns="0" rIns="0" tIns="0" bIns="0">
+            <a:spAutoFit/>
+          </a:bodyPr>
+          <a:lstStyle/>
+          <a:p>
+            <a:pPr algn="l">
+              <a:lnSpc>
+                <a:spcPct val="118000"/>
+              </a:lnSpc>
+              <a:spcBef>
+                <a:spcPts val="0"/>
+              </a:spcBef>
+              <a:spcAft>
+                <a:spcPts val="200"/>
+              </a:spcAft>
+            </a:pPr>
+            <a:r>
+              <a:rPr sz="850" b="1">
+                <a:solidFill>
+                  <a:srgbClr val="E60012"/>
+                </a:solidFill>
+                <a:latin typeface="Consolas"/>
+                <a:ea typeface="Consolas"/>
+              </a:rPr>
+              <a:t>電子部品・パッケージ基板</a:t>
+            </a:r>
+          </a:p>
+          <a:p>
+            <a:pPr algn="l">
+              <a:lnSpc>
+                <a:spcPct val="118000"/>
+              </a:lnSpc>
+              <a:spcBef>
+                <a:spcPts val="0"/>
+              </a:spcBef>
+              <a:spcAft>
+                <a:spcPts val="200"/>
+              </a:spcAft>
+            </a:pPr>
+            <a:r>
+              <a:rPr sz="950" b="1">
+                <a:solidFill>
+                  <a:srgbClr val="1A1D21"/>
+                </a:solidFill>
+                <a:latin typeface="Noto Sans JP"/>
+                <a:ea typeface="Noto Sans JP"/>
+              </a:rPr>
+              <a:t>村田製作所・太陽誘電・TDK・イビデン・新光電気</a:t>
+            </a:r>
+          </a:p>
+        </p:txBody>
+      </p:sp>
+      <p:sp>
+        <p:nvSpPr>
+          <p:cNvPr id="68" name="Rectangle 67"/>
+          <p:cNvSpPr/>
+          <p:nvPr/>
+        </p:nvSpPr>
+        <p:spPr>
+          <a:xfrm>
+            <a:off x="8421624" y="5321808"/>
+            <a:ext cx="10972" cy="676656"/>
+          </a:xfrm>
+          <a:prstGeom prst="rect">
+            <a:avLst/>
+          </a:prstGeom>
+          <a:solidFill>
+            <a:srgbClr val="F3C7CD"/>
+          </a:solidFill>
+          <a:ln>
+            <a:noFill/>
+          </a:ln>
+          <a:effectLst/>
+        </p:spPr>
+        <p:style>
+          <a:lnRef idx="1">
+            <a:schemeClr val="accent1"/>
+          </a:lnRef>
+          <a:fillRef idx="3">
+            <a:schemeClr val="accent1"/>
+          </a:fillRef>
+          <a:effectRef idx="2">
+            <a:schemeClr val="accent1"/>
+          </a:effectRef>
+          <a:fontRef idx="minor">
+            <a:schemeClr val="lt1"/>
+          </a:fontRef>
+        </p:style>
+        <p:txBody>
+          <a:bodyPr rtlCol="0" anchor="ctr"/>
+          <a:lstStyle/>
+          <a:p>
+            <a:pPr algn="ctr"/>
+          </a:p>
+        </p:txBody>
+      </p:sp>
+      <p:sp>
+        <p:nvSpPr>
+          <p:cNvPr id="69" name="TextBox 68"/>
+          <p:cNvSpPr txBox="1"/>
+          <p:nvPr/>
+        </p:nvSpPr>
+        <p:spPr>
+          <a:xfrm>
+            <a:off x="8494776" y="5294376"/>
+            <a:ext cx="2734056" cy="731520"/>
+          </a:xfrm>
+          <a:prstGeom prst="rect">
+            <a:avLst/>
+          </a:prstGeom>
+          <a:noFill/>
+        </p:spPr>
+        <p:txBody>
+          <a:bodyPr wrap="square" anchor="t" lIns="0" rIns="0" tIns="0" bIns="0">
+            <a:spAutoFit/>
+          </a:bodyPr>
+          <a:lstStyle/>
+          <a:p>
+            <a:pPr algn="l">
+              <a:lnSpc>
+                <a:spcPct val="118000"/>
+              </a:lnSpc>
+              <a:spcBef>
+                <a:spcPts val="0"/>
+              </a:spcBef>
+              <a:spcAft>
+                <a:spcPts val="200"/>
+              </a:spcAft>
+            </a:pPr>
+            <a:r>
+              <a:rPr sz="850" b="1">
+                <a:solidFill>
+                  <a:srgbClr val="E60012"/>
+                </a:solidFill>
+                <a:latin typeface="Consolas"/>
+                <a:ea typeface="Consolas"/>
+              </a:rPr>
+              <a:t>産業/特殊ガス・前駆体材料</a:t>
+            </a:r>
+          </a:p>
+          <a:p>
+            <a:pPr algn="l">
+              <a:lnSpc>
+                <a:spcPct val="118000"/>
+              </a:lnSpc>
+              <a:spcBef>
+                <a:spcPts val="0"/>
+              </a:spcBef>
+              <a:spcAft>
+                <a:spcPts val="200"/>
+              </a:spcAft>
+            </a:pPr>
+            <a:r>
+              <a:rPr sz="950" b="1">
+                <a:solidFill>
+                  <a:srgbClr val="1A1D21"/>
+                </a:solidFill>
+                <a:latin typeface="Noto Sans JP"/>
+                <a:ea typeface="Noto Sans JP"/>
+              </a:rPr>
+              <a:t>日本酸素HD・関東電化工業・トリケミカル研究所</a:t>
+            </a:r>
+          </a:p>
+        </p:txBody>
+      </p:sp>
+      <p:sp>
+        <p:nvSpPr>
+          <p:cNvPr id="70" name="Rounded Rectangle 69"/>
+          <p:cNvSpPr/>
+          <p:nvPr/>
+        </p:nvSpPr>
+        <p:spPr>
+          <a:xfrm>
+            <a:off x="777240" y="6272784"/>
+            <a:ext cx="10634472" cy="402336"/>
           </a:xfrm>
           <a:prstGeom prst="roundRect">
             <a:avLst>
@@ -22677,14 +23158,14 @@
       </p:sp>
       <p:sp>
         <p:nvSpPr>
-          <p:cNvPr id="63" name="TextBox 62"/>
-          <p:cNvSpPr txBox="1"/>
-          <p:nvPr/>
-        </p:nvSpPr>
-        <p:spPr>
-          <a:xfrm>
-            <a:off x="1005840" y="5989320"/>
-            <a:ext cx="10241280" cy="457200"/>
+          <p:cNvPr id="71" name="TextBox 70"/>
+          <p:cNvSpPr txBox="1"/>
+          <p:nvPr/>
+        </p:nvSpPr>
+        <p:spPr>
+          <a:xfrm>
+            <a:off x="1005840" y="6272784"/>
+            <a:ext cx="10241280" cy="402336"/>
           </a:xfrm>
           <a:prstGeom prst="rect">
             <a:avLst/>
@@ -22709,7 +23190,7 @@
               </a:spcAft>
             </a:pPr>
             <a:r>
-              <a:rPr sz="1000" b="1">
+              <a:rPr sz="950" b="1">
                 <a:solidFill>
                   <a:srgbClr val="8A9098"/>
                 </a:solidFill>
@@ -22719,7 +23200,7 @@
               <a:t>現場管理の入り方：</a:t>
             </a:r>
             <a:r>
-              <a:rPr sz="1050" b="1">
+              <a:rPr sz="1000" b="1">
                 <a:solidFill>
                   <a:srgbClr val="454B54"/>
                 </a:solidFill>
@@ -22729,7 +23210,7 @@
               <a:t> A 発注者＝自社の設備投資を建てる側で管理</a:t>
             </a:r>
             <a:r>
-              <a:rPr sz="1000" b="0">
+              <a:rPr sz="950" b="0">
                 <a:solidFill>
                   <a:srgbClr val="8A9098"/>
                 </a:solidFill>
@@ -22739,7 +23220,7 @@
               <a:t>　／　</a:t>
             </a:r>
             <a:r>
-              <a:rPr sz="1050" b="1">
+              <a:rPr sz="1000" b="1">
                 <a:solidFill>
                   <a:srgbClr val="E60012"/>
                 </a:solidFill>
@@ -22749,7 +23230,7 @@
               <a:t>B 請負＝据付・試運転・保守を納める側で管理</a:t>
             </a:r>
             <a:r>
-              <a:rPr sz="900" b="0">
+              <a:rPr sz="850" b="0">
                 <a:solidFill>
                   <a:srgbClr val="8A9098"/>
                 </a:solidFill>
@@ -22757,62 +23238,6 @@
                 <a:ea typeface="Noto Sans JP"/>
               </a:rPr>
               <a:t>　※各段階は代表企業のみ</a:t>
-            </a:r>
-          </a:p>
-        </p:txBody>
-      </p:sp>
-      <p:sp>
-        <p:nvSpPr>
-          <p:cNvPr id="64" name="TextBox 63"/>
-          <p:cNvSpPr txBox="1"/>
-          <p:nvPr/>
-        </p:nvSpPr>
-        <p:spPr>
-          <a:xfrm>
-            <a:off x="822960" y="6510528"/>
-            <a:ext cx="10515600" cy="256032"/>
-          </a:xfrm>
-          <a:prstGeom prst="rect">
-            <a:avLst/>
-          </a:prstGeom>
-          <a:noFill/>
-        </p:spPr>
-        <p:txBody>
-          <a:bodyPr wrap="square" anchor="t" lIns="0" rIns="0" tIns="0" bIns="0">
-            <a:spAutoFit/>
-          </a:bodyPr>
-          <a:lstStyle/>
-          <a:p>
-            <a:pPr algn="l">
-              <a:lnSpc>
-                <a:spcPct val="106000"/>
-              </a:lnSpc>
-              <a:spcBef>
-                <a:spcPts val="0"/>
-              </a:spcBef>
-              <a:spcAft>
-                <a:spcPts val="400"/>
-              </a:spcAft>
-            </a:pPr>
-            <a:r>
-              <a:rPr sz="900" b="1">
-                <a:solidFill>
-                  <a:srgbClr val="E60012"/>
-                </a:solidFill>
-                <a:latin typeface="Consolas"/>
-                <a:ea typeface="Consolas"/>
-              </a:rPr>
-              <a:t>さらに川下へ波及：</a:t>
-            </a:r>
-            <a:r>
-              <a:rPr sz="900" b="0">
-                <a:solidFill>
-                  <a:srgbClr val="3C4148"/>
-                </a:solidFill>
-                <a:latin typeface="Noto Sans JP"/>
-                <a:ea typeface="Noto Sans JP"/>
-              </a:rPr>
-              <a:t>半導体製造装置の部品（SMC・堀場・アドバンテスト等）／電子部品・パッケージ基板（村田・イビデン等）／産業ガスにも拡大 → 付録参照</a:t>
             </a:r>
           </a:p>
         </p:txBody>

</xml_diff>

<commit_message>
Add SEG017 (DC construction SI / DC operators) and reflect in outputs
Integrate the "build the IT inside the box → operate" layer (SEG017,
8 companies) as the flow's final step before service go-live in both
the flow HTML and deck slide 2, relabel the parts/materials/gas band
as a SUPPORT layer, add a領域07 appendix slide, and regenerate the
master xlsx (153 companies). Pure IT distributors/software SI are
documented as out-of-scope for ANDPAD targeting.

Co-Authored-By: Claude Sonnet 5 <noreply@anthropic.com>
Claude-Session: https://claude.ai/code/session_017hVm54qQ8iaGNRYcCDuKBy
</commit_message>
<xml_diff>
--- a/output/andpad_ai_opportunity_deck.pptx
+++ b/output/andpad_ai_opportunity_deck.pptx
@@ -21,6 +21,7 @@
     <p:sldId id="269" r:id="rId20"/>
     <p:sldId id="270" r:id="rId21"/>
     <p:sldId id="271" r:id="rId22"/>
+    <p:sldId id="272" r:id="rId23"/>
   </p:sldIdLst>
   <p:sldSz cx="12191695" cy="6858000" type="screen4x3"/>
   <p:notesSz cx="6858000" cy="9144000"/>
@@ -19559,6 +19560,2466 @@
 </p:sld>
 </file>
 
+<file path=ppt/slides/slide17.xml><?xml version="1.0" encoding="utf-8"?>
+<p:sld xmlns:a="http://schemas.openxmlformats.org/drawingml/2006/main" xmlns:p="http://schemas.openxmlformats.org/presentationml/2006/main" xmlns:r="http://schemas.openxmlformats.org/officeDocument/2006/relationships">
+  <p:cSld>
+    <p:spTree>
+      <p:nvGrpSpPr>
+        <p:cNvPr id="1" name=""/>
+        <p:cNvGrpSpPr/>
+        <p:nvPr/>
+      </p:nvGrpSpPr>
+      <p:grpSpPr/>
+      <p:sp>
+        <p:nvSpPr>
+          <p:cNvPr id="2" name="Rectangle 1"/>
+          <p:cNvSpPr/>
+          <p:nvPr/>
+        </p:nvSpPr>
+        <p:spPr>
+          <a:xfrm>
+            <a:off x="0" y="0"/>
+            <a:ext cx="12191695" cy="6858000"/>
+          </a:xfrm>
+          <a:prstGeom prst="rect">
+            <a:avLst/>
+          </a:prstGeom>
+          <a:solidFill>
+            <a:srgbClr val="FFFFFF"/>
+          </a:solidFill>
+          <a:ln>
+            <a:noFill/>
+          </a:ln>
+          <a:effectLst/>
+        </p:spPr>
+        <p:style>
+          <a:lnRef idx="1">
+            <a:schemeClr val="accent1"/>
+          </a:lnRef>
+          <a:fillRef idx="3">
+            <a:schemeClr val="accent1"/>
+          </a:fillRef>
+          <a:effectRef idx="2">
+            <a:schemeClr val="accent1"/>
+          </a:effectRef>
+          <a:fontRef idx="minor">
+            <a:schemeClr val="lt1"/>
+          </a:fontRef>
+        </p:style>
+        <p:txBody>
+          <a:bodyPr rtlCol="0" anchor="ctr"/>
+          <a:lstStyle/>
+          <a:p>
+            <a:pPr algn="ctr"/>
+          </a:p>
+        </p:txBody>
+      </p:sp>
+      <p:sp>
+        <p:nvSpPr>
+          <p:cNvPr id="3" name="Rounded Rectangle 2"/>
+          <p:cNvSpPr/>
+          <p:nvPr/>
+        </p:nvSpPr>
+        <p:spPr>
+          <a:xfrm>
+            <a:off x="777240" y="457200"/>
+            <a:ext cx="475488" cy="475488"/>
+          </a:xfrm>
+          <a:prstGeom prst="roundRect">
+            <a:avLst>
+              <a:gd name="adj" fmla="val 18000"/>
+            </a:avLst>
+          </a:prstGeom>
+          <a:solidFill>
+            <a:srgbClr val="E60012"/>
+          </a:solidFill>
+          <a:ln>
+            <a:noFill/>
+          </a:ln>
+          <a:effectLst/>
+        </p:spPr>
+        <p:style>
+          <a:lnRef idx="1">
+            <a:schemeClr val="accent1"/>
+          </a:lnRef>
+          <a:fillRef idx="3">
+            <a:schemeClr val="accent1"/>
+          </a:fillRef>
+          <a:effectRef idx="2">
+            <a:schemeClr val="accent1"/>
+          </a:effectRef>
+          <a:fontRef idx="minor">
+            <a:schemeClr val="lt1"/>
+          </a:fontRef>
+        </p:style>
+        <p:txBody>
+          <a:bodyPr rtlCol="0" anchor="ctr"/>
+          <a:lstStyle/>
+          <a:p>
+            <a:pPr algn="ctr"/>
+          </a:p>
+        </p:txBody>
+      </p:sp>
+      <p:sp>
+        <p:nvSpPr>
+          <p:cNvPr id="4" name="TextBox 3"/>
+          <p:cNvSpPr txBox="1"/>
+          <p:nvPr/>
+        </p:nvSpPr>
+        <p:spPr>
+          <a:xfrm>
+            <a:off x="777240" y="457200"/>
+            <a:ext cx="475488" cy="475488"/>
+          </a:xfrm>
+          <a:prstGeom prst="rect">
+            <a:avLst/>
+          </a:prstGeom>
+          <a:noFill/>
+        </p:spPr>
+        <p:txBody>
+          <a:bodyPr wrap="square" anchor="ctr" lIns="0" rIns="0" tIns="0" bIns="0">
+            <a:spAutoFit/>
+          </a:bodyPr>
+          <a:lstStyle/>
+          <a:p>
+            <a:pPr algn="ctr">
+              <a:lnSpc>
+                <a:spcPct val="106000"/>
+              </a:lnSpc>
+              <a:spcBef>
+                <a:spcPts val="0"/>
+              </a:spcBef>
+              <a:spcAft>
+                <a:spcPts val="400"/>
+              </a:spcAft>
+            </a:pPr>
+            <a:r>
+              <a:rPr sz="1500" b="1">
+                <a:solidFill>
+                  <a:srgbClr val="FFFFFF"/>
+                </a:solidFill>
+                <a:latin typeface="Consolas"/>
+                <a:ea typeface="Consolas"/>
+              </a:rPr>
+              <a:t>参</a:t>
+            </a:r>
+          </a:p>
+        </p:txBody>
+      </p:sp>
+      <p:sp>
+        <p:nvSpPr>
+          <p:cNvPr id="5" name="TextBox 4"/>
+          <p:cNvSpPr txBox="1"/>
+          <p:nvPr/>
+        </p:nvSpPr>
+        <p:spPr>
+          <a:xfrm>
+            <a:off x="1417320" y="457200"/>
+            <a:ext cx="10058400" cy="256032"/>
+          </a:xfrm>
+          <a:prstGeom prst="rect">
+            <a:avLst/>
+          </a:prstGeom>
+          <a:noFill/>
+        </p:spPr>
+        <p:txBody>
+          <a:bodyPr wrap="square" anchor="t" lIns="0" rIns="0" tIns="0" bIns="0">
+            <a:spAutoFit/>
+          </a:bodyPr>
+          <a:lstStyle/>
+          <a:p>
+            <a:pPr algn="l">
+              <a:lnSpc>
+                <a:spcPct val="106000"/>
+              </a:lnSpc>
+              <a:spcBef>
+                <a:spcPts val="0"/>
+              </a:spcBef>
+              <a:spcAft>
+                <a:spcPts val="400"/>
+              </a:spcAft>
+            </a:pPr>
+            <a:r>
+              <a:rPr sz="1100" b="1" spc="150">
+                <a:solidFill>
+                  <a:srgbClr val="E60012"/>
+                </a:solidFill>
+                <a:latin typeface="Consolas"/>
+                <a:ea typeface="Consolas"/>
+              </a:rPr>
+              <a:t>領域07 ・ DC構築・ITインフラSI／DC運営</a:t>
+            </a:r>
+          </a:p>
+        </p:txBody>
+      </p:sp>
+      <p:sp>
+        <p:nvSpPr>
+          <p:cNvPr id="6" name="TextBox 5"/>
+          <p:cNvSpPr txBox="1"/>
+          <p:nvPr/>
+        </p:nvSpPr>
+        <p:spPr>
+          <a:xfrm>
+            <a:off x="1399032" y="676656"/>
+            <a:ext cx="10241280" cy="457200"/>
+          </a:xfrm>
+          <a:prstGeom prst="rect">
+            <a:avLst/>
+          </a:prstGeom>
+          <a:noFill/>
+        </p:spPr>
+        <p:txBody>
+          <a:bodyPr wrap="square" anchor="t" lIns="0" rIns="0" tIns="0" bIns="0">
+            <a:spAutoFit/>
+          </a:bodyPr>
+          <a:lstStyle/>
+          <a:p>
+            <a:pPr algn="l">
+              <a:lnSpc>
+                <a:spcPct val="106000"/>
+              </a:lnSpc>
+              <a:spcBef>
+                <a:spcPts val="0"/>
+              </a:spcBef>
+              <a:spcAft>
+                <a:spcPts val="400"/>
+              </a:spcAft>
+            </a:pPr>
+            <a:r>
+              <a:rPr sz="2100" b="1">
+                <a:solidFill>
+                  <a:srgbClr val="1A1D21"/>
+                </a:solidFill>
+                <a:latin typeface="Noto Sans JP"/>
+                <a:ea typeface="Noto Sans JP"/>
+              </a:rPr>
+              <a:t>箱の中身を構築し“稼働”へ — 建屋完成〜サービス稼働の橋渡し</a:t>
+            </a:r>
+          </a:p>
+        </p:txBody>
+      </p:sp>
+      <p:sp>
+        <p:nvSpPr>
+          <p:cNvPr id="7" name="Rectangle 6"/>
+          <p:cNvSpPr/>
+          <p:nvPr/>
+        </p:nvSpPr>
+        <p:spPr>
+          <a:xfrm>
+            <a:off x="777240" y="1170432"/>
+            <a:ext cx="10634472" cy="18288"/>
+          </a:xfrm>
+          <a:prstGeom prst="rect">
+            <a:avLst/>
+          </a:prstGeom>
+          <a:solidFill>
+            <a:srgbClr val="E2E4E9"/>
+          </a:solidFill>
+          <a:ln>
+            <a:noFill/>
+          </a:ln>
+          <a:effectLst/>
+        </p:spPr>
+        <p:style>
+          <a:lnRef idx="1">
+            <a:schemeClr val="accent1"/>
+          </a:lnRef>
+          <a:fillRef idx="3">
+            <a:schemeClr val="accent1"/>
+          </a:fillRef>
+          <a:effectRef idx="2">
+            <a:schemeClr val="accent1"/>
+          </a:effectRef>
+          <a:fontRef idx="minor">
+            <a:schemeClr val="lt1"/>
+          </a:fontRef>
+        </p:style>
+        <p:txBody>
+          <a:bodyPr rtlCol="0" anchor="ctr"/>
+          <a:lstStyle/>
+          <a:p>
+            <a:pPr algn="ctr"/>
+          </a:p>
+        </p:txBody>
+      </p:sp>
+      <p:sp>
+        <p:nvSpPr>
+          <p:cNvPr id="8" name="TextBox 7"/>
+          <p:cNvSpPr txBox="1"/>
+          <p:nvPr/>
+        </p:nvSpPr>
+        <p:spPr>
+          <a:xfrm>
+            <a:off x="822960" y="1225296"/>
+            <a:ext cx="10515600" cy="274320"/>
+          </a:xfrm>
+          <a:prstGeom prst="rect">
+            <a:avLst/>
+          </a:prstGeom>
+          <a:noFill/>
+        </p:spPr>
+        <p:txBody>
+          <a:bodyPr wrap="square" anchor="t" lIns="0" rIns="0" tIns="0" bIns="0">
+            <a:spAutoFit/>
+          </a:bodyPr>
+          <a:lstStyle/>
+          <a:p>
+            <a:pPr algn="l">
+              <a:lnSpc>
+                <a:spcPct val="106000"/>
+              </a:lnSpc>
+              <a:spcBef>
+                <a:spcPts val="0"/>
+              </a:spcBef>
+              <a:spcAft>
+                <a:spcPts val="400"/>
+              </a:spcAft>
+            </a:pPr>
+            <a:r>
+              <a:rPr sz="1050" b="1" spc="100">
+                <a:solidFill>
+                  <a:srgbClr val="E60012"/>
+                </a:solidFill>
+                <a:latin typeface="Consolas"/>
+                <a:ea typeface="Consolas"/>
+              </a:rPr>
+              <a:t>Model A / B 両取り</a:t>
+            </a:r>
+          </a:p>
+        </p:txBody>
+      </p:sp>
+      <p:sp>
+        <p:nvSpPr>
+          <p:cNvPr id="9" name="TextBox 8"/>
+          <p:cNvSpPr txBox="1"/>
+          <p:nvPr/>
+        </p:nvSpPr>
+        <p:spPr>
+          <a:xfrm>
+            <a:off x="886968" y="1627632"/>
+            <a:ext cx="2103120" cy="590931"/>
+          </a:xfrm>
+          <a:prstGeom prst="rect">
+            <a:avLst/>
+          </a:prstGeom>
+          <a:noFill/>
+        </p:spPr>
+        <p:txBody>
+          <a:bodyPr wrap="square" anchor="ctr" lIns="0" rIns="0" tIns="0" bIns="0">
+            <a:spAutoFit/>
+          </a:bodyPr>
+          <a:lstStyle/>
+          <a:p>
+            <a:pPr algn="l">
+              <a:lnSpc>
+                <a:spcPct val="102000"/>
+              </a:lnSpc>
+              <a:spcBef>
+                <a:spcPts val="0"/>
+              </a:spcBef>
+              <a:spcAft>
+                <a:spcPts val="400"/>
+              </a:spcAft>
+            </a:pPr>
+            <a:r>
+              <a:rPr sz="1150" b="1">
+                <a:solidFill>
+                  <a:srgbClr val="1A1D21"/>
+                </a:solidFill>
+                <a:latin typeface="Noto Sans JP"/>
+                <a:ea typeface="Noto Sans JP"/>
+              </a:rPr>
+              <a:t>さくらインターネット</a:t>
+            </a:r>
+          </a:p>
+        </p:txBody>
+      </p:sp>
+      <p:sp>
+        <p:nvSpPr>
+          <p:cNvPr id="10" name="TextBox 9"/>
+          <p:cNvSpPr txBox="1"/>
+          <p:nvPr/>
+        </p:nvSpPr>
+        <p:spPr>
+          <a:xfrm>
+            <a:off x="3108960" y="1627632"/>
+            <a:ext cx="822960" cy="590931"/>
+          </a:xfrm>
+          <a:prstGeom prst="rect">
+            <a:avLst/>
+          </a:prstGeom>
+          <a:noFill/>
+        </p:spPr>
+        <p:txBody>
+          <a:bodyPr wrap="square" anchor="ctr" lIns="0" rIns="0" tIns="0" bIns="0">
+            <a:spAutoFit/>
+          </a:bodyPr>
+          <a:lstStyle/>
+          <a:p>
+            <a:pPr algn="l">
+              <a:lnSpc>
+                <a:spcPct val="106000"/>
+              </a:lnSpc>
+              <a:spcBef>
+                <a:spcPts val="0"/>
+              </a:spcBef>
+              <a:spcAft>
+                <a:spcPts val="400"/>
+              </a:spcAft>
+            </a:pPr>
+            <a:r>
+              <a:rPr sz="1050" b="0">
+                <a:solidFill>
+                  <a:srgbClr val="8A9098"/>
+                </a:solidFill>
+                <a:latin typeface="Consolas"/>
+                <a:ea typeface="Consolas"/>
+              </a:rPr>
+              <a:t>3778</a:t>
+            </a:r>
+          </a:p>
+        </p:txBody>
+      </p:sp>
+      <p:sp>
+        <p:nvSpPr>
+          <p:cNvPr id="11" name="TextBox 10"/>
+          <p:cNvSpPr txBox="1"/>
+          <p:nvPr/>
+        </p:nvSpPr>
+        <p:spPr>
+          <a:xfrm>
+            <a:off x="4087368" y="1627632"/>
+            <a:ext cx="5943600" cy="590931"/>
+          </a:xfrm>
+          <a:prstGeom prst="rect">
+            <a:avLst/>
+          </a:prstGeom>
+          <a:noFill/>
+        </p:spPr>
+        <p:txBody>
+          <a:bodyPr wrap="square" anchor="ctr" lIns="0" rIns="0" tIns="0" bIns="0">
+            <a:spAutoFit/>
+          </a:bodyPr>
+          <a:lstStyle/>
+          <a:p>
+            <a:pPr algn="l">
+              <a:lnSpc>
+                <a:spcPct val="108000"/>
+              </a:lnSpc>
+              <a:spcBef>
+                <a:spcPts val="0"/>
+              </a:spcBef>
+              <a:spcAft>
+                <a:spcPts val="400"/>
+              </a:spcAft>
+            </a:pPr>
+            <a:r>
+              <a:rPr sz="1100" b="0">
+                <a:solidFill>
+                  <a:srgbClr val="3C4148"/>
+                </a:solidFill>
+                <a:latin typeface="Noto Sans JP"/>
+                <a:ea typeface="Noto Sans JP"/>
+              </a:rPr>
+              <a:t>生成AI向けGPU基盤拡大で石狩DCを拡張・液冷導入、NVIDIA Blackwell搭載。設備投資668億円（発注者）。</a:t>
+            </a:r>
+          </a:p>
+        </p:txBody>
+      </p:sp>
+      <p:sp>
+        <p:nvSpPr>
+          <p:cNvPr id="12" name="TextBox 11"/>
+          <p:cNvSpPr txBox="1"/>
+          <p:nvPr/>
+        </p:nvSpPr>
+        <p:spPr>
+          <a:xfrm>
+            <a:off x="10030968" y="1627632"/>
+            <a:ext cx="640080" cy="590931"/>
+          </a:xfrm>
+          <a:prstGeom prst="rect">
+            <a:avLst/>
+          </a:prstGeom>
+          <a:noFill/>
+        </p:spPr>
+        <p:txBody>
+          <a:bodyPr wrap="square" anchor="ctr" lIns="0" rIns="0" tIns="0" bIns="0">
+            <a:spAutoFit/>
+          </a:bodyPr>
+          <a:lstStyle/>
+          <a:p>
+            <a:pPr algn="r">
+              <a:lnSpc>
+                <a:spcPct val="106000"/>
+              </a:lnSpc>
+              <a:spcBef>
+                <a:spcPts val="0"/>
+              </a:spcBef>
+              <a:spcAft>
+                <a:spcPts val="400"/>
+              </a:spcAft>
+            </a:pPr>
+            <a:r>
+              <a:rPr sz="900" b="0">
+                <a:solidFill>
+                  <a:srgbClr val="8A9098"/>
+                </a:solidFill>
+                <a:latin typeface="Consolas"/>
+                <a:ea typeface="Consolas"/>
+              </a:rPr>
+              <a:t>確度 </a:t>
+            </a:r>
+            <a:r>
+              <a:rPr sz="1000" b="1">
+                <a:solidFill>
+                  <a:srgbClr val="E60012"/>
+                </a:solidFill>
+                <a:latin typeface="Noto Sans JP"/>
+                <a:ea typeface="Noto Sans JP"/>
+              </a:rPr>
+              <a:t>高</a:t>
+            </a:r>
+          </a:p>
+        </p:txBody>
+      </p:sp>
+      <p:sp>
+        <p:nvSpPr>
+          <p:cNvPr id="13" name="Rectangle 12"/>
+          <p:cNvSpPr/>
+          <p:nvPr/>
+        </p:nvSpPr>
+        <p:spPr>
+          <a:xfrm>
+            <a:off x="777240" y="2218563"/>
+            <a:ext cx="9966960" cy="590931"/>
+          </a:xfrm>
+          <a:prstGeom prst="rect">
+            <a:avLst/>
+          </a:prstGeom>
+          <a:solidFill>
+            <a:srgbClr val="F3F4F6"/>
+          </a:solidFill>
+          <a:ln>
+            <a:noFill/>
+          </a:ln>
+          <a:effectLst/>
+        </p:spPr>
+        <p:style>
+          <a:lnRef idx="1">
+            <a:schemeClr val="accent1"/>
+          </a:lnRef>
+          <a:fillRef idx="3">
+            <a:schemeClr val="accent1"/>
+          </a:fillRef>
+          <a:effectRef idx="2">
+            <a:schemeClr val="accent1"/>
+          </a:effectRef>
+          <a:fontRef idx="minor">
+            <a:schemeClr val="lt1"/>
+          </a:fontRef>
+        </p:style>
+        <p:txBody>
+          <a:bodyPr rtlCol="0" anchor="ctr"/>
+          <a:lstStyle/>
+          <a:p>
+            <a:pPr algn="ctr"/>
+          </a:p>
+        </p:txBody>
+      </p:sp>
+      <p:sp>
+        <p:nvSpPr>
+          <p:cNvPr id="14" name="TextBox 13"/>
+          <p:cNvSpPr txBox="1"/>
+          <p:nvPr/>
+        </p:nvSpPr>
+        <p:spPr>
+          <a:xfrm>
+            <a:off x="886968" y="2218563"/>
+            <a:ext cx="2103120" cy="590931"/>
+          </a:xfrm>
+          <a:prstGeom prst="rect">
+            <a:avLst/>
+          </a:prstGeom>
+          <a:noFill/>
+        </p:spPr>
+        <p:txBody>
+          <a:bodyPr wrap="square" anchor="ctr" lIns="0" rIns="0" tIns="0" bIns="0">
+            <a:spAutoFit/>
+          </a:bodyPr>
+          <a:lstStyle/>
+          <a:p>
+            <a:pPr algn="l">
+              <a:lnSpc>
+                <a:spcPct val="102000"/>
+              </a:lnSpc>
+              <a:spcBef>
+                <a:spcPts val="0"/>
+              </a:spcBef>
+              <a:spcAft>
+                <a:spcPts val="400"/>
+              </a:spcAft>
+            </a:pPr>
+            <a:r>
+              <a:rPr sz="1150" b="1">
+                <a:solidFill>
+                  <a:srgbClr val="1A1D21"/>
+                </a:solidFill>
+                <a:latin typeface="Noto Sans JP"/>
+                <a:ea typeface="Noto Sans JP"/>
+              </a:rPr>
+              <a:t>インターネットイニシアティブ</a:t>
+            </a:r>
+          </a:p>
+        </p:txBody>
+      </p:sp>
+      <p:sp>
+        <p:nvSpPr>
+          <p:cNvPr id="15" name="TextBox 14"/>
+          <p:cNvSpPr txBox="1"/>
+          <p:nvPr/>
+        </p:nvSpPr>
+        <p:spPr>
+          <a:xfrm>
+            <a:off x="3108960" y="2218563"/>
+            <a:ext cx="822960" cy="590931"/>
+          </a:xfrm>
+          <a:prstGeom prst="rect">
+            <a:avLst/>
+          </a:prstGeom>
+          <a:noFill/>
+        </p:spPr>
+        <p:txBody>
+          <a:bodyPr wrap="square" anchor="ctr" lIns="0" rIns="0" tIns="0" bIns="0">
+            <a:spAutoFit/>
+          </a:bodyPr>
+          <a:lstStyle/>
+          <a:p>
+            <a:pPr algn="l">
+              <a:lnSpc>
+                <a:spcPct val="106000"/>
+              </a:lnSpc>
+              <a:spcBef>
+                <a:spcPts val="0"/>
+              </a:spcBef>
+              <a:spcAft>
+                <a:spcPts val="400"/>
+              </a:spcAft>
+            </a:pPr>
+            <a:r>
+              <a:rPr sz="1050" b="0">
+                <a:solidFill>
+                  <a:srgbClr val="8A9098"/>
+                </a:solidFill>
+                <a:latin typeface="Consolas"/>
+                <a:ea typeface="Consolas"/>
+              </a:rPr>
+              <a:t>3774</a:t>
+            </a:r>
+          </a:p>
+        </p:txBody>
+      </p:sp>
+      <p:sp>
+        <p:nvSpPr>
+          <p:cNvPr id="16" name="TextBox 15"/>
+          <p:cNvSpPr txBox="1"/>
+          <p:nvPr/>
+        </p:nvSpPr>
+        <p:spPr>
+          <a:xfrm>
+            <a:off x="4087368" y="2218563"/>
+            <a:ext cx="5943600" cy="590931"/>
+          </a:xfrm>
+          <a:prstGeom prst="rect">
+            <a:avLst/>
+          </a:prstGeom>
+          <a:noFill/>
+        </p:spPr>
+        <p:txBody>
+          <a:bodyPr wrap="square" anchor="ctr" lIns="0" rIns="0" tIns="0" bIns="0">
+            <a:spAutoFit/>
+          </a:bodyPr>
+          <a:lstStyle/>
+          <a:p>
+            <a:pPr algn="l">
+              <a:lnSpc>
+                <a:spcPct val="108000"/>
+              </a:lnSpc>
+              <a:spcBef>
+                <a:spcPts val="0"/>
+              </a:spcBef>
+              <a:spcAft>
+                <a:spcPts val="400"/>
+              </a:spcAft>
+            </a:pPr>
+            <a:r>
+              <a:rPr sz="1100" b="0">
+                <a:solidFill>
+                  <a:srgbClr val="3C4148"/>
+                </a:solidFill>
+                <a:latin typeface="Noto Sans JP"/>
+                <a:ea typeface="Noto Sans JP"/>
+              </a:rPr>
+              <a:t>白井DCキャンパス3期棟（約1,000ラック・約300億円）を増設、水冷Readyで26年度運用開始（発注者）。</a:t>
+            </a:r>
+          </a:p>
+        </p:txBody>
+      </p:sp>
+      <p:sp>
+        <p:nvSpPr>
+          <p:cNvPr id="17" name="TextBox 16"/>
+          <p:cNvSpPr txBox="1"/>
+          <p:nvPr/>
+        </p:nvSpPr>
+        <p:spPr>
+          <a:xfrm>
+            <a:off x="10030968" y="2218563"/>
+            <a:ext cx="640080" cy="590931"/>
+          </a:xfrm>
+          <a:prstGeom prst="rect">
+            <a:avLst/>
+          </a:prstGeom>
+          <a:noFill/>
+        </p:spPr>
+        <p:txBody>
+          <a:bodyPr wrap="square" anchor="ctr" lIns="0" rIns="0" tIns="0" bIns="0">
+            <a:spAutoFit/>
+          </a:bodyPr>
+          <a:lstStyle/>
+          <a:p>
+            <a:pPr algn="r">
+              <a:lnSpc>
+                <a:spcPct val="106000"/>
+              </a:lnSpc>
+              <a:spcBef>
+                <a:spcPts val="0"/>
+              </a:spcBef>
+              <a:spcAft>
+                <a:spcPts val="400"/>
+              </a:spcAft>
+            </a:pPr>
+            <a:r>
+              <a:rPr sz="900" b="0">
+                <a:solidFill>
+                  <a:srgbClr val="8A9098"/>
+                </a:solidFill>
+                <a:latin typeface="Consolas"/>
+                <a:ea typeface="Consolas"/>
+              </a:rPr>
+              <a:t>確度 </a:t>
+            </a:r>
+            <a:r>
+              <a:rPr sz="1000" b="1">
+                <a:solidFill>
+                  <a:srgbClr val="E60012"/>
+                </a:solidFill>
+                <a:latin typeface="Noto Sans JP"/>
+                <a:ea typeface="Noto Sans JP"/>
+              </a:rPr>
+              <a:t>高</a:t>
+            </a:r>
+          </a:p>
+        </p:txBody>
+      </p:sp>
+      <p:sp>
+        <p:nvSpPr>
+          <p:cNvPr id="18" name="TextBox 17"/>
+          <p:cNvSpPr txBox="1"/>
+          <p:nvPr/>
+        </p:nvSpPr>
+        <p:spPr>
+          <a:xfrm>
+            <a:off x="886968" y="2809494"/>
+            <a:ext cx="2103120" cy="590931"/>
+          </a:xfrm>
+          <a:prstGeom prst="rect">
+            <a:avLst/>
+          </a:prstGeom>
+          <a:noFill/>
+        </p:spPr>
+        <p:txBody>
+          <a:bodyPr wrap="square" anchor="ctr" lIns="0" rIns="0" tIns="0" bIns="0">
+            <a:spAutoFit/>
+          </a:bodyPr>
+          <a:lstStyle/>
+          <a:p>
+            <a:pPr algn="l">
+              <a:lnSpc>
+                <a:spcPct val="102000"/>
+              </a:lnSpc>
+              <a:spcBef>
+                <a:spcPts val="0"/>
+              </a:spcBef>
+              <a:spcAft>
+                <a:spcPts val="400"/>
+              </a:spcAft>
+            </a:pPr>
+            <a:r>
+              <a:rPr sz="1150" b="1">
+                <a:solidFill>
+                  <a:srgbClr val="1A1D21"/>
+                </a:solidFill>
+                <a:latin typeface="Noto Sans JP"/>
+                <a:ea typeface="Noto Sans JP"/>
+              </a:rPr>
+              <a:t>NTTデータグループ</a:t>
+            </a:r>
+          </a:p>
+        </p:txBody>
+      </p:sp>
+      <p:sp>
+        <p:nvSpPr>
+          <p:cNvPr id="19" name="TextBox 18"/>
+          <p:cNvSpPr txBox="1"/>
+          <p:nvPr/>
+        </p:nvSpPr>
+        <p:spPr>
+          <a:xfrm>
+            <a:off x="3108960" y="2809494"/>
+            <a:ext cx="822960" cy="590931"/>
+          </a:xfrm>
+          <a:prstGeom prst="rect">
+            <a:avLst/>
+          </a:prstGeom>
+          <a:noFill/>
+        </p:spPr>
+        <p:txBody>
+          <a:bodyPr wrap="square" anchor="ctr" lIns="0" rIns="0" tIns="0" bIns="0">
+            <a:spAutoFit/>
+          </a:bodyPr>
+          <a:lstStyle/>
+          <a:p>
+            <a:pPr algn="l">
+              <a:lnSpc>
+                <a:spcPct val="106000"/>
+              </a:lnSpc>
+              <a:spcBef>
+                <a:spcPts val="0"/>
+              </a:spcBef>
+              <a:spcAft>
+                <a:spcPts val="400"/>
+              </a:spcAft>
+            </a:pPr>
+            <a:r>
+              <a:rPr sz="1050" b="0">
+                <a:solidFill>
+                  <a:srgbClr val="8A9098"/>
+                </a:solidFill>
+                <a:latin typeface="Consolas"/>
+                <a:ea typeface="Consolas"/>
+              </a:rPr>
+              <a:t>9613</a:t>
+            </a:r>
+          </a:p>
+        </p:txBody>
+      </p:sp>
+      <p:sp>
+        <p:nvSpPr>
+          <p:cNvPr id="20" name="TextBox 19"/>
+          <p:cNvSpPr txBox="1"/>
+          <p:nvPr/>
+        </p:nvSpPr>
+        <p:spPr>
+          <a:xfrm>
+            <a:off x="4087368" y="2809494"/>
+            <a:ext cx="5943600" cy="590931"/>
+          </a:xfrm>
+          <a:prstGeom prst="rect">
+            <a:avLst/>
+          </a:prstGeom>
+          <a:noFill/>
+        </p:spPr>
+        <p:txBody>
+          <a:bodyPr wrap="square" anchor="ctr" lIns="0" rIns="0" tIns="0" bIns="0">
+            <a:spAutoFit/>
+          </a:bodyPr>
+          <a:lstStyle/>
+          <a:p>
+            <a:pPr algn="l">
+              <a:lnSpc>
+                <a:spcPct val="108000"/>
+              </a:lnSpc>
+              <a:spcBef>
+                <a:spcPts val="0"/>
+              </a:spcBef>
+              <a:spcAft>
+                <a:spcPts val="400"/>
+              </a:spcAft>
+            </a:pPr>
+            <a:r>
+              <a:rPr sz="1100" b="0">
+                <a:solidFill>
+                  <a:srgbClr val="3C4148"/>
+                </a:solidFill>
+                <a:latin typeface="Noto Sans JP"/>
+                <a:ea typeface="Noto Sans JP"/>
+              </a:rPr>
+              <a:t>DCをAI中核インフラと位置づけ2030年度に3GW超へ。外部ファンドと共同出資で投資を上積み（発注者）。</a:t>
+            </a:r>
+          </a:p>
+        </p:txBody>
+      </p:sp>
+      <p:sp>
+        <p:nvSpPr>
+          <p:cNvPr id="21" name="TextBox 20"/>
+          <p:cNvSpPr txBox="1"/>
+          <p:nvPr/>
+        </p:nvSpPr>
+        <p:spPr>
+          <a:xfrm>
+            <a:off x="10030968" y="2809494"/>
+            <a:ext cx="640080" cy="590931"/>
+          </a:xfrm>
+          <a:prstGeom prst="rect">
+            <a:avLst/>
+          </a:prstGeom>
+          <a:noFill/>
+        </p:spPr>
+        <p:txBody>
+          <a:bodyPr wrap="square" anchor="ctr" lIns="0" rIns="0" tIns="0" bIns="0">
+            <a:spAutoFit/>
+          </a:bodyPr>
+          <a:lstStyle/>
+          <a:p>
+            <a:pPr algn="r">
+              <a:lnSpc>
+                <a:spcPct val="106000"/>
+              </a:lnSpc>
+              <a:spcBef>
+                <a:spcPts val="0"/>
+              </a:spcBef>
+              <a:spcAft>
+                <a:spcPts val="400"/>
+              </a:spcAft>
+            </a:pPr>
+            <a:r>
+              <a:rPr sz="900" b="0">
+                <a:solidFill>
+                  <a:srgbClr val="8A9098"/>
+                </a:solidFill>
+                <a:latin typeface="Consolas"/>
+                <a:ea typeface="Consolas"/>
+              </a:rPr>
+              <a:t>確度 </a:t>
+            </a:r>
+            <a:r>
+              <a:rPr sz="1000" b="1">
+                <a:solidFill>
+                  <a:srgbClr val="E60012"/>
+                </a:solidFill>
+                <a:latin typeface="Noto Sans JP"/>
+                <a:ea typeface="Noto Sans JP"/>
+              </a:rPr>
+              <a:t>高</a:t>
+            </a:r>
+          </a:p>
+        </p:txBody>
+      </p:sp>
+      <p:sp>
+        <p:nvSpPr>
+          <p:cNvPr id="22" name="Rectangle 21"/>
+          <p:cNvSpPr/>
+          <p:nvPr/>
+        </p:nvSpPr>
+        <p:spPr>
+          <a:xfrm>
+            <a:off x="777240" y="3400425"/>
+            <a:ext cx="9966960" cy="590931"/>
+          </a:xfrm>
+          <a:prstGeom prst="rect">
+            <a:avLst/>
+          </a:prstGeom>
+          <a:solidFill>
+            <a:srgbClr val="F3F4F6"/>
+          </a:solidFill>
+          <a:ln>
+            <a:noFill/>
+          </a:ln>
+          <a:effectLst/>
+        </p:spPr>
+        <p:style>
+          <a:lnRef idx="1">
+            <a:schemeClr val="accent1"/>
+          </a:lnRef>
+          <a:fillRef idx="3">
+            <a:schemeClr val="accent1"/>
+          </a:fillRef>
+          <a:effectRef idx="2">
+            <a:schemeClr val="accent1"/>
+          </a:effectRef>
+          <a:fontRef idx="minor">
+            <a:schemeClr val="lt1"/>
+          </a:fontRef>
+        </p:style>
+        <p:txBody>
+          <a:bodyPr rtlCol="0" anchor="ctr"/>
+          <a:lstStyle/>
+          <a:p>
+            <a:pPr algn="ctr"/>
+          </a:p>
+        </p:txBody>
+      </p:sp>
+      <p:sp>
+        <p:nvSpPr>
+          <p:cNvPr id="23" name="TextBox 22"/>
+          <p:cNvSpPr txBox="1"/>
+          <p:nvPr/>
+        </p:nvSpPr>
+        <p:spPr>
+          <a:xfrm>
+            <a:off x="886968" y="3400425"/>
+            <a:ext cx="2103120" cy="590931"/>
+          </a:xfrm>
+          <a:prstGeom prst="rect">
+            <a:avLst/>
+          </a:prstGeom>
+          <a:noFill/>
+        </p:spPr>
+        <p:txBody>
+          <a:bodyPr wrap="square" anchor="ctr" lIns="0" rIns="0" tIns="0" bIns="0">
+            <a:spAutoFit/>
+          </a:bodyPr>
+          <a:lstStyle/>
+          <a:p>
+            <a:pPr algn="l">
+              <a:lnSpc>
+                <a:spcPct val="102000"/>
+              </a:lnSpc>
+              <a:spcBef>
+                <a:spcPts val="0"/>
+              </a:spcBef>
+              <a:spcAft>
+                <a:spcPts val="400"/>
+              </a:spcAft>
+            </a:pPr>
+            <a:r>
+              <a:rPr sz="1150" b="1">
+                <a:solidFill>
+                  <a:srgbClr val="1A1D21"/>
+                </a:solidFill>
+                <a:latin typeface="Noto Sans JP"/>
+                <a:ea typeface="Noto Sans JP"/>
+              </a:rPr>
+              <a:t>伊藤忠テクノソリューションズ</a:t>
+            </a:r>
+          </a:p>
+        </p:txBody>
+      </p:sp>
+      <p:sp>
+        <p:nvSpPr>
+          <p:cNvPr id="24" name="TextBox 23"/>
+          <p:cNvSpPr txBox="1"/>
+          <p:nvPr/>
+        </p:nvSpPr>
+        <p:spPr>
+          <a:xfrm>
+            <a:off x="3108960" y="3400425"/>
+            <a:ext cx="822960" cy="590931"/>
+          </a:xfrm>
+          <a:prstGeom prst="rect">
+            <a:avLst/>
+          </a:prstGeom>
+          <a:noFill/>
+        </p:spPr>
+        <p:txBody>
+          <a:bodyPr wrap="square" anchor="ctr" lIns="0" rIns="0" tIns="0" bIns="0">
+            <a:spAutoFit/>
+          </a:bodyPr>
+          <a:lstStyle/>
+          <a:p>
+            <a:pPr algn="l">
+              <a:lnSpc>
+                <a:spcPct val="106000"/>
+              </a:lnSpc>
+              <a:spcBef>
+                <a:spcPts val="0"/>
+              </a:spcBef>
+              <a:spcAft>
+                <a:spcPts val="400"/>
+              </a:spcAft>
+            </a:pPr>
+            <a:r>
+              <a:rPr sz="1050" b="0">
+                <a:solidFill>
+                  <a:srgbClr val="8A9098"/>
+                </a:solidFill>
+                <a:latin typeface="Consolas"/>
+                <a:ea typeface="Consolas"/>
+              </a:rPr>
+              <a:t>4739</a:t>
+            </a:r>
+          </a:p>
+        </p:txBody>
+      </p:sp>
+      <p:sp>
+        <p:nvSpPr>
+          <p:cNvPr id="25" name="TextBox 24"/>
+          <p:cNvSpPr txBox="1"/>
+          <p:nvPr/>
+        </p:nvSpPr>
+        <p:spPr>
+          <a:xfrm>
+            <a:off x="4087368" y="3400425"/>
+            <a:ext cx="5943600" cy="590931"/>
+          </a:xfrm>
+          <a:prstGeom prst="rect">
+            <a:avLst/>
+          </a:prstGeom>
+          <a:noFill/>
+        </p:spPr>
+        <p:txBody>
+          <a:bodyPr wrap="square" anchor="ctr" lIns="0" rIns="0" tIns="0" bIns="0">
+            <a:spAutoFit/>
+          </a:bodyPr>
+          <a:lstStyle/>
+          <a:p>
+            <a:pPr algn="l">
+              <a:lnSpc>
+                <a:spcPct val="108000"/>
+              </a:lnSpc>
+              <a:spcBef>
+                <a:spcPts val="0"/>
+              </a:spcBef>
+              <a:spcAft>
+                <a:spcPts val="400"/>
+              </a:spcAft>
+            </a:pPr>
+            <a:r>
+              <a:rPr sz="1100" b="0">
+                <a:solidFill>
+                  <a:srgbClr val="3C4148"/>
+                </a:solidFill>
+                <a:latin typeface="Noto Sans JP"/>
+                <a:ea typeface="Noto Sans JP"/>
+              </a:rPr>
+              <a:t>クラウド・GPU基盤サービスが牽引し26/3期は売上7,937億円+9%・営業+19%（発注者＋構築請負）。</a:t>
+            </a:r>
+          </a:p>
+        </p:txBody>
+      </p:sp>
+      <p:sp>
+        <p:nvSpPr>
+          <p:cNvPr id="26" name="TextBox 25"/>
+          <p:cNvSpPr txBox="1"/>
+          <p:nvPr/>
+        </p:nvSpPr>
+        <p:spPr>
+          <a:xfrm>
+            <a:off x="10030968" y="3400425"/>
+            <a:ext cx="640080" cy="590931"/>
+          </a:xfrm>
+          <a:prstGeom prst="rect">
+            <a:avLst/>
+          </a:prstGeom>
+          <a:noFill/>
+        </p:spPr>
+        <p:txBody>
+          <a:bodyPr wrap="square" anchor="ctr" lIns="0" rIns="0" tIns="0" bIns="0">
+            <a:spAutoFit/>
+          </a:bodyPr>
+          <a:lstStyle/>
+          <a:p>
+            <a:pPr algn="r">
+              <a:lnSpc>
+                <a:spcPct val="106000"/>
+              </a:lnSpc>
+              <a:spcBef>
+                <a:spcPts val="0"/>
+              </a:spcBef>
+              <a:spcAft>
+                <a:spcPts val="400"/>
+              </a:spcAft>
+            </a:pPr>
+            <a:r>
+              <a:rPr sz="900" b="0">
+                <a:solidFill>
+                  <a:srgbClr val="8A9098"/>
+                </a:solidFill>
+                <a:latin typeface="Consolas"/>
+                <a:ea typeface="Consolas"/>
+              </a:rPr>
+              <a:t>確度 </a:t>
+            </a:r>
+            <a:r>
+              <a:rPr sz="1000" b="1">
+                <a:solidFill>
+                  <a:srgbClr val="E60012"/>
+                </a:solidFill>
+                <a:latin typeface="Noto Sans JP"/>
+                <a:ea typeface="Noto Sans JP"/>
+              </a:rPr>
+              <a:t>高</a:t>
+            </a:r>
+          </a:p>
+        </p:txBody>
+      </p:sp>
+      <p:sp>
+        <p:nvSpPr>
+          <p:cNvPr id="27" name="TextBox 26"/>
+          <p:cNvSpPr txBox="1"/>
+          <p:nvPr/>
+        </p:nvSpPr>
+        <p:spPr>
+          <a:xfrm>
+            <a:off x="886968" y="3991356"/>
+            <a:ext cx="2103120" cy="590931"/>
+          </a:xfrm>
+          <a:prstGeom prst="rect">
+            <a:avLst/>
+          </a:prstGeom>
+          <a:noFill/>
+        </p:spPr>
+        <p:txBody>
+          <a:bodyPr wrap="square" anchor="ctr" lIns="0" rIns="0" tIns="0" bIns="0">
+            <a:spAutoFit/>
+          </a:bodyPr>
+          <a:lstStyle/>
+          <a:p>
+            <a:pPr algn="l">
+              <a:lnSpc>
+                <a:spcPct val="102000"/>
+              </a:lnSpc>
+              <a:spcBef>
+                <a:spcPts val="0"/>
+              </a:spcBef>
+              <a:spcAft>
+                <a:spcPts val="400"/>
+              </a:spcAft>
+            </a:pPr>
+            <a:r>
+              <a:rPr sz="1150" b="1">
+                <a:solidFill>
+                  <a:srgbClr val="1A1D21"/>
+                </a:solidFill>
+                <a:latin typeface="Noto Sans JP"/>
+                <a:ea typeface="Noto Sans JP"/>
+              </a:rPr>
+              <a:t>兼松エレクトロニクス</a:t>
+            </a:r>
+          </a:p>
+        </p:txBody>
+      </p:sp>
+      <p:sp>
+        <p:nvSpPr>
+          <p:cNvPr id="28" name="TextBox 27"/>
+          <p:cNvSpPr txBox="1"/>
+          <p:nvPr/>
+        </p:nvSpPr>
+        <p:spPr>
+          <a:xfrm>
+            <a:off x="3108960" y="3991356"/>
+            <a:ext cx="822960" cy="590931"/>
+          </a:xfrm>
+          <a:prstGeom prst="rect">
+            <a:avLst/>
+          </a:prstGeom>
+          <a:noFill/>
+        </p:spPr>
+        <p:txBody>
+          <a:bodyPr wrap="square" anchor="ctr" lIns="0" rIns="0" tIns="0" bIns="0">
+            <a:spAutoFit/>
+          </a:bodyPr>
+          <a:lstStyle/>
+          <a:p>
+            <a:pPr algn="l">
+              <a:lnSpc>
+                <a:spcPct val="106000"/>
+              </a:lnSpc>
+              <a:spcBef>
+                <a:spcPts val="0"/>
+              </a:spcBef>
+              <a:spcAft>
+                <a:spcPts val="400"/>
+              </a:spcAft>
+            </a:pPr>
+            <a:r>
+              <a:rPr sz="1050" b="0">
+                <a:solidFill>
+                  <a:srgbClr val="8A9098"/>
+                </a:solidFill>
+                <a:latin typeface="Consolas"/>
+                <a:ea typeface="Consolas"/>
+              </a:rPr>
+              <a:t>8096</a:t>
+            </a:r>
+          </a:p>
+        </p:txBody>
+      </p:sp>
+      <p:sp>
+        <p:nvSpPr>
+          <p:cNvPr id="29" name="TextBox 28"/>
+          <p:cNvSpPr txBox="1"/>
+          <p:nvPr/>
+        </p:nvSpPr>
+        <p:spPr>
+          <a:xfrm>
+            <a:off x="4087368" y="3991356"/>
+            <a:ext cx="5943600" cy="590931"/>
+          </a:xfrm>
+          <a:prstGeom prst="rect">
+            <a:avLst/>
+          </a:prstGeom>
+          <a:noFill/>
+        </p:spPr>
+        <p:txBody>
+          <a:bodyPr wrap="square" anchor="ctr" lIns="0" rIns="0" tIns="0" bIns="0">
+            <a:spAutoFit/>
+          </a:bodyPr>
+          <a:lstStyle/>
+          <a:p>
+            <a:pPr algn="l">
+              <a:lnSpc>
+                <a:spcPct val="108000"/>
+              </a:lnSpc>
+              <a:spcBef>
+                <a:spcPts val="0"/>
+              </a:spcBef>
+              <a:spcAft>
+                <a:spcPts val="400"/>
+              </a:spcAft>
+            </a:pPr>
+            <a:r>
+              <a:rPr sz="1100" b="0">
+                <a:solidFill>
+                  <a:srgbClr val="3C4148"/>
+                </a:solidFill>
+                <a:latin typeface="Noto Sans JP"/>
+                <a:ea typeface="Noto Sans JP"/>
+              </a:rPr>
+              <a:t>NW機器・生成AI機器とDCインフラ構築需要で3期ぶり増収増益（売上1,073億+9.7%・営業+37.2%／請負）。</a:t>
+            </a:r>
+          </a:p>
+        </p:txBody>
+      </p:sp>
+      <p:sp>
+        <p:nvSpPr>
+          <p:cNvPr id="30" name="TextBox 29"/>
+          <p:cNvSpPr txBox="1"/>
+          <p:nvPr/>
+        </p:nvSpPr>
+        <p:spPr>
+          <a:xfrm>
+            <a:off x="10030968" y="3991356"/>
+            <a:ext cx="640080" cy="590931"/>
+          </a:xfrm>
+          <a:prstGeom prst="rect">
+            <a:avLst/>
+          </a:prstGeom>
+          <a:noFill/>
+        </p:spPr>
+        <p:txBody>
+          <a:bodyPr wrap="square" anchor="ctr" lIns="0" rIns="0" tIns="0" bIns="0">
+            <a:spAutoFit/>
+          </a:bodyPr>
+          <a:lstStyle/>
+          <a:p>
+            <a:pPr algn="r">
+              <a:lnSpc>
+                <a:spcPct val="106000"/>
+              </a:lnSpc>
+              <a:spcBef>
+                <a:spcPts val="0"/>
+              </a:spcBef>
+              <a:spcAft>
+                <a:spcPts val="400"/>
+              </a:spcAft>
+            </a:pPr>
+            <a:r>
+              <a:rPr sz="900" b="0">
+                <a:solidFill>
+                  <a:srgbClr val="8A9098"/>
+                </a:solidFill>
+                <a:latin typeface="Consolas"/>
+                <a:ea typeface="Consolas"/>
+              </a:rPr>
+              <a:t>確度 </a:t>
+            </a:r>
+            <a:r>
+              <a:rPr sz="1000" b="1">
+                <a:solidFill>
+                  <a:srgbClr val="E60012"/>
+                </a:solidFill>
+                <a:latin typeface="Noto Sans JP"/>
+                <a:ea typeface="Noto Sans JP"/>
+              </a:rPr>
+              <a:t>高</a:t>
+            </a:r>
+          </a:p>
+        </p:txBody>
+      </p:sp>
+      <p:sp>
+        <p:nvSpPr>
+          <p:cNvPr id="31" name="Rectangle 30"/>
+          <p:cNvSpPr/>
+          <p:nvPr/>
+        </p:nvSpPr>
+        <p:spPr>
+          <a:xfrm>
+            <a:off x="777240" y="4582287"/>
+            <a:ext cx="9966960" cy="590931"/>
+          </a:xfrm>
+          <a:prstGeom prst="rect">
+            <a:avLst/>
+          </a:prstGeom>
+          <a:solidFill>
+            <a:srgbClr val="F3F4F6"/>
+          </a:solidFill>
+          <a:ln>
+            <a:noFill/>
+          </a:ln>
+          <a:effectLst/>
+        </p:spPr>
+        <p:style>
+          <a:lnRef idx="1">
+            <a:schemeClr val="accent1"/>
+          </a:lnRef>
+          <a:fillRef idx="3">
+            <a:schemeClr val="accent1"/>
+          </a:fillRef>
+          <a:effectRef idx="2">
+            <a:schemeClr val="accent1"/>
+          </a:effectRef>
+          <a:fontRef idx="minor">
+            <a:schemeClr val="lt1"/>
+          </a:fontRef>
+        </p:style>
+        <p:txBody>
+          <a:bodyPr rtlCol="0" anchor="ctr"/>
+          <a:lstStyle/>
+          <a:p>
+            <a:pPr algn="ctr"/>
+          </a:p>
+        </p:txBody>
+      </p:sp>
+      <p:sp>
+        <p:nvSpPr>
+          <p:cNvPr id="32" name="TextBox 31"/>
+          <p:cNvSpPr txBox="1"/>
+          <p:nvPr/>
+        </p:nvSpPr>
+        <p:spPr>
+          <a:xfrm>
+            <a:off x="886968" y="4582287"/>
+            <a:ext cx="2103120" cy="590931"/>
+          </a:xfrm>
+          <a:prstGeom prst="rect">
+            <a:avLst/>
+          </a:prstGeom>
+          <a:noFill/>
+        </p:spPr>
+        <p:txBody>
+          <a:bodyPr wrap="square" anchor="ctr" lIns="0" rIns="0" tIns="0" bIns="0">
+            <a:spAutoFit/>
+          </a:bodyPr>
+          <a:lstStyle/>
+          <a:p>
+            <a:pPr algn="l">
+              <a:lnSpc>
+                <a:spcPct val="102000"/>
+              </a:lnSpc>
+              <a:spcBef>
+                <a:spcPts val="0"/>
+              </a:spcBef>
+              <a:spcAft>
+                <a:spcPts val="400"/>
+              </a:spcAft>
+            </a:pPr>
+            <a:r>
+              <a:rPr sz="1150" b="1">
+                <a:solidFill>
+                  <a:srgbClr val="1A1D21"/>
+                </a:solidFill>
+                <a:latin typeface="Noto Sans JP"/>
+                <a:ea typeface="Noto Sans JP"/>
+              </a:rPr>
+              <a:t>アイネット</a:t>
+            </a:r>
+          </a:p>
+        </p:txBody>
+      </p:sp>
+      <p:sp>
+        <p:nvSpPr>
+          <p:cNvPr id="33" name="TextBox 32"/>
+          <p:cNvSpPr txBox="1"/>
+          <p:nvPr/>
+        </p:nvSpPr>
+        <p:spPr>
+          <a:xfrm>
+            <a:off x="3108960" y="4582287"/>
+            <a:ext cx="822960" cy="590931"/>
+          </a:xfrm>
+          <a:prstGeom prst="rect">
+            <a:avLst/>
+          </a:prstGeom>
+          <a:noFill/>
+        </p:spPr>
+        <p:txBody>
+          <a:bodyPr wrap="square" anchor="ctr" lIns="0" rIns="0" tIns="0" bIns="0">
+            <a:spAutoFit/>
+          </a:bodyPr>
+          <a:lstStyle/>
+          <a:p>
+            <a:pPr algn="l">
+              <a:lnSpc>
+                <a:spcPct val="106000"/>
+              </a:lnSpc>
+              <a:spcBef>
+                <a:spcPts val="0"/>
+              </a:spcBef>
+              <a:spcAft>
+                <a:spcPts val="400"/>
+              </a:spcAft>
+            </a:pPr>
+            <a:r>
+              <a:rPr sz="1050" b="0">
+                <a:solidFill>
+                  <a:srgbClr val="8A9098"/>
+                </a:solidFill>
+                <a:latin typeface="Consolas"/>
+                <a:ea typeface="Consolas"/>
+              </a:rPr>
+              <a:t>9600</a:t>
+            </a:r>
+          </a:p>
+        </p:txBody>
+      </p:sp>
+      <p:sp>
+        <p:nvSpPr>
+          <p:cNvPr id="34" name="TextBox 33"/>
+          <p:cNvSpPr txBox="1"/>
+          <p:nvPr/>
+        </p:nvSpPr>
+        <p:spPr>
+          <a:xfrm>
+            <a:off x="4087368" y="4582287"/>
+            <a:ext cx="5943600" cy="590931"/>
+          </a:xfrm>
+          <a:prstGeom prst="rect">
+            <a:avLst/>
+          </a:prstGeom>
+          <a:noFill/>
+        </p:spPr>
+        <p:txBody>
+          <a:bodyPr wrap="square" anchor="ctr" lIns="0" rIns="0" tIns="0" bIns="0">
+            <a:spAutoFit/>
+          </a:bodyPr>
+          <a:lstStyle/>
+          <a:p>
+            <a:pPr algn="l">
+              <a:lnSpc>
+                <a:spcPct val="108000"/>
+              </a:lnSpc>
+              <a:spcBef>
+                <a:spcPts val="0"/>
+              </a:spcBef>
+              <a:spcAft>
+                <a:spcPts val="400"/>
+              </a:spcAft>
+            </a:pPr>
+            <a:r>
+              <a:rPr sz="1100" b="0">
+                <a:solidFill>
+                  <a:srgbClr val="3C4148"/>
+                </a:solidFill>
+                <a:latin typeface="Noto Sans JP"/>
+                <a:ea typeface="Noto Sans JP"/>
+              </a:rPr>
+              <a:t>横浜の新DC「inet annex」を26年1月開所、DC・クラウド事業で増収増益を継続（発注者）。</a:t>
+            </a:r>
+          </a:p>
+        </p:txBody>
+      </p:sp>
+      <p:sp>
+        <p:nvSpPr>
+          <p:cNvPr id="35" name="TextBox 34"/>
+          <p:cNvSpPr txBox="1"/>
+          <p:nvPr/>
+        </p:nvSpPr>
+        <p:spPr>
+          <a:xfrm>
+            <a:off x="10030968" y="4582287"/>
+            <a:ext cx="640080" cy="590931"/>
+          </a:xfrm>
+          <a:prstGeom prst="rect">
+            <a:avLst/>
+          </a:prstGeom>
+          <a:noFill/>
+        </p:spPr>
+        <p:txBody>
+          <a:bodyPr wrap="square" anchor="ctr" lIns="0" rIns="0" tIns="0" bIns="0">
+            <a:spAutoFit/>
+          </a:bodyPr>
+          <a:lstStyle/>
+          <a:p>
+            <a:pPr algn="r">
+              <a:lnSpc>
+                <a:spcPct val="106000"/>
+              </a:lnSpc>
+              <a:spcBef>
+                <a:spcPts val="0"/>
+              </a:spcBef>
+              <a:spcAft>
+                <a:spcPts val="400"/>
+              </a:spcAft>
+            </a:pPr>
+            <a:r>
+              <a:rPr sz="900" b="0">
+                <a:solidFill>
+                  <a:srgbClr val="8A9098"/>
+                </a:solidFill>
+                <a:latin typeface="Consolas"/>
+                <a:ea typeface="Consolas"/>
+              </a:rPr>
+              <a:t>確度 </a:t>
+            </a:r>
+            <a:r>
+              <a:rPr sz="1000" b="1">
+                <a:solidFill>
+                  <a:srgbClr val="454B54"/>
+                </a:solidFill>
+                <a:latin typeface="Noto Sans JP"/>
+                <a:ea typeface="Noto Sans JP"/>
+              </a:rPr>
+              <a:t>中</a:t>
+            </a:r>
+          </a:p>
+        </p:txBody>
+      </p:sp>
+      <p:sp>
+        <p:nvSpPr>
+          <p:cNvPr id="36" name="TextBox 35"/>
+          <p:cNvSpPr txBox="1"/>
+          <p:nvPr/>
+        </p:nvSpPr>
+        <p:spPr>
+          <a:xfrm>
+            <a:off x="886968" y="5173218"/>
+            <a:ext cx="2103120" cy="590931"/>
+          </a:xfrm>
+          <a:prstGeom prst="rect">
+            <a:avLst/>
+          </a:prstGeom>
+          <a:noFill/>
+        </p:spPr>
+        <p:txBody>
+          <a:bodyPr wrap="square" anchor="ctr" lIns="0" rIns="0" tIns="0" bIns="0">
+            <a:spAutoFit/>
+          </a:bodyPr>
+          <a:lstStyle/>
+          <a:p>
+            <a:pPr algn="l">
+              <a:lnSpc>
+                <a:spcPct val="102000"/>
+              </a:lnSpc>
+              <a:spcBef>
+                <a:spcPts val="0"/>
+              </a:spcBef>
+              <a:spcAft>
+                <a:spcPts val="400"/>
+              </a:spcAft>
+            </a:pPr>
+            <a:r>
+              <a:rPr sz="1150" b="1">
+                <a:solidFill>
+                  <a:srgbClr val="1A1D21"/>
+                </a:solidFill>
+                <a:latin typeface="Noto Sans JP"/>
+                <a:ea typeface="Noto Sans JP"/>
+              </a:rPr>
+              <a:t>NECネッツエスアイ</a:t>
+            </a:r>
+          </a:p>
+        </p:txBody>
+      </p:sp>
+      <p:sp>
+        <p:nvSpPr>
+          <p:cNvPr id="37" name="TextBox 36"/>
+          <p:cNvSpPr txBox="1"/>
+          <p:nvPr/>
+        </p:nvSpPr>
+        <p:spPr>
+          <a:xfrm>
+            <a:off x="3108960" y="5173218"/>
+            <a:ext cx="822960" cy="590931"/>
+          </a:xfrm>
+          <a:prstGeom prst="rect">
+            <a:avLst/>
+          </a:prstGeom>
+          <a:noFill/>
+        </p:spPr>
+        <p:txBody>
+          <a:bodyPr wrap="square" anchor="ctr" lIns="0" rIns="0" tIns="0" bIns="0">
+            <a:spAutoFit/>
+          </a:bodyPr>
+          <a:lstStyle/>
+          <a:p>
+            <a:pPr algn="l">
+              <a:lnSpc>
+                <a:spcPct val="106000"/>
+              </a:lnSpc>
+              <a:spcBef>
+                <a:spcPts val="0"/>
+              </a:spcBef>
+              <a:spcAft>
+                <a:spcPts val="400"/>
+              </a:spcAft>
+            </a:pPr>
+            <a:r>
+              <a:rPr sz="1050" b="0">
+                <a:solidFill>
+                  <a:srgbClr val="8A9098"/>
+                </a:solidFill>
+                <a:latin typeface="Consolas"/>
+                <a:ea typeface="Consolas"/>
+              </a:rPr>
+              <a:t>非上場</a:t>
+            </a:r>
+          </a:p>
+        </p:txBody>
+      </p:sp>
+      <p:sp>
+        <p:nvSpPr>
+          <p:cNvPr id="38" name="TextBox 37"/>
+          <p:cNvSpPr txBox="1"/>
+          <p:nvPr/>
+        </p:nvSpPr>
+        <p:spPr>
+          <a:xfrm>
+            <a:off x="4087368" y="5173218"/>
+            <a:ext cx="5943600" cy="590931"/>
+          </a:xfrm>
+          <a:prstGeom prst="rect">
+            <a:avLst/>
+          </a:prstGeom>
+          <a:noFill/>
+        </p:spPr>
+        <p:txBody>
+          <a:bodyPr wrap="square" anchor="ctr" lIns="0" rIns="0" tIns="0" bIns="0">
+            <a:spAutoFit/>
+          </a:bodyPr>
+          <a:lstStyle/>
+          <a:p>
+            <a:pPr algn="l">
+              <a:lnSpc>
+                <a:spcPct val="108000"/>
+              </a:lnSpc>
+              <a:spcBef>
+                <a:spcPts val="0"/>
+              </a:spcBef>
+              <a:spcAft>
+                <a:spcPts val="400"/>
+              </a:spcAft>
+            </a:pPr>
+            <a:r>
+              <a:rPr sz="1100" b="0">
+                <a:solidFill>
+                  <a:srgbClr val="3C4148"/>
+                </a:solidFill>
+                <a:latin typeface="Noto Sans JP"/>
+                <a:ea typeface="Noto Sans JP"/>
+              </a:rPr>
+              <a:t>企業のAIインフラ（NW・セキュリティ・計算基盤）の設計・構築をCisco連携で提供（構築請負）。</a:t>
+            </a:r>
+          </a:p>
+        </p:txBody>
+      </p:sp>
+      <p:sp>
+        <p:nvSpPr>
+          <p:cNvPr id="39" name="TextBox 38"/>
+          <p:cNvSpPr txBox="1"/>
+          <p:nvPr/>
+        </p:nvSpPr>
+        <p:spPr>
+          <a:xfrm>
+            <a:off x="10030968" y="5173218"/>
+            <a:ext cx="640080" cy="590931"/>
+          </a:xfrm>
+          <a:prstGeom prst="rect">
+            <a:avLst/>
+          </a:prstGeom>
+          <a:noFill/>
+        </p:spPr>
+        <p:txBody>
+          <a:bodyPr wrap="square" anchor="ctr" lIns="0" rIns="0" tIns="0" bIns="0">
+            <a:spAutoFit/>
+          </a:bodyPr>
+          <a:lstStyle/>
+          <a:p>
+            <a:pPr algn="r">
+              <a:lnSpc>
+                <a:spcPct val="106000"/>
+              </a:lnSpc>
+              <a:spcBef>
+                <a:spcPts val="0"/>
+              </a:spcBef>
+              <a:spcAft>
+                <a:spcPts val="400"/>
+              </a:spcAft>
+            </a:pPr>
+            <a:r>
+              <a:rPr sz="900" b="0">
+                <a:solidFill>
+                  <a:srgbClr val="8A9098"/>
+                </a:solidFill>
+                <a:latin typeface="Consolas"/>
+                <a:ea typeface="Consolas"/>
+              </a:rPr>
+              <a:t>確度 </a:t>
+            </a:r>
+            <a:r>
+              <a:rPr sz="1000" b="1">
+                <a:solidFill>
+                  <a:srgbClr val="454B54"/>
+                </a:solidFill>
+                <a:latin typeface="Noto Sans JP"/>
+                <a:ea typeface="Noto Sans JP"/>
+              </a:rPr>
+              <a:t>中</a:t>
+            </a:r>
+          </a:p>
+        </p:txBody>
+      </p:sp>
+      <p:sp>
+        <p:nvSpPr>
+          <p:cNvPr id="40" name="Rectangle 39"/>
+          <p:cNvSpPr/>
+          <p:nvPr/>
+        </p:nvSpPr>
+        <p:spPr>
+          <a:xfrm>
+            <a:off x="777240" y="5764149"/>
+            <a:ext cx="9966960" cy="590931"/>
+          </a:xfrm>
+          <a:prstGeom prst="rect">
+            <a:avLst/>
+          </a:prstGeom>
+          <a:solidFill>
+            <a:srgbClr val="F3F4F6"/>
+          </a:solidFill>
+          <a:ln>
+            <a:noFill/>
+          </a:ln>
+          <a:effectLst/>
+        </p:spPr>
+        <p:style>
+          <a:lnRef idx="1">
+            <a:schemeClr val="accent1"/>
+          </a:lnRef>
+          <a:fillRef idx="3">
+            <a:schemeClr val="accent1"/>
+          </a:fillRef>
+          <a:effectRef idx="2">
+            <a:schemeClr val="accent1"/>
+          </a:effectRef>
+          <a:fontRef idx="minor">
+            <a:schemeClr val="lt1"/>
+          </a:fontRef>
+        </p:style>
+        <p:txBody>
+          <a:bodyPr rtlCol="0" anchor="ctr"/>
+          <a:lstStyle/>
+          <a:p>
+            <a:pPr algn="ctr"/>
+          </a:p>
+        </p:txBody>
+      </p:sp>
+      <p:sp>
+        <p:nvSpPr>
+          <p:cNvPr id="41" name="TextBox 40"/>
+          <p:cNvSpPr txBox="1"/>
+          <p:nvPr/>
+        </p:nvSpPr>
+        <p:spPr>
+          <a:xfrm>
+            <a:off x="886968" y="5764149"/>
+            <a:ext cx="2103120" cy="590931"/>
+          </a:xfrm>
+          <a:prstGeom prst="rect">
+            <a:avLst/>
+          </a:prstGeom>
+          <a:noFill/>
+        </p:spPr>
+        <p:txBody>
+          <a:bodyPr wrap="square" anchor="ctr" lIns="0" rIns="0" tIns="0" bIns="0">
+            <a:spAutoFit/>
+          </a:bodyPr>
+          <a:lstStyle/>
+          <a:p>
+            <a:pPr algn="l">
+              <a:lnSpc>
+                <a:spcPct val="102000"/>
+              </a:lnSpc>
+              <a:spcBef>
+                <a:spcPts val="0"/>
+              </a:spcBef>
+              <a:spcAft>
+                <a:spcPts val="400"/>
+              </a:spcAft>
+            </a:pPr>
+            <a:r>
+              <a:rPr sz="1150" b="1">
+                <a:solidFill>
+                  <a:srgbClr val="1A1D21"/>
+                </a:solidFill>
+                <a:latin typeface="Noto Sans JP"/>
+                <a:ea typeface="Noto Sans JP"/>
+              </a:rPr>
+              <a:t>NTTファシリティーズ</a:t>
+            </a:r>
+          </a:p>
+        </p:txBody>
+      </p:sp>
+      <p:sp>
+        <p:nvSpPr>
+          <p:cNvPr id="42" name="TextBox 41"/>
+          <p:cNvSpPr txBox="1"/>
+          <p:nvPr/>
+        </p:nvSpPr>
+        <p:spPr>
+          <a:xfrm>
+            <a:off x="3108960" y="5764149"/>
+            <a:ext cx="822960" cy="590931"/>
+          </a:xfrm>
+          <a:prstGeom prst="rect">
+            <a:avLst/>
+          </a:prstGeom>
+          <a:noFill/>
+        </p:spPr>
+        <p:txBody>
+          <a:bodyPr wrap="square" anchor="ctr" lIns="0" rIns="0" tIns="0" bIns="0">
+            <a:spAutoFit/>
+          </a:bodyPr>
+          <a:lstStyle/>
+          <a:p>
+            <a:pPr algn="l">
+              <a:lnSpc>
+                <a:spcPct val="106000"/>
+              </a:lnSpc>
+              <a:spcBef>
+                <a:spcPts val="0"/>
+              </a:spcBef>
+              <a:spcAft>
+                <a:spcPts val="400"/>
+              </a:spcAft>
+            </a:pPr>
+            <a:r>
+              <a:rPr sz="1050" b="0">
+                <a:solidFill>
+                  <a:srgbClr val="8A9098"/>
+                </a:solidFill>
+                <a:latin typeface="Consolas"/>
+                <a:ea typeface="Consolas"/>
+              </a:rPr>
+              <a:t>非上場</a:t>
+            </a:r>
+          </a:p>
+        </p:txBody>
+      </p:sp>
+      <p:sp>
+        <p:nvSpPr>
+          <p:cNvPr id="43" name="TextBox 42"/>
+          <p:cNvSpPr txBox="1"/>
+          <p:nvPr/>
+        </p:nvSpPr>
+        <p:spPr>
+          <a:xfrm>
+            <a:off x="4087368" y="5764149"/>
+            <a:ext cx="5943600" cy="590931"/>
+          </a:xfrm>
+          <a:prstGeom prst="rect">
+            <a:avLst/>
+          </a:prstGeom>
+          <a:noFill/>
+        </p:spPr>
+        <p:txBody>
+          <a:bodyPr wrap="square" anchor="ctr" lIns="0" rIns="0" tIns="0" bIns="0">
+            <a:spAutoFit/>
+          </a:bodyPr>
+          <a:lstStyle/>
+          <a:p>
+            <a:pPr algn="l">
+              <a:lnSpc>
+                <a:spcPct val="108000"/>
+              </a:lnSpc>
+              <a:spcBef>
+                <a:spcPts val="0"/>
+              </a:spcBef>
+              <a:spcAft>
+                <a:spcPts val="400"/>
+              </a:spcAft>
+            </a:pPr>
+            <a:r>
+              <a:rPr sz="1100" b="0">
+                <a:solidFill>
+                  <a:srgbClr val="3C4148"/>
+                </a:solidFill>
+                <a:latin typeface="Noto Sans JP"/>
+                <a:ea typeface="Noto Sans JP"/>
+              </a:rPr>
+              <a:t>高発熱GPUサーバー対応のDC冷却（液冷・チラーレス）の設計・施工力を強化（構築請負）。</a:t>
+            </a:r>
+          </a:p>
+        </p:txBody>
+      </p:sp>
+      <p:sp>
+        <p:nvSpPr>
+          <p:cNvPr id="44" name="TextBox 43"/>
+          <p:cNvSpPr txBox="1"/>
+          <p:nvPr/>
+        </p:nvSpPr>
+        <p:spPr>
+          <a:xfrm>
+            <a:off x="10030968" y="5764149"/>
+            <a:ext cx="640080" cy="590931"/>
+          </a:xfrm>
+          <a:prstGeom prst="rect">
+            <a:avLst/>
+          </a:prstGeom>
+          <a:noFill/>
+        </p:spPr>
+        <p:txBody>
+          <a:bodyPr wrap="square" anchor="ctr" lIns="0" rIns="0" tIns="0" bIns="0">
+            <a:spAutoFit/>
+          </a:bodyPr>
+          <a:lstStyle/>
+          <a:p>
+            <a:pPr algn="r">
+              <a:lnSpc>
+                <a:spcPct val="106000"/>
+              </a:lnSpc>
+              <a:spcBef>
+                <a:spcPts val="0"/>
+              </a:spcBef>
+              <a:spcAft>
+                <a:spcPts val="400"/>
+              </a:spcAft>
+            </a:pPr>
+            <a:r>
+              <a:rPr sz="900" b="0">
+                <a:solidFill>
+                  <a:srgbClr val="8A9098"/>
+                </a:solidFill>
+                <a:latin typeface="Consolas"/>
+                <a:ea typeface="Consolas"/>
+              </a:rPr>
+              <a:t>確度 </a:t>
+            </a:r>
+            <a:r>
+              <a:rPr sz="1000" b="1">
+                <a:solidFill>
+                  <a:srgbClr val="454B54"/>
+                </a:solidFill>
+                <a:latin typeface="Noto Sans JP"/>
+                <a:ea typeface="Noto Sans JP"/>
+              </a:rPr>
+              <a:t>中</a:t>
+            </a:r>
+          </a:p>
+        </p:txBody>
+      </p:sp>
+      <p:sp>
+        <p:nvSpPr>
+          <p:cNvPr id="45" name="Rectangle 44"/>
+          <p:cNvSpPr/>
+          <p:nvPr/>
+        </p:nvSpPr>
+        <p:spPr>
+          <a:xfrm>
+            <a:off x="777240" y="1627632"/>
+            <a:ext cx="9966960" cy="9144"/>
+          </a:xfrm>
+          <a:prstGeom prst="rect">
+            <a:avLst/>
+          </a:prstGeom>
+          <a:solidFill>
+            <a:srgbClr val="E2E4E9"/>
+          </a:solidFill>
+          <a:ln>
+            <a:noFill/>
+          </a:ln>
+          <a:effectLst/>
+        </p:spPr>
+        <p:style>
+          <a:lnRef idx="1">
+            <a:schemeClr val="accent1"/>
+          </a:lnRef>
+          <a:fillRef idx="3">
+            <a:schemeClr val="accent1"/>
+          </a:fillRef>
+          <a:effectRef idx="2">
+            <a:schemeClr val="accent1"/>
+          </a:effectRef>
+          <a:fontRef idx="minor">
+            <a:schemeClr val="lt1"/>
+          </a:fontRef>
+        </p:style>
+        <p:txBody>
+          <a:bodyPr rtlCol="0" anchor="ctr"/>
+          <a:lstStyle/>
+          <a:p>
+            <a:pPr algn="ctr"/>
+          </a:p>
+        </p:txBody>
+      </p:sp>
+      <p:sp>
+        <p:nvSpPr>
+          <p:cNvPr id="46" name="Rectangle 45"/>
+          <p:cNvSpPr/>
+          <p:nvPr/>
+        </p:nvSpPr>
+        <p:spPr>
+          <a:xfrm>
+            <a:off x="777240" y="2218563"/>
+            <a:ext cx="9966960" cy="9144"/>
+          </a:xfrm>
+          <a:prstGeom prst="rect">
+            <a:avLst/>
+          </a:prstGeom>
+          <a:solidFill>
+            <a:srgbClr val="E2E4E9"/>
+          </a:solidFill>
+          <a:ln>
+            <a:noFill/>
+          </a:ln>
+          <a:effectLst/>
+        </p:spPr>
+        <p:style>
+          <a:lnRef idx="1">
+            <a:schemeClr val="accent1"/>
+          </a:lnRef>
+          <a:fillRef idx="3">
+            <a:schemeClr val="accent1"/>
+          </a:fillRef>
+          <a:effectRef idx="2">
+            <a:schemeClr val="accent1"/>
+          </a:effectRef>
+          <a:fontRef idx="minor">
+            <a:schemeClr val="lt1"/>
+          </a:fontRef>
+        </p:style>
+        <p:txBody>
+          <a:bodyPr rtlCol="0" anchor="ctr"/>
+          <a:lstStyle/>
+          <a:p>
+            <a:pPr algn="ctr"/>
+          </a:p>
+        </p:txBody>
+      </p:sp>
+      <p:sp>
+        <p:nvSpPr>
+          <p:cNvPr id="47" name="Rectangle 46"/>
+          <p:cNvSpPr/>
+          <p:nvPr/>
+        </p:nvSpPr>
+        <p:spPr>
+          <a:xfrm>
+            <a:off x="777240" y="2809494"/>
+            <a:ext cx="9966960" cy="9144"/>
+          </a:xfrm>
+          <a:prstGeom prst="rect">
+            <a:avLst/>
+          </a:prstGeom>
+          <a:solidFill>
+            <a:srgbClr val="E2E4E9"/>
+          </a:solidFill>
+          <a:ln>
+            <a:noFill/>
+          </a:ln>
+          <a:effectLst/>
+        </p:spPr>
+        <p:style>
+          <a:lnRef idx="1">
+            <a:schemeClr val="accent1"/>
+          </a:lnRef>
+          <a:fillRef idx="3">
+            <a:schemeClr val="accent1"/>
+          </a:fillRef>
+          <a:effectRef idx="2">
+            <a:schemeClr val="accent1"/>
+          </a:effectRef>
+          <a:fontRef idx="minor">
+            <a:schemeClr val="lt1"/>
+          </a:fontRef>
+        </p:style>
+        <p:txBody>
+          <a:bodyPr rtlCol="0" anchor="ctr"/>
+          <a:lstStyle/>
+          <a:p>
+            <a:pPr algn="ctr"/>
+          </a:p>
+        </p:txBody>
+      </p:sp>
+      <p:sp>
+        <p:nvSpPr>
+          <p:cNvPr id="48" name="Rectangle 47"/>
+          <p:cNvSpPr/>
+          <p:nvPr/>
+        </p:nvSpPr>
+        <p:spPr>
+          <a:xfrm>
+            <a:off x="777240" y="3400425"/>
+            <a:ext cx="9966960" cy="9144"/>
+          </a:xfrm>
+          <a:prstGeom prst="rect">
+            <a:avLst/>
+          </a:prstGeom>
+          <a:solidFill>
+            <a:srgbClr val="E2E4E9"/>
+          </a:solidFill>
+          <a:ln>
+            <a:noFill/>
+          </a:ln>
+          <a:effectLst/>
+        </p:spPr>
+        <p:style>
+          <a:lnRef idx="1">
+            <a:schemeClr val="accent1"/>
+          </a:lnRef>
+          <a:fillRef idx="3">
+            <a:schemeClr val="accent1"/>
+          </a:fillRef>
+          <a:effectRef idx="2">
+            <a:schemeClr val="accent1"/>
+          </a:effectRef>
+          <a:fontRef idx="minor">
+            <a:schemeClr val="lt1"/>
+          </a:fontRef>
+        </p:style>
+        <p:txBody>
+          <a:bodyPr rtlCol="0" anchor="ctr"/>
+          <a:lstStyle/>
+          <a:p>
+            <a:pPr algn="ctr"/>
+          </a:p>
+        </p:txBody>
+      </p:sp>
+      <p:sp>
+        <p:nvSpPr>
+          <p:cNvPr id="49" name="Rectangle 48"/>
+          <p:cNvSpPr/>
+          <p:nvPr/>
+        </p:nvSpPr>
+        <p:spPr>
+          <a:xfrm>
+            <a:off x="777240" y="3991356"/>
+            <a:ext cx="9966960" cy="9144"/>
+          </a:xfrm>
+          <a:prstGeom prst="rect">
+            <a:avLst/>
+          </a:prstGeom>
+          <a:solidFill>
+            <a:srgbClr val="E2E4E9"/>
+          </a:solidFill>
+          <a:ln>
+            <a:noFill/>
+          </a:ln>
+          <a:effectLst/>
+        </p:spPr>
+        <p:style>
+          <a:lnRef idx="1">
+            <a:schemeClr val="accent1"/>
+          </a:lnRef>
+          <a:fillRef idx="3">
+            <a:schemeClr val="accent1"/>
+          </a:fillRef>
+          <a:effectRef idx="2">
+            <a:schemeClr val="accent1"/>
+          </a:effectRef>
+          <a:fontRef idx="minor">
+            <a:schemeClr val="lt1"/>
+          </a:fontRef>
+        </p:style>
+        <p:txBody>
+          <a:bodyPr rtlCol="0" anchor="ctr"/>
+          <a:lstStyle/>
+          <a:p>
+            <a:pPr algn="ctr"/>
+          </a:p>
+        </p:txBody>
+      </p:sp>
+      <p:sp>
+        <p:nvSpPr>
+          <p:cNvPr id="50" name="Rectangle 49"/>
+          <p:cNvSpPr/>
+          <p:nvPr/>
+        </p:nvSpPr>
+        <p:spPr>
+          <a:xfrm>
+            <a:off x="777240" y="4582287"/>
+            <a:ext cx="9966960" cy="9144"/>
+          </a:xfrm>
+          <a:prstGeom prst="rect">
+            <a:avLst/>
+          </a:prstGeom>
+          <a:solidFill>
+            <a:srgbClr val="E2E4E9"/>
+          </a:solidFill>
+          <a:ln>
+            <a:noFill/>
+          </a:ln>
+          <a:effectLst/>
+        </p:spPr>
+        <p:style>
+          <a:lnRef idx="1">
+            <a:schemeClr val="accent1"/>
+          </a:lnRef>
+          <a:fillRef idx="3">
+            <a:schemeClr val="accent1"/>
+          </a:fillRef>
+          <a:effectRef idx="2">
+            <a:schemeClr val="accent1"/>
+          </a:effectRef>
+          <a:fontRef idx="minor">
+            <a:schemeClr val="lt1"/>
+          </a:fontRef>
+        </p:style>
+        <p:txBody>
+          <a:bodyPr rtlCol="0" anchor="ctr"/>
+          <a:lstStyle/>
+          <a:p>
+            <a:pPr algn="ctr"/>
+          </a:p>
+        </p:txBody>
+      </p:sp>
+      <p:sp>
+        <p:nvSpPr>
+          <p:cNvPr id="51" name="Rectangle 50"/>
+          <p:cNvSpPr/>
+          <p:nvPr/>
+        </p:nvSpPr>
+        <p:spPr>
+          <a:xfrm>
+            <a:off x="777240" y="5173218"/>
+            <a:ext cx="9966960" cy="9144"/>
+          </a:xfrm>
+          <a:prstGeom prst="rect">
+            <a:avLst/>
+          </a:prstGeom>
+          <a:solidFill>
+            <a:srgbClr val="E2E4E9"/>
+          </a:solidFill>
+          <a:ln>
+            <a:noFill/>
+          </a:ln>
+          <a:effectLst/>
+        </p:spPr>
+        <p:style>
+          <a:lnRef idx="1">
+            <a:schemeClr val="accent1"/>
+          </a:lnRef>
+          <a:fillRef idx="3">
+            <a:schemeClr val="accent1"/>
+          </a:fillRef>
+          <a:effectRef idx="2">
+            <a:schemeClr val="accent1"/>
+          </a:effectRef>
+          <a:fontRef idx="minor">
+            <a:schemeClr val="lt1"/>
+          </a:fontRef>
+        </p:style>
+        <p:txBody>
+          <a:bodyPr rtlCol="0" anchor="ctr"/>
+          <a:lstStyle/>
+          <a:p>
+            <a:pPr algn="ctr"/>
+          </a:p>
+        </p:txBody>
+      </p:sp>
+      <p:sp>
+        <p:nvSpPr>
+          <p:cNvPr id="52" name="Rectangle 51"/>
+          <p:cNvSpPr/>
+          <p:nvPr/>
+        </p:nvSpPr>
+        <p:spPr>
+          <a:xfrm>
+            <a:off x="777240" y="5764149"/>
+            <a:ext cx="9966960" cy="9144"/>
+          </a:xfrm>
+          <a:prstGeom prst="rect">
+            <a:avLst/>
+          </a:prstGeom>
+          <a:solidFill>
+            <a:srgbClr val="E2E4E9"/>
+          </a:solidFill>
+          <a:ln>
+            <a:noFill/>
+          </a:ln>
+          <a:effectLst/>
+        </p:spPr>
+        <p:style>
+          <a:lnRef idx="1">
+            <a:schemeClr val="accent1"/>
+          </a:lnRef>
+          <a:fillRef idx="3">
+            <a:schemeClr val="accent1"/>
+          </a:fillRef>
+          <a:effectRef idx="2">
+            <a:schemeClr val="accent1"/>
+          </a:effectRef>
+          <a:fontRef idx="minor">
+            <a:schemeClr val="lt1"/>
+          </a:fontRef>
+        </p:style>
+        <p:txBody>
+          <a:bodyPr rtlCol="0" anchor="ctr"/>
+          <a:lstStyle/>
+          <a:p>
+            <a:pPr algn="ctr"/>
+          </a:p>
+        </p:txBody>
+      </p:sp>
+      <p:sp>
+        <p:nvSpPr>
+          <p:cNvPr id="53" name="Rectangle 52"/>
+          <p:cNvSpPr/>
+          <p:nvPr/>
+        </p:nvSpPr>
+        <p:spPr>
+          <a:xfrm>
+            <a:off x="777240" y="6355080"/>
+            <a:ext cx="9966960" cy="9144"/>
+          </a:xfrm>
+          <a:prstGeom prst="rect">
+            <a:avLst/>
+          </a:prstGeom>
+          <a:solidFill>
+            <a:srgbClr val="E2E4E9"/>
+          </a:solidFill>
+          <a:ln>
+            <a:noFill/>
+          </a:ln>
+          <a:effectLst/>
+        </p:spPr>
+        <p:style>
+          <a:lnRef idx="1">
+            <a:schemeClr val="accent1"/>
+          </a:lnRef>
+          <a:fillRef idx="3">
+            <a:schemeClr val="accent1"/>
+          </a:fillRef>
+          <a:effectRef idx="2">
+            <a:schemeClr val="accent1"/>
+          </a:effectRef>
+          <a:fontRef idx="minor">
+            <a:schemeClr val="lt1"/>
+          </a:fontRef>
+        </p:style>
+        <p:txBody>
+          <a:bodyPr rtlCol="0" anchor="ctr"/>
+          <a:lstStyle/>
+          <a:p>
+            <a:pPr algn="ctr"/>
+          </a:p>
+        </p:txBody>
+      </p:sp>
+    </p:spTree>
+  </p:cSld>
+  <p:clrMapOvr>
+    <a:masterClrMapping/>
+  </p:clrMapOvr>
+</p:sld>
+</file>
+
 <file path=ppt/slides/slide2.xml><?xml version="1.0" encoding="utf-8"?>
 <p:sld xmlns:a="http://schemas.openxmlformats.org/drawingml/2006/main" xmlns:p="http://schemas.openxmlformats.org/presentationml/2006/main" xmlns:r="http://schemas.openxmlformats.org/officeDocument/2006/relationships">
   <p:cSld>
@@ -19988,11 +22449,11 @@
         <p:spPr>
           <a:xfrm>
             <a:off x="9747504" y="1325880"/>
-            <a:ext cx="1664208" cy="822960"/>
+            <a:ext cx="1664208" cy="3703320"/>
           </a:xfrm>
           <a:prstGeom prst="roundRect">
             <a:avLst>
-              <a:gd name="adj" fmla="val 6000"/>
+              <a:gd name="adj" fmla="val 5000"/>
             </a:avLst>
           </a:prstGeom>
           <a:solidFill>
@@ -20033,85 +22494,359 @@
         </p:nvSpPr>
         <p:spPr>
           <a:xfrm>
-            <a:off x="9747504" y="1325880"/>
-            <a:ext cx="1664208" cy="822960"/>
-          </a:xfrm>
-          <a:prstGeom prst="rect">
-            <a:avLst/>
-          </a:prstGeom>
-          <a:noFill/>
-        </p:spPr>
-        <p:txBody>
-          <a:bodyPr wrap="square" anchor="ctr" lIns="0" rIns="0" tIns="0" bIns="0">
-            <a:spAutoFit/>
-          </a:bodyPr>
-          <a:lstStyle/>
-          <a:p>
-            <a:pPr algn="ctr">
-              <a:lnSpc>
-                <a:spcPct val="100000"/>
-              </a:lnSpc>
-              <a:spcBef>
-                <a:spcPts val="0"/>
-              </a:spcBef>
-              <a:spcAft>
-                <a:spcPts val="0"/>
-              </a:spcAft>
-            </a:pPr>
-            <a:r>
-              <a:rPr sz="800" b="1" spc="100">
+            <a:off x="9875520" y="1453895"/>
+            <a:ext cx="1408176" cy="822960"/>
+          </a:xfrm>
+          <a:prstGeom prst="rect">
+            <a:avLst/>
+          </a:prstGeom>
+          <a:noFill/>
+        </p:spPr>
+        <p:txBody>
+          <a:bodyPr wrap="square" anchor="t" lIns="0" rIns="0" tIns="0" bIns="0">
+            <a:spAutoFit/>
+          </a:bodyPr>
+          <a:lstStyle/>
+          <a:p>
+            <a:pPr algn="l">
+              <a:lnSpc>
+                <a:spcPct val="105000"/>
+              </a:lnSpc>
+              <a:spcBef>
+                <a:spcPts val="0"/>
+              </a:spcBef>
+              <a:spcAft>
+                <a:spcPts val="100"/>
+              </a:spcAft>
+            </a:pPr>
+            <a:r>
+              <a:rPr sz="750" b="1" spc="100">
                 <a:solidFill>
                   <a:srgbClr val="C7CFDB"/>
                 </a:solidFill>
                 <a:latin typeface="Consolas"/>
                 <a:ea typeface="Consolas"/>
               </a:rPr>
-              <a:t>価値実現</a:t>
-            </a:r>
-          </a:p>
-          <a:p>
-            <a:pPr algn="ctr">
-              <a:lnSpc>
-                <a:spcPct val="100000"/>
-              </a:lnSpc>
-              <a:spcBef>
-                <a:spcPts val="0"/>
-              </a:spcBef>
-              <a:spcAft>
-                <a:spcPts val="0"/>
-              </a:spcAft>
-            </a:pPr>
-            <a:r>
-              <a:rPr sz="1250" b="1">
+              <a:t>最終工程</a:t>
+            </a:r>
+          </a:p>
+          <a:p>
+            <a:pPr algn="l">
+              <a:lnSpc>
+                <a:spcPct val="105000"/>
+              </a:lnSpc>
+              <a:spcBef>
+                <a:spcPts val="0"/>
+              </a:spcBef>
+              <a:spcAft>
+                <a:spcPts val="100"/>
+              </a:spcAft>
+            </a:pPr>
+            <a:r>
+              <a:rPr sz="1050" b="1">
                 <a:solidFill>
                   <a:srgbClr val="FFFFFF"/>
                 </a:solidFill>
                 <a:latin typeface="Noto Sans JP"/>
                 <a:ea typeface="Noto Sans JP"/>
               </a:rPr>
-              <a:t>AIサービス</a:t>
-            </a:r>
-          </a:p>
-          <a:p>
-            <a:pPr algn="ctr">
-              <a:lnSpc>
-                <a:spcPct val="100000"/>
-              </a:lnSpc>
-              <a:spcBef>
-                <a:spcPts val="0"/>
-              </a:spcBef>
-              <a:spcAft>
-                <a:spcPts val="0"/>
-              </a:spcAft>
-            </a:pPr>
-            <a:r>
-              <a:rPr sz="1000" b="1">
-                <a:solidFill>
-                  <a:srgbClr val="FFFFFF"/>
+              <a:t>DC構築・IT基盤SI</a:t>
+            </a:r>
+          </a:p>
+          <a:p>
+            <a:pPr algn="l">
+              <a:lnSpc>
+                <a:spcPct val="105000"/>
+              </a:lnSpc>
+              <a:spcBef>
+                <a:spcPts val="0"/>
+              </a:spcBef>
+              <a:spcAft>
+                <a:spcPts val="100"/>
+              </a:spcAft>
+            </a:pPr>
+            <a:r>
+              <a:rPr sz="850" b="0">
+                <a:solidFill>
+                  <a:srgbClr val="C7CFDB"/>
                 </a:solidFill>
                 <a:latin typeface="Noto Sans JP"/>
                 <a:ea typeface="Noto Sans JP"/>
               </a:rPr>
+              <a:t>／DC運営</a:t>
+            </a:r>
+          </a:p>
+        </p:txBody>
+      </p:sp>
+      <p:sp>
+        <p:nvSpPr>
+          <p:cNvPr id="12" name="TextBox 11"/>
+          <p:cNvSpPr txBox="1"/>
+          <p:nvPr/>
+        </p:nvSpPr>
+        <p:spPr>
+          <a:xfrm>
+            <a:off x="9875520" y="2286000"/>
+            <a:ext cx="1408176" cy="219456"/>
+          </a:xfrm>
+          <a:prstGeom prst="rect">
+            <a:avLst/>
+          </a:prstGeom>
+          <a:noFill/>
+        </p:spPr>
+        <p:txBody>
+          <a:bodyPr wrap="square" anchor="t" lIns="0" rIns="0" tIns="0" bIns="0">
+            <a:spAutoFit/>
+          </a:bodyPr>
+          <a:lstStyle/>
+          <a:p>
+            <a:pPr algn="l">
+              <a:lnSpc>
+                <a:spcPct val="106000"/>
+              </a:lnSpc>
+              <a:spcBef>
+                <a:spcPts val="0"/>
+              </a:spcBef>
+              <a:spcAft>
+                <a:spcPts val="400"/>
+              </a:spcAft>
+            </a:pPr>
+            <a:r>
+              <a:rPr sz="750" b="0">
+                <a:solidFill>
+                  <a:srgbClr val="9AA6B6"/>
+                </a:solidFill>
+                <a:latin typeface="Noto Sans JP"/>
+                <a:ea typeface="Noto Sans JP"/>
+              </a:rPr>
+              <a:t>箱の中身を構築し“稼働”へ</a:t>
+            </a:r>
+          </a:p>
+        </p:txBody>
+      </p:sp>
+      <p:sp>
+        <p:nvSpPr>
+          <p:cNvPr id="13" name="TextBox 12"/>
+          <p:cNvSpPr txBox="1"/>
+          <p:nvPr/>
+        </p:nvSpPr>
+        <p:spPr>
+          <a:xfrm>
+            <a:off x="9875520" y="2532888"/>
+            <a:ext cx="1408176" cy="1234440"/>
+          </a:xfrm>
+          <a:prstGeom prst="rect">
+            <a:avLst/>
+          </a:prstGeom>
+          <a:noFill/>
+        </p:spPr>
+        <p:txBody>
+          <a:bodyPr wrap="square" anchor="t" lIns="0" rIns="0" tIns="0" bIns="0">
+            <a:spAutoFit/>
+          </a:bodyPr>
+          <a:lstStyle/>
+          <a:p>
+            <a:pPr algn="l">
+              <a:lnSpc>
+                <a:spcPct val="120000"/>
+              </a:lnSpc>
+              <a:spcBef>
+                <a:spcPts val="0"/>
+              </a:spcBef>
+              <a:spcAft>
+                <a:spcPts val="200"/>
+              </a:spcAft>
+            </a:pPr>
+            <a:r>
+              <a:rPr sz="700" b="1">
+                <a:solidFill>
+                  <a:srgbClr val="9AA6B6"/>
+                </a:solidFill>
+                <a:latin typeface="Consolas"/>
+                <a:ea typeface="Consolas"/>
+              </a:rPr>
+              <a:t>代表企業</a:t>
+            </a:r>
+          </a:p>
+          <a:p>
+            <a:pPr algn="l">
+              <a:lnSpc>
+                <a:spcPct val="120000"/>
+              </a:lnSpc>
+              <a:spcBef>
+                <a:spcPts val="0"/>
+              </a:spcBef>
+              <a:spcAft>
+                <a:spcPts val="200"/>
+              </a:spcAft>
+            </a:pPr>
+            <a:r>
+              <a:rPr sz="850" b="1">
+                <a:solidFill>
+                  <a:srgbClr val="EAEEF4"/>
+                </a:solidFill>
+                <a:latin typeface="Noto Sans JP"/>
+                <a:ea typeface="Noto Sans JP"/>
+              </a:rPr>
+              <a:t>さくら・IIJ・NTTデータ・CTC・兼松エレ・NECネッツ</a:t>
+            </a:r>
+          </a:p>
+        </p:txBody>
+      </p:sp>
+      <p:sp>
+        <p:nvSpPr>
+          <p:cNvPr id="14" name="Rectangle 13"/>
+          <p:cNvSpPr/>
+          <p:nvPr/>
+        </p:nvSpPr>
+        <p:spPr>
+          <a:xfrm>
+            <a:off x="9875520" y="3931920"/>
+            <a:ext cx="1408176" cy="10972"/>
+          </a:xfrm>
+          <a:prstGeom prst="rect">
+            <a:avLst/>
+          </a:prstGeom>
+          <a:solidFill>
+            <a:srgbClr val="33425A"/>
+          </a:solidFill>
+          <a:ln>
+            <a:noFill/>
+          </a:ln>
+          <a:effectLst/>
+        </p:spPr>
+        <p:style>
+          <a:lnRef idx="1">
+            <a:schemeClr val="accent1"/>
+          </a:lnRef>
+          <a:fillRef idx="3">
+            <a:schemeClr val="accent1"/>
+          </a:fillRef>
+          <a:effectRef idx="2">
+            <a:schemeClr val="accent1"/>
+          </a:effectRef>
+          <a:fontRef idx="minor">
+            <a:schemeClr val="lt1"/>
+          </a:fontRef>
+        </p:style>
+        <p:txBody>
+          <a:bodyPr rtlCol="0" anchor="ctr"/>
+          <a:lstStyle/>
+          <a:p>
+            <a:pPr algn="ctr"/>
+          </a:p>
+        </p:txBody>
+      </p:sp>
+      <p:sp>
+        <p:nvSpPr>
+          <p:cNvPr id="15" name="TextBox 14"/>
+          <p:cNvSpPr txBox="1"/>
+          <p:nvPr/>
+        </p:nvSpPr>
+        <p:spPr>
+          <a:xfrm>
+            <a:off x="9875520" y="4023360"/>
+            <a:ext cx="1408176" cy="219456"/>
+          </a:xfrm>
+          <a:prstGeom prst="rect">
+            <a:avLst/>
+          </a:prstGeom>
+          <a:noFill/>
+        </p:spPr>
+        <p:txBody>
+          <a:bodyPr wrap="square" anchor="t" lIns="0" rIns="0" tIns="0" bIns="0">
+            <a:spAutoFit/>
+          </a:bodyPr>
+          <a:lstStyle/>
+          <a:p>
+            <a:pPr algn="l">
+              <a:lnSpc>
+                <a:spcPct val="106000"/>
+              </a:lnSpc>
+              <a:spcBef>
+                <a:spcPts val="0"/>
+              </a:spcBef>
+              <a:spcAft>
+                <a:spcPts val="400"/>
+              </a:spcAft>
+            </a:pPr>
+            <a:r>
+              <a:rPr sz="750" b="1">
+                <a:solidFill>
+                  <a:srgbClr val="C7CFDB"/>
+                </a:solidFill>
+                <a:latin typeface="Consolas"/>
+                <a:ea typeface="Consolas"/>
+              </a:rPr>
+              <a:t>A 発注者（運営）＋ B 請負（構築）</a:t>
+            </a:r>
+          </a:p>
+        </p:txBody>
+      </p:sp>
+      <p:sp>
+        <p:nvSpPr>
+          <p:cNvPr id="16" name="TextBox 15"/>
+          <p:cNvSpPr txBox="1"/>
+          <p:nvPr/>
+        </p:nvSpPr>
+        <p:spPr>
+          <a:xfrm>
+            <a:off x="9875520" y="4389120"/>
+            <a:ext cx="1408176" cy="502920"/>
+          </a:xfrm>
+          <a:prstGeom prst="rect">
+            <a:avLst/>
+          </a:prstGeom>
+          <a:noFill/>
+        </p:spPr>
+        <p:txBody>
+          <a:bodyPr wrap="square" anchor="t" lIns="0" rIns="0" tIns="0" bIns="0">
+            <a:spAutoFit/>
+          </a:bodyPr>
+          <a:lstStyle/>
+          <a:p>
+            <a:pPr algn="l">
+              <a:lnSpc>
+                <a:spcPct val="100000"/>
+              </a:lnSpc>
+              <a:spcBef>
+                <a:spcPts val="0"/>
+              </a:spcBef>
+              <a:spcAft>
+                <a:spcPts val="0"/>
+              </a:spcAft>
+            </a:pPr>
+            <a:r>
+              <a:rPr sz="1150" b="1">
+                <a:solidFill>
+                  <a:srgbClr val="FFFFFF"/>
+                </a:solidFill>
+                <a:latin typeface="Noto Sans JP"/>
+                <a:ea typeface="Noto Sans JP"/>
+              </a:rPr>
+              <a:t>→ AIサービス</a:t>
+            </a:r>
+          </a:p>
+          <a:p>
+            <a:pPr algn="l">
+              <a:lnSpc>
+                <a:spcPct val="100000"/>
+              </a:lnSpc>
+              <a:spcBef>
+                <a:spcPts val="0"/>
+              </a:spcBef>
+              <a:spcAft>
+                <a:spcPts val="0"/>
+              </a:spcAft>
+            </a:pPr>
+            <a:r>
+              <a:rPr sz="950" b="1">
+                <a:solidFill>
+                  <a:srgbClr val="FFFFFF"/>
+                </a:solidFill>
+                <a:latin typeface="Noto Sans JP"/>
+                <a:ea typeface="Noto Sans JP"/>
+              </a:rPr>
               <a:t>稼働</a:t>
             </a:r>
           </a:p>
@@ -20119,7 +22854,7 @@
       </p:sp>
       <p:sp>
         <p:nvSpPr>
-          <p:cNvPr id="12" name="Chevron 11"/>
+          <p:cNvPr id="17" name="Chevron 16"/>
           <p:cNvSpPr/>
           <p:nvPr/>
         </p:nvSpPr>
@@ -20161,7 +22896,7 @@
       </p:sp>
       <p:sp>
         <p:nvSpPr>
-          <p:cNvPr id="13" name="TextBox 12"/>
+          <p:cNvPr id="18" name="TextBox 17"/>
           <p:cNvSpPr txBox="1"/>
           <p:nvPr/>
         </p:nvSpPr>
@@ -20230,7 +22965,7 @@
       </p:sp>
       <p:sp>
         <p:nvSpPr>
-          <p:cNvPr id="14" name="Rounded Rectangle 13"/>
+          <p:cNvPr id="19" name="Rounded Rectangle 18"/>
           <p:cNvSpPr/>
           <p:nvPr/>
         </p:nvSpPr>
@@ -20278,7 +23013,7 @@
       </p:sp>
       <p:sp>
         <p:nvSpPr>
-          <p:cNvPr id="15" name="TextBox 14"/>
+          <p:cNvPr id="20" name="TextBox 19"/>
           <p:cNvSpPr txBox="1"/>
           <p:nvPr/>
         </p:nvSpPr>
@@ -20324,7 +23059,7 @@
       </p:sp>
       <p:sp>
         <p:nvSpPr>
-          <p:cNvPr id="16" name="TextBox 15"/>
+          <p:cNvPr id="21" name="TextBox 20"/>
           <p:cNvSpPr txBox="1"/>
           <p:nvPr/>
         </p:nvSpPr>
@@ -20370,7 +23105,7 @@
       </p:sp>
       <p:sp>
         <p:nvSpPr>
-          <p:cNvPr id="17" name="TextBox 16"/>
+          <p:cNvPr id="22" name="TextBox 21"/>
           <p:cNvSpPr txBox="1"/>
           <p:nvPr/>
         </p:nvSpPr>
@@ -20416,7 +23151,7 @@
       </p:sp>
       <p:sp>
         <p:nvSpPr>
-          <p:cNvPr id="18" name="Rectangle 17"/>
+          <p:cNvPr id="23" name="Rectangle 22"/>
           <p:cNvSpPr/>
           <p:nvPr/>
         </p:nvSpPr>
@@ -20460,7 +23195,7 @@
       </p:sp>
       <p:sp>
         <p:nvSpPr>
-          <p:cNvPr id="19" name="TextBox 18"/>
+          <p:cNvPr id="24" name="TextBox 23"/>
           <p:cNvSpPr txBox="1"/>
           <p:nvPr/>
         </p:nvSpPr>
@@ -20529,7 +23264,7 @@
       </p:sp>
       <p:sp>
         <p:nvSpPr>
-          <p:cNvPr id="20" name="TextBox 19"/>
+          <p:cNvPr id="25" name="TextBox 24"/>
           <p:cNvSpPr txBox="1"/>
           <p:nvPr/>
         </p:nvSpPr>
@@ -20575,7 +23310,7 @@
       </p:sp>
       <p:sp>
         <p:nvSpPr>
-          <p:cNvPr id="21" name="TextBox 20"/>
+          <p:cNvPr id="26" name="TextBox 25"/>
           <p:cNvSpPr txBox="1"/>
           <p:nvPr/>
         </p:nvSpPr>
@@ -20621,7 +23356,7 @@
       </p:sp>
       <p:sp>
         <p:nvSpPr>
-          <p:cNvPr id="22" name="Chevron 21"/>
+          <p:cNvPr id="27" name="Chevron 26"/>
           <p:cNvSpPr/>
           <p:nvPr/>
         </p:nvSpPr>
@@ -20663,7 +23398,7 @@
       </p:sp>
       <p:sp>
         <p:nvSpPr>
-          <p:cNvPr id="23" name="TextBox 22"/>
+          <p:cNvPr id="28" name="TextBox 27"/>
           <p:cNvSpPr txBox="1"/>
           <p:nvPr/>
         </p:nvSpPr>
@@ -20732,7 +23467,7 @@
       </p:sp>
       <p:sp>
         <p:nvSpPr>
-          <p:cNvPr id="24" name="Rounded Rectangle 23"/>
+          <p:cNvPr id="29" name="Rounded Rectangle 28"/>
           <p:cNvSpPr/>
           <p:nvPr/>
         </p:nvSpPr>
@@ -20780,7 +23515,7 @@
       </p:sp>
       <p:sp>
         <p:nvSpPr>
-          <p:cNvPr id="25" name="TextBox 24"/>
+          <p:cNvPr id="30" name="TextBox 29"/>
           <p:cNvSpPr txBox="1"/>
           <p:nvPr/>
         </p:nvSpPr>
@@ -20826,7 +23561,7 @@
       </p:sp>
       <p:sp>
         <p:nvSpPr>
-          <p:cNvPr id="26" name="TextBox 25"/>
+          <p:cNvPr id="31" name="TextBox 30"/>
           <p:cNvSpPr txBox="1"/>
           <p:nvPr/>
         </p:nvSpPr>
@@ -20872,7 +23607,7 @@
       </p:sp>
       <p:sp>
         <p:nvSpPr>
-          <p:cNvPr id="27" name="TextBox 26"/>
+          <p:cNvPr id="32" name="TextBox 31"/>
           <p:cNvSpPr txBox="1"/>
           <p:nvPr/>
         </p:nvSpPr>
@@ -20918,7 +23653,7 @@
       </p:sp>
       <p:sp>
         <p:nvSpPr>
-          <p:cNvPr id="28" name="Rectangle 27"/>
+          <p:cNvPr id="33" name="Rectangle 32"/>
           <p:cNvSpPr/>
           <p:nvPr/>
         </p:nvSpPr>
@@ -20962,7 +23697,7 @@
       </p:sp>
       <p:sp>
         <p:nvSpPr>
-          <p:cNvPr id="29" name="TextBox 28"/>
+          <p:cNvPr id="34" name="TextBox 33"/>
           <p:cNvSpPr txBox="1"/>
           <p:nvPr/>
         </p:nvSpPr>
@@ -21031,7 +23766,7 @@
       </p:sp>
       <p:sp>
         <p:nvSpPr>
-          <p:cNvPr id="30" name="TextBox 29"/>
+          <p:cNvPr id="35" name="TextBox 34"/>
           <p:cNvSpPr txBox="1"/>
           <p:nvPr/>
         </p:nvSpPr>
@@ -21077,7 +23812,7 @@
       </p:sp>
       <p:sp>
         <p:nvSpPr>
-          <p:cNvPr id="31" name="TextBox 30"/>
+          <p:cNvPr id="36" name="TextBox 35"/>
           <p:cNvSpPr txBox="1"/>
           <p:nvPr/>
         </p:nvSpPr>
@@ -21123,7 +23858,7 @@
       </p:sp>
       <p:sp>
         <p:nvSpPr>
-          <p:cNvPr id="32" name="Chevron 31"/>
+          <p:cNvPr id="37" name="Chevron 36"/>
           <p:cNvSpPr/>
           <p:nvPr/>
         </p:nvSpPr>
@@ -21165,7 +23900,7 @@
       </p:sp>
       <p:sp>
         <p:nvSpPr>
-          <p:cNvPr id="33" name="TextBox 32"/>
+          <p:cNvPr id="38" name="TextBox 37"/>
           <p:cNvSpPr txBox="1"/>
           <p:nvPr/>
         </p:nvSpPr>
@@ -21234,7 +23969,7 @@
       </p:sp>
       <p:sp>
         <p:nvSpPr>
-          <p:cNvPr id="34" name="Rounded Rectangle 33"/>
+          <p:cNvPr id="39" name="Rounded Rectangle 38"/>
           <p:cNvSpPr/>
           <p:nvPr/>
         </p:nvSpPr>
@@ -21282,7 +24017,7 @@
       </p:sp>
       <p:sp>
         <p:nvSpPr>
-          <p:cNvPr id="35" name="TextBox 34"/>
+          <p:cNvPr id="40" name="TextBox 39"/>
           <p:cNvSpPr txBox="1"/>
           <p:nvPr/>
         </p:nvSpPr>
@@ -21328,7 +24063,7 @@
       </p:sp>
       <p:sp>
         <p:nvSpPr>
-          <p:cNvPr id="36" name="TextBox 35"/>
+          <p:cNvPr id="41" name="TextBox 40"/>
           <p:cNvSpPr txBox="1"/>
           <p:nvPr/>
         </p:nvSpPr>
@@ -21374,7 +24109,7 @@
       </p:sp>
       <p:sp>
         <p:nvSpPr>
-          <p:cNvPr id="37" name="TextBox 36"/>
+          <p:cNvPr id="42" name="TextBox 41"/>
           <p:cNvSpPr txBox="1"/>
           <p:nvPr/>
         </p:nvSpPr>
@@ -21420,7 +24155,7 @@
       </p:sp>
       <p:sp>
         <p:nvSpPr>
-          <p:cNvPr id="38" name="Rectangle 37"/>
+          <p:cNvPr id="43" name="Rectangle 42"/>
           <p:cNvSpPr/>
           <p:nvPr/>
         </p:nvSpPr>
@@ -21464,7 +24199,7 @@
       </p:sp>
       <p:sp>
         <p:nvSpPr>
-          <p:cNvPr id="39" name="TextBox 38"/>
+          <p:cNvPr id="44" name="TextBox 43"/>
           <p:cNvSpPr txBox="1"/>
           <p:nvPr/>
         </p:nvSpPr>
@@ -21533,7 +24268,7 @@
       </p:sp>
       <p:sp>
         <p:nvSpPr>
-          <p:cNvPr id="40" name="TextBox 39"/>
+          <p:cNvPr id="45" name="TextBox 44"/>
           <p:cNvSpPr txBox="1"/>
           <p:nvPr/>
         </p:nvSpPr>
@@ -21579,7 +24314,7 @@
       </p:sp>
       <p:sp>
         <p:nvSpPr>
-          <p:cNvPr id="41" name="TextBox 40"/>
+          <p:cNvPr id="46" name="TextBox 45"/>
           <p:cNvSpPr txBox="1"/>
           <p:nvPr/>
         </p:nvSpPr>
@@ -21625,7 +24360,7 @@
       </p:sp>
       <p:sp>
         <p:nvSpPr>
-          <p:cNvPr id="42" name="Chevron 41"/>
+          <p:cNvPr id="47" name="Chevron 46"/>
           <p:cNvSpPr/>
           <p:nvPr/>
         </p:nvSpPr>
@@ -21667,7 +24402,7 @@
       </p:sp>
       <p:sp>
         <p:nvSpPr>
-          <p:cNvPr id="43" name="TextBox 42"/>
+          <p:cNvPr id="48" name="TextBox 47"/>
           <p:cNvSpPr txBox="1"/>
           <p:nvPr/>
         </p:nvSpPr>
@@ -21736,7 +24471,7 @@
       </p:sp>
       <p:sp>
         <p:nvSpPr>
-          <p:cNvPr id="44" name="Rounded Rectangle 43"/>
+          <p:cNvPr id="49" name="Rounded Rectangle 48"/>
           <p:cNvSpPr/>
           <p:nvPr/>
         </p:nvSpPr>
@@ -21784,7 +24519,7 @@
       </p:sp>
       <p:sp>
         <p:nvSpPr>
-          <p:cNvPr id="45" name="TextBox 44"/>
+          <p:cNvPr id="50" name="TextBox 49"/>
           <p:cNvSpPr txBox="1"/>
           <p:nvPr/>
         </p:nvSpPr>
@@ -21830,7 +24565,7 @@
       </p:sp>
       <p:sp>
         <p:nvSpPr>
-          <p:cNvPr id="46" name="TextBox 45"/>
+          <p:cNvPr id="51" name="TextBox 50"/>
           <p:cNvSpPr txBox="1"/>
           <p:nvPr/>
         </p:nvSpPr>
@@ -21876,7 +24611,7 @@
       </p:sp>
       <p:sp>
         <p:nvSpPr>
-          <p:cNvPr id="47" name="TextBox 46"/>
+          <p:cNvPr id="52" name="TextBox 51"/>
           <p:cNvSpPr txBox="1"/>
           <p:nvPr/>
         </p:nvSpPr>
@@ -21922,7 +24657,7 @@
       </p:sp>
       <p:sp>
         <p:nvSpPr>
-          <p:cNvPr id="48" name="Rectangle 47"/>
+          <p:cNvPr id="53" name="Rectangle 52"/>
           <p:cNvSpPr/>
           <p:nvPr/>
         </p:nvSpPr>
@@ -21966,7 +24701,7 @@
       </p:sp>
       <p:sp>
         <p:nvSpPr>
-          <p:cNvPr id="49" name="TextBox 48"/>
+          <p:cNvPr id="54" name="TextBox 53"/>
           <p:cNvSpPr txBox="1"/>
           <p:nvPr/>
         </p:nvSpPr>
@@ -22035,7 +24770,7 @@
       </p:sp>
       <p:sp>
         <p:nvSpPr>
-          <p:cNvPr id="50" name="TextBox 49"/>
+          <p:cNvPr id="55" name="TextBox 54"/>
           <p:cNvSpPr txBox="1"/>
           <p:nvPr/>
         </p:nvSpPr>
@@ -22081,7 +24816,7 @@
       </p:sp>
       <p:sp>
         <p:nvSpPr>
-          <p:cNvPr id="51" name="TextBox 50"/>
+          <p:cNvPr id="56" name="TextBox 55"/>
           <p:cNvSpPr txBox="1"/>
           <p:nvPr/>
         </p:nvSpPr>
@@ -22127,7 +24862,7 @@
       </p:sp>
       <p:sp>
         <p:nvSpPr>
-          <p:cNvPr id="52" name="Chevron 51"/>
+          <p:cNvPr id="57" name="Chevron 56"/>
           <p:cNvSpPr/>
           <p:nvPr/>
         </p:nvSpPr>
@@ -22169,7 +24904,7 @@
       </p:sp>
       <p:sp>
         <p:nvSpPr>
-          <p:cNvPr id="53" name="TextBox 52"/>
+          <p:cNvPr id="58" name="TextBox 57"/>
           <p:cNvSpPr txBox="1"/>
           <p:nvPr/>
         </p:nvSpPr>
@@ -22238,7 +24973,7 @@
       </p:sp>
       <p:sp>
         <p:nvSpPr>
-          <p:cNvPr id="54" name="Rounded Rectangle 53"/>
+          <p:cNvPr id="59" name="Rounded Rectangle 58"/>
           <p:cNvSpPr/>
           <p:nvPr/>
         </p:nvSpPr>
@@ -22286,7 +25021,7 @@
       </p:sp>
       <p:sp>
         <p:nvSpPr>
-          <p:cNvPr id="55" name="TextBox 54"/>
+          <p:cNvPr id="60" name="TextBox 59"/>
           <p:cNvSpPr txBox="1"/>
           <p:nvPr/>
         </p:nvSpPr>
@@ -22332,7 +25067,7 @@
       </p:sp>
       <p:sp>
         <p:nvSpPr>
-          <p:cNvPr id="56" name="TextBox 55"/>
+          <p:cNvPr id="61" name="TextBox 60"/>
           <p:cNvSpPr txBox="1"/>
           <p:nvPr/>
         </p:nvSpPr>
@@ -22378,7 +25113,7 @@
       </p:sp>
       <p:sp>
         <p:nvSpPr>
-          <p:cNvPr id="57" name="TextBox 56"/>
+          <p:cNvPr id="62" name="TextBox 61"/>
           <p:cNvSpPr txBox="1"/>
           <p:nvPr/>
         </p:nvSpPr>
@@ -22424,7 +25159,7 @@
       </p:sp>
       <p:sp>
         <p:nvSpPr>
-          <p:cNvPr id="58" name="Rectangle 57"/>
+          <p:cNvPr id="63" name="Rectangle 62"/>
           <p:cNvSpPr/>
           <p:nvPr/>
         </p:nvSpPr>
@@ -22468,7 +25203,7 @@
       </p:sp>
       <p:sp>
         <p:nvSpPr>
-          <p:cNvPr id="59" name="TextBox 58"/>
+          <p:cNvPr id="64" name="TextBox 63"/>
           <p:cNvSpPr txBox="1"/>
           <p:nvPr/>
         </p:nvSpPr>
@@ -22537,7 +25272,7 @@
       </p:sp>
       <p:sp>
         <p:nvSpPr>
-          <p:cNvPr id="60" name="TextBox 59"/>
+          <p:cNvPr id="65" name="TextBox 64"/>
           <p:cNvSpPr txBox="1"/>
           <p:nvPr/>
         </p:nvSpPr>
@@ -22583,7 +25318,7 @@
       </p:sp>
       <p:sp>
         <p:nvSpPr>
-          <p:cNvPr id="61" name="TextBox 60"/>
+          <p:cNvPr id="66" name="TextBox 65"/>
           <p:cNvSpPr txBox="1"/>
           <p:nvPr/>
         </p:nvSpPr>
@@ -22629,7 +25364,7 @@
       </p:sp>
       <p:sp>
         <p:nvSpPr>
-          <p:cNvPr id="62" name="Rounded Rectangle 61"/>
+          <p:cNvPr id="67" name="Rounded Rectangle 66"/>
           <p:cNvSpPr/>
           <p:nvPr/>
         </p:nvSpPr>
@@ -22677,7 +25412,7 @@
       </p:sp>
       <p:sp>
         <p:nvSpPr>
-          <p:cNvPr id="63" name="Rounded Rectangle 62"/>
+          <p:cNvPr id="68" name="Rounded Rectangle 67"/>
           <p:cNvSpPr/>
           <p:nvPr/>
         </p:nvSpPr>
@@ -22723,7 +25458,7 @@
       </p:sp>
       <p:sp>
         <p:nvSpPr>
-          <p:cNvPr id="64" name="TextBox 63"/>
+          <p:cNvPr id="69" name="TextBox 68"/>
           <p:cNvSpPr txBox="1"/>
           <p:nvPr/>
         </p:nvSpPr>
@@ -22755,14 +25490,14 @@
               </a:spcAft>
             </a:pPr>
             <a:r>
-              <a:rPr sz="1200" b="1" spc="100">
+              <a:rPr sz="750" b="1" spc="150">
                 <a:solidFill>
                   <a:srgbClr val="FFC9CE"/>
                 </a:solidFill>
                 <a:latin typeface="Consolas"/>
                 <a:ea typeface="Consolas"/>
               </a:rPr>
-              <a:t>06</a:t>
+              <a:t>SUPPORT</a:t>
             </a:r>
           </a:p>
           <a:p>
@@ -22808,14 +25543,14 @@
                 <a:latin typeface="Noto Sans JP"/>
                 <a:ea typeface="Noto Sans JP"/>
               </a:rPr>
-              <a:t>全体を支える基盤層</a:t>
-            </a:r>
-          </a:p>
-        </p:txBody>
-      </p:sp>
-      <p:sp>
-        <p:nvSpPr>
-          <p:cNvPr id="65" name="TextBox 64"/>
+              <a:t>全段階を下から支える層</a:t>
+            </a:r>
+          </a:p>
+        </p:txBody>
+      </p:sp>
+      <p:sp>
+        <p:nvSpPr>
+          <p:cNvPr id="70" name="TextBox 69"/>
           <p:cNvSpPr txBox="1"/>
           <p:nvPr/>
         </p:nvSpPr>
@@ -22884,7 +25619,7 @@
       </p:sp>
       <p:sp>
         <p:nvSpPr>
-          <p:cNvPr id="66" name="Rectangle 65"/>
+          <p:cNvPr id="71" name="Rectangle 70"/>
           <p:cNvSpPr/>
           <p:nvPr/>
         </p:nvSpPr>
@@ -22928,7 +25663,7 @@
       </p:sp>
       <p:sp>
         <p:nvSpPr>
-          <p:cNvPr id="67" name="TextBox 66"/>
+          <p:cNvPr id="72" name="TextBox 71"/>
           <p:cNvSpPr txBox="1"/>
           <p:nvPr/>
         </p:nvSpPr>
@@ -22997,7 +25732,7 @@
       </p:sp>
       <p:sp>
         <p:nvSpPr>
-          <p:cNvPr id="68" name="Rectangle 67"/>
+          <p:cNvPr id="73" name="Rectangle 72"/>
           <p:cNvSpPr/>
           <p:nvPr/>
         </p:nvSpPr>
@@ -23041,7 +25776,7 @@
       </p:sp>
       <p:sp>
         <p:nvSpPr>
-          <p:cNvPr id="69" name="TextBox 68"/>
+          <p:cNvPr id="74" name="TextBox 73"/>
           <p:cNvSpPr txBox="1"/>
           <p:nvPr/>
         </p:nvSpPr>
@@ -23110,7 +25845,7 @@
       </p:sp>
       <p:sp>
         <p:nvSpPr>
-          <p:cNvPr id="70" name="Rounded Rectangle 69"/>
+          <p:cNvPr id="75" name="Rounded Rectangle 74"/>
           <p:cNvSpPr/>
           <p:nvPr/>
         </p:nvSpPr>
@@ -23158,7 +25893,7 @@
       </p:sp>
       <p:sp>
         <p:nvSpPr>
-          <p:cNvPr id="71" name="TextBox 70"/>
+          <p:cNvPr id="76" name="TextBox 75"/>
           <p:cNvSpPr txBox="1"/>
           <p:nvPr/>
         </p:nvSpPr>

</xml_diff>